<commit_message>
Put the template inside the deck, and add three more layouts
The deck and the template were two files, which is one too many. The
company deck now carries the layouts in its own slide master: all 67
pages stay exactly as they are, and Home > New Slide offers the IAQ
layouts by name, so a page added a year from now comes out like the ones
around it. PowerPoint's own eleven starter layouts come out of that menu,
since picking one of those is how a deck goes off-brand.

Three layouts join the set. An agenda, for saying what a deck covers
before it covers it. A quote, for letting a client say it instead of us.
And a before and after, for the two states of a hall that the work is
the difference between.

Co-Authored-By: Claude Opus 5 <noreply@anthropic.com>
Claude-Session: https://claude.ai/code/session_01J2vuPhCFFpRn7AimXuA7Hp
</commit_message>
<xml_diff>
--- a/iaq-deck/template/IAQ-Master-Template-2026.pptx
+++ b/iaq-deck/template/IAQ-Master-Template-2026.pptx
@@ -23,45 +23,48 @@
     <p:sldId id="271" r:id="rId22"/>
     <p:sldId id="272" r:id="rId23"/>
     <p:sldId id="273" r:id="rId24"/>
+    <p:sldId id="274" r:id="rId25"/>
+    <p:sldId id="275" r:id="rId26"/>
+    <p:sldId id="276" r:id="rId27"/>
   </p:sldIdLst>
   <p:sldSz cx="12192000" cy="6858000" type="screen4x3"/>
   <p:notesSz cx="6858000" cy="9144000"/>
   <p:embeddedFontLst>
     <p:embeddedFont>
       <p:font typeface="League Spartan" pitchFamily="34" charset="0"/>
-      <p:regular r:id="rId25"/>
+      <p:regular r:id="rId28"/>
     </p:embeddedFont>
     <p:embeddedFont>
       <p:font typeface="League Spartan Medium" pitchFamily="34" charset="0"/>
-      <p:regular r:id="rId26"/>
+      <p:regular r:id="rId29"/>
     </p:embeddedFont>
     <p:embeddedFont>
       <p:font typeface="League Spartan SemiBold" pitchFamily="34" charset="0"/>
-      <p:regular r:id="rId27"/>
+      <p:regular r:id="rId30"/>
     </p:embeddedFont>
     <p:embeddedFont>
       <p:font typeface="Poppins Medium" pitchFamily="34" charset="0"/>
-      <p:regular r:id="rId28"/>
+      <p:regular r:id="rId31"/>
     </p:embeddedFont>
     <p:embeddedFont>
       <p:font typeface="Poppins SemiBold" pitchFamily="34" charset="0"/>
-      <p:regular r:id="rId29"/>
+      <p:regular r:id="rId32"/>
     </p:embeddedFont>
     <p:embeddedFont>
       <p:font typeface="Poppins" pitchFamily="34" charset="0"/>
-      <p:bold r:id="rId30"/>
+      <p:bold r:id="rId33"/>
     </p:embeddedFont>
     <p:embeddedFont>
       <p:font typeface="Urbanist" pitchFamily="34" charset="0"/>
-      <p:regular r:id="rId31"/>
+      <p:regular r:id="rId34"/>
     </p:embeddedFont>
     <p:embeddedFont>
       <p:font typeface="Urbanist Medium" pitchFamily="34" charset="0"/>
-      <p:regular r:id="rId32"/>
+      <p:regular r:id="rId35"/>
     </p:embeddedFont>
     <p:embeddedFont>
       <p:font typeface="Urbanist SemiBold" pitchFamily="34" charset="0"/>
-      <p:regular r:id="rId33"/>
+      <p:regular r:id="rId36"/>
     </p:embeddedFont>
   </p:embeddedFontLst>
   <p:defaultTextStyle>
@@ -5233,6 +5236,339 @@
         </p:nvSpPr>
         <p:spPr>
           <a:xfrm>
+            <a:off x="6178550" y="4079875"/>
+            <a:ext cx="292100" cy="76200"/>
+          </a:xfrm>
+          <a:prstGeom prst="rect">
+            <a:avLst/>
+          </a:prstGeom>
+          <a:noFill/>
+        </p:spPr>
+        <p:txBody>
+          <a:bodyPr wrap="none" lIns="0" rIns="0" tIns="0" bIns="0" anchor="ctr">
+            <a:noAutofit/>
+          </a:bodyPr>
+          <a:lstStyle/>
+          <a:p>
+            <a:pPr algn="l"/>
+            <a:r>
+              <a:rPr sz="650" b="0" i="0" spc="91">
+                <a:solidFill>
+                  <a:srgbClr val="EC2326"/>
+                </a:solidFill>
+                <a:latin typeface="League Spartan SemiBold"/>
+                <a:ea typeface="League Spartan SemiBold"/>
+                <a:cs typeface="League Spartan SemiBold"/>
+              </a:rPr>
+              <a:t>18</a:t>
+            </a:r>
+          </a:p>
+        </p:txBody>
+      </p:sp>
+      <p:sp>
+        <p:nvSpPr>
+          <p:cNvPr id="60" name="TextBox 59"/>
+          <p:cNvSpPr txBox="1"/>
+          <p:nvPr/>
+        </p:nvSpPr>
+        <p:spPr>
+          <a:xfrm>
+            <a:off x="6572250" y="4022725"/>
+            <a:ext cx="1587500" cy="152400"/>
+          </a:xfrm>
+          <a:prstGeom prst="rect">
+            <a:avLst/>
+          </a:prstGeom>
+          <a:noFill/>
+        </p:spPr>
+        <p:txBody>
+          <a:bodyPr wrap="none" lIns="0" rIns="0" tIns="0" bIns="0" anchor="ctr">
+            <a:noAutofit/>
+          </a:bodyPr>
+          <a:lstStyle/>
+          <a:p>
+            <a:pPr algn="l"/>
+            <a:r>
+              <a:rPr sz="850" b="0" i="0" spc="-17">
+                <a:solidFill>
+                  <a:srgbClr val="101A2B"/>
+                </a:solidFill>
+                <a:latin typeface="Poppins SemiBold"/>
+                <a:ea typeface="Poppins SemiBold"/>
+                <a:cs typeface="Poppins SemiBold"/>
+              </a:rPr>
+              <a:t>Agenda</a:t>
+            </a:r>
+          </a:p>
+        </p:txBody>
+      </p:sp>
+      <p:sp>
+        <p:nvSpPr>
+          <p:cNvPr id="61" name="TextBox 60"/>
+          <p:cNvSpPr txBox="1"/>
+          <p:nvPr/>
+        </p:nvSpPr>
+        <p:spPr>
+          <a:xfrm>
+            <a:off x="8261350" y="4048125"/>
+            <a:ext cx="3321050" cy="114300"/>
+          </a:xfrm>
+          <a:prstGeom prst="rect">
+            <a:avLst/>
+          </a:prstGeom>
+          <a:noFill/>
+        </p:spPr>
+        <p:txBody>
+          <a:bodyPr wrap="none" lIns="0" rIns="0" tIns="0" bIns="0" anchor="ctr">
+            <a:noAutofit/>
+          </a:bodyPr>
+          <a:lstStyle/>
+          <a:p>
+            <a:pPr algn="l"/>
+            <a:r>
+              <a:rPr sz="720" b="0" i="0">
+                <a:solidFill>
+                  <a:srgbClr val="64707A"/>
+                </a:solidFill>
+                <a:latin typeface="Urbanist"/>
+                <a:ea typeface="Urbanist"/>
+                <a:cs typeface="Urbanist"/>
+              </a:rPr>
+              <a:t>What the deck covers, before it covers it.</a:t>
+            </a:r>
+          </a:p>
+        </p:txBody>
+      </p:sp>
+      <p:sp>
+        <p:nvSpPr>
+          <p:cNvPr id="62" name="TextBox 61"/>
+          <p:cNvSpPr txBox="1"/>
+          <p:nvPr/>
+        </p:nvSpPr>
+        <p:spPr>
+          <a:xfrm>
+            <a:off x="609600" y="4362850"/>
+            <a:ext cx="292100" cy="76200"/>
+          </a:xfrm>
+          <a:prstGeom prst="rect">
+            <a:avLst/>
+          </a:prstGeom>
+          <a:noFill/>
+        </p:spPr>
+        <p:txBody>
+          <a:bodyPr wrap="none" lIns="0" rIns="0" tIns="0" bIns="0" anchor="ctr">
+            <a:noAutofit/>
+          </a:bodyPr>
+          <a:lstStyle/>
+          <a:p>
+            <a:pPr algn="l"/>
+            <a:r>
+              <a:rPr sz="650" b="0" i="0" spc="91">
+                <a:solidFill>
+                  <a:srgbClr val="EC2326"/>
+                </a:solidFill>
+                <a:latin typeface="League Spartan SemiBold"/>
+                <a:ea typeface="League Spartan SemiBold"/>
+                <a:cs typeface="League Spartan SemiBold"/>
+              </a:rPr>
+              <a:t>19</a:t>
+            </a:r>
+          </a:p>
+        </p:txBody>
+      </p:sp>
+      <p:sp>
+        <p:nvSpPr>
+          <p:cNvPr id="63" name="TextBox 62"/>
+          <p:cNvSpPr txBox="1"/>
+          <p:nvPr/>
+        </p:nvSpPr>
+        <p:spPr>
+          <a:xfrm>
+            <a:off x="1003300" y="4305700"/>
+            <a:ext cx="1587500" cy="152400"/>
+          </a:xfrm>
+          <a:prstGeom prst="rect">
+            <a:avLst/>
+          </a:prstGeom>
+          <a:noFill/>
+        </p:spPr>
+        <p:txBody>
+          <a:bodyPr wrap="none" lIns="0" rIns="0" tIns="0" bIns="0" anchor="ctr">
+            <a:noAutofit/>
+          </a:bodyPr>
+          <a:lstStyle/>
+          <a:p>
+            <a:pPr algn="l"/>
+            <a:r>
+              <a:rPr sz="850" b="0" i="0" spc="-17">
+                <a:solidFill>
+                  <a:srgbClr val="101A2B"/>
+                </a:solidFill>
+                <a:latin typeface="Poppins SemiBold"/>
+                <a:ea typeface="Poppins SemiBold"/>
+                <a:cs typeface="Poppins SemiBold"/>
+              </a:rPr>
+              <a:t>Quote</a:t>
+            </a:r>
+          </a:p>
+        </p:txBody>
+      </p:sp>
+      <p:sp>
+        <p:nvSpPr>
+          <p:cNvPr id="64" name="TextBox 63"/>
+          <p:cNvSpPr txBox="1"/>
+          <p:nvPr/>
+        </p:nvSpPr>
+        <p:spPr>
+          <a:xfrm>
+            <a:off x="2692400" y="4331100"/>
+            <a:ext cx="3321050" cy="114300"/>
+          </a:xfrm>
+          <a:prstGeom prst="rect">
+            <a:avLst/>
+          </a:prstGeom>
+          <a:noFill/>
+        </p:spPr>
+        <p:txBody>
+          <a:bodyPr wrap="none" lIns="0" rIns="0" tIns="0" bIns="0" anchor="ctr">
+            <a:noAutofit/>
+          </a:bodyPr>
+          <a:lstStyle/>
+          <a:p>
+            <a:pPr algn="l"/>
+            <a:r>
+              <a:rPr sz="720" b="0" i="0">
+                <a:solidFill>
+                  <a:srgbClr val="64707A"/>
+                </a:solidFill>
+                <a:latin typeface="Urbanist"/>
+                <a:ea typeface="Urbanist"/>
+                <a:cs typeface="Urbanist"/>
+              </a:rPr>
+              <a:t>Let a client, or the board, say it instead of you.</a:t>
+            </a:r>
+          </a:p>
+        </p:txBody>
+      </p:sp>
+      <p:sp>
+        <p:nvSpPr>
+          <p:cNvPr id="65" name="TextBox 64"/>
+          <p:cNvSpPr txBox="1"/>
+          <p:nvPr/>
+        </p:nvSpPr>
+        <p:spPr>
+          <a:xfrm>
+            <a:off x="6178550" y="4362850"/>
+            <a:ext cx="292100" cy="76200"/>
+          </a:xfrm>
+          <a:prstGeom prst="rect">
+            <a:avLst/>
+          </a:prstGeom>
+          <a:noFill/>
+        </p:spPr>
+        <p:txBody>
+          <a:bodyPr wrap="none" lIns="0" rIns="0" tIns="0" bIns="0" anchor="ctr">
+            <a:noAutofit/>
+          </a:bodyPr>
+          <a:lstStyle/>
+          <a:p>
+            <a:pPr algn="l"/>
+            <a:r>
+              <a:rPr sz="650" b="0" i="0" spc="91">
+                <a:solidFill>
+                  <a:srgbClr val="EC2326"/>
+                </a:solidFill>
+                <a:latin typeface="League Spartan SemiBold"/>
+                <a:ea typeface="League Spartan SemiBold"/>
+                <a:cs typeface="League Spartan SemiBold"/>
+              </a:rPr>
+              <a:t>20</a:t>
+            </a:r>
+          </a:p>
+        </p:txBody>
+      </p:sp>
+      <p:sp>
+        <p:nvSpPr>
+          <p:cNvPr id="66" name="TextBox 65"/>
+          <p:cNvSpPr txBox="1"/>
+          <p:nvPr/>
+        </p:nvSpPr>
+        <p:spPr>
+          <a:xfrm>
+            <a:off x="6572250" y="4305700"/>
+            <a:ext cx="1587500" cy="152400"/>
+          </a:xfrm>
+          <a:prstGeom prst="rect">
+            <a:avLst/>
+          </a:prstGeom>
+          <a:noFill/>
+        </p:spPr>
+        <p:txBody>
+          <a:bodyPr wrap="none" lIns="0" rIns="0" tIns="0" bIns="0" anchor="ctr">
+            <a:noAutofit/>
+          </a:bodyPr>
+          <a:lstStyle/>
+          <a:p>
+            <a:pPr algn="l"/>
+            <a:r>
+              <a:rPr sz="850" b="0" i="0" spc="-17">
+                <a:solidFill>
+                  <a:srgbClr val="101A2B"/>
+                </a:solidFill>
+                <a:latin typeface="Poppins SemiBold"/>
+                <a:ea typeface="Poppins SemiBold"/>
+                <a:cs typeface="Poppins SemiBold"/>
+              </a:rPr>
+              <a:t>Before and after</a:t>
+            </a:r>
+          </a:p>
+        </p:txBody>
+      </p:sp>
+      <p:sp>
+        <p:nvSpPr>
+          <p:cNvPr id="67" name="TextBox 66"/>
+          <p:cNvSpPr txBox="1"/>
+          <p:nvPr/>
+        </p:nvSpPr>
+        <p:spPr>
+          <a:xfrm>
+            <a:off x="8261350" y="4331100"/>
+            <a:ext cx="3321050" cy="114300"/>
+          </a:xfrm>
+          <a:prstGeom prst="rect">
+            <a:avLst/>
+          </a:prstGeom>
+          <a:noFill/>
+        </p:spPr>
+        <p:txBody>
+          <a:bodyPr wrap="none" lIns="0" rIns="0" tIns="0" bIns="0" anchor="ctr">
+            <a:noAutofit/>
+          </a:bodyPr>
+          <a:lstStyle/>
+          <a:p>
+            <a:pPr algn="l"/>
+            <a:r>
+              <a:rPr sz="720" b="0" i="0">
+                <a:solidFill>
+                  <a:srgbClr val="64707A"/>
+                </a:solidFill>
+                <a:latin typeface="Urbanist"/>
+                <a:ea typeface="Urbanist"/>
+                <a:cs typeface="Urbanist"/>
+              </a:rPr>
+              <a:t>Two states of the same thing, side by side.</a:t>
+            </a:r>
+          </a:p>
+        </p:txBody>
+      </p:sp>
+      <p:sp>
+        <p:nvSpPr>
+          <p:cNvPr id="68" name="TextBox 67"/>
+          <p:cNvSpPr txBox="1"/>
+          <p:nvPr/>
+        </p:nvSpPr>
+        <p:spPr>
+          <a:xfrm>
             <a:off x="609600" y="6445250"/>
             <a:ext cx="138112" cy="76200"/>
           </a:xfrm>
@@ -5264,7 +5600,7 @@
       </p:sp>
       <p:sp>
         <p:nvSpPr>
-          <p:cNvPr id="60" name="TextBox 59"/>
+          <p:cNvPr id="69" name="TextBox 68"/>
           <p:cNvSpPr txBox="1"/>
           <p:nvPr/>
         </p:nvSpPr>
@@ -17946,6 +18282,1560 @@
 </p:sld>
 </file>
 
+<file path=ppt/slides/slide19.xml><?xml version="1.0" encoding="utf-8"?>
+<p:sld xmlns:a="http://schemas.openxmlformats.org/drawingml/2006/main" xmlns:p="http://schemas.openxmlformats.org/presentationml/2006/main" xmlns:r="http://schemas.openxmlformats.org/officeDocument/2006/relationships">
+  <p:cSld>
+    <p:spTree>
+      <p:nvGrpSpPr>
+        <p:cNvPr id="1" name=""/>
+        <p:cNvGrpSpPr/>
+        <p:nvPr/>
+      </p:nvGrpSpPr>
+      <p:grpSpPr/>
+      <p:sp>
+        <p:nvSpPr>
+          <p:cNvPr id="2" name="Rectangle 1"/>
+          <p:cNvSpPr/>
+          <p:nvPr/>
+        </p:nvSpPr>
+        <p:spPr>
+          <a:xfrm>
+            <a:off x="0" y="0"/>
+            <a:ext cx="12192000" cy="6858000"/>
+          </a:xfrm>
+          <a:prstGeom prst="rect">
+            <a:avLst/>
+          </a:prstGeom>
+          <a:solidFill>
+            <a:srgbClr val="F6F7F9"/>
+          </a:solidFill>
+          <a:ln>
+            <a:noFill/>
+          </a:ln>
+          <a:effectLst/>
+        </p:spPr>
+        <p:txBody>
+          <a:bodyPr rtlCol="0" anchor="ctr"/>
+          <a:lstStyle/>
+          <a:p>
+            <a:pPr algn="ctr"/>
+          </a:p>
+        </p:txBody>
+      </p:sp>
+      <p:sp>
+        <p:nvSpPr>
+          <p:cNvPr id="3" name="Rectangle 2"/>
+          <p:cNvSpPr/>
+          <p:nvPr/>
+        </p:nvSpPr>
+        <p:spPr>
+          <a:xfrm>
+            <a:off x="609600" y="381000"/>
+            <a:ext cx="235350" cy="165100"/>
+          </a:xfrm>
+          <a:prstGeom prst="rect">
+            <a:avLst/>
+          </a:prstGeom>
+          <a:solidFill>
+            <a:srgbClr val="EC2326"/>
+          </a:solidFill>
+          <a:ln>
+            <a:noFill/>
+          </a:ln>
+          <a:effectLst/>
+        </p:spPr>
+        <p:txBody>
+          <a:bodyPr rtlCol="0" anchor="ctr"/>
+          <a:lstStyle/>
+          <a:p>
+            <a:pPr algn="ctr"/>
+          </a:p>
+        </p:txBody>
+      </p:sp>
+      <p:sp>
+        <p:nvSpPr>
+          <p:cNvPr id="4" name="TextBox 3"/>
+          <p:cNvSpPr txBox="1"/>
+          <p:nvPr/>
+        </p:nvSpPr>
+        <p:spPr>
+          <a:xfrm>
+            <a:off x="609600" y="425450"/>
+            <a:ext cx="235350" cy="82550"/>
+          </a:xfrm>
+          <a:prstGeom prst="rect">
+            <a:avLst/>
+          </a:prstGeom>
+          <a:noFill/>
+        </p:spPr>
+        <p:txBody>
+          <a:bodyPr wrap="none" lIns="69850" rIns="69850" tIns="0" bIns="0" anchor="ctr">
+            <a:noAutofit/>
+          </a:bodyPr>
+          <a:lstStyle/>
+          <a:p>
+            <a:pPr algn="l"/>
+            <a:r>
+              <a:rPr sz="700" b="0" i="0" spc="70">
+                <a:solidFill>
+                  <a:srgbClr val="FFFFFF"/>
+                </a:solidFill>
+                <a:latin typeface="League Spartan SemiBold"/>
+                <a:ea typeface="League Spartan SemiBold"/>
+                <a:cs typeface="League Spartan SemiBold"/>
+              </a:rPr>
+              <a:t>18</a:t>
+            </a:r>
+          </a:p>
+        </p:txBody>
+      </p:sp>
+      <p:sp>
+        <p:nvSpPr>
+          <p:cNvPr id="5" name="TextBox 4"/>
+          <p:cNvSpPr txBox="1"/>
+          <p:nvPr/>
+        </p:nvSpPr>
+        <p:spPr>
+          <a:xfrm>
+            <a:off x="946550" y="414338"/>
+            <a:ext cx="957859" cy="88900"/>
+          </a:xfrm>
+          <a:prstGeom prst="rect">
+            <a:avLst/>
+          </a:prstGeom>
+          <a:noFill/>
+        </p:spPr>
+        <p:txBody>
+          <a:bodyPr wrap="none" lIns="0" rIns="0" tIns="0" bIns="0" anchor="ctr">
+            <a:noAutofit/>
+          </a:bodyPr>
+          <a:lstStyle/>
+          <a:p>
+            <a:pPr algn="l"/>
+            <a:r>
+              <a:rPr sz="780" b="0" i="0" spc="186">
+                <a:solidFill>
+                  <a:srgbClr val="101A2B"/>
+                </a:solidFill>
+                <a:latin typeface="League Spartan SemiBold"/>
+                <a:ea typeface="League Spartan SemiBold"/>
+                <a:cs typeface="League Spartan SemiBold"/>
+              </a:rPr>
+              <a:t>SECTION NAME</a:t>
+            </a:r>
+          </a:p>
+        </p:txBody>
+      </p:sp>
+      <p:pic>
+        <p:nvPicPr>
+          <p:cNvPr id="6" name="Picture 5" descr="iaq-logo-tag.png"/>
+          <p:cNvPicPr>
+            <a:picLocks noChangeAspect="1"/>
+          </p:cNvPicPr>
+          <p:nvPr/>
+        </p:nvPicPr>
+        <p:blipFill>
+          <a:blip r:embed="rId2"/>
+          <a:stretch>
+            <a:fillRect/>
+          </a:stretch>
+        </p:blipFill>
+        <p:spPr>
+          <a:xfrm>
+            <a:off x="10947400" y="304800"/>
+            <a:ext cx="635000" cy="317500"/>
+          </a:xfrm>
+          <a:prstGeom prst="rect">
+            <a:avLst/>
+          </a:prstGeom>
+        </p:spPr>
+      </p:pic>
+      <p:sp>
+        <p:nvSpPr>
+          <p:cNvPr id="7" name="Rectangle 6"/>
+          <p:cNvSpPr/>
+          <p:nvPr/>
+        </p:nvSpPr>
+        <p:spPr>
+          <a:xfrm>
+            <a:off x="609600" y="1438872"/>
+            <a:ext cx="10972800" cy="6350"/>
+          </a:xfrm>
+          <a:prstGeom prst="rect">
+            <a:avLst/>
+          </a:prstGeom>
+          <a:solidFill>
+            <a:srgbClr val="D5DBE2"/>
+          </a:solidFill>
+          <a:ln>
+            <a:noFill/>
+          </a:ln>
+          <a:effectLst/>
+        </p:spPr>
+        <p:txBody>
+          <a:bodyPr rtlCol="0" anchor="ctr"/>
+          <a:lstStyle/>
+          <a:p>
+            <a:pPr algn="ctr"/>
+          </a:p>
+        </p:txBody>
+      </p:sp>
+      <p:sp>
+        <p:nvSpPr>
+          <p:cNvPr id="8" name="TextBox 7"/>
+          <p:cNvSpPr txBox="1"/>
+          <p:nvPr/>
+        </p:nvSpPr>
+        <p:spPr>
+          <a:xfrm>
+            <a:off x="609600" y="768350"/>
+            <a:ext cx="10972800" cy="304800"/>
+          </a:xfrm>
+          <a:prstGeom prst="rect">
+            <a:avLst/>
+          </a:prstGeom>
+          <a:noFill/>
+        </p:spPr>
+        <p:txBody>
+          <a:bodyPr wrap="none" lIns="0" rIns="0" tIns="0" bIns="0" anchor="ctr">
+            <a:noAutofit/>
+          </a:bodyPr>
+          <a:lstStyle/>
+          <a:p>
+            <a:pPr algn="l"/>
+            <a:r>
+              <a:rPr sz="1700" b="0" i="0" spc="-34">
+                <a:solidFill>
+                  <a:srgbClr val="64707A"/>
+                </a:solidFill>
+                <a:latin typeface="Poppins SemiBold"/>
+                <a:ea typeface="Poppins SemiBold"/>
+                <a:cs typeface="Poppins SemiBold"/>
+              </a:rPr>
+              <a:t>Page title</a:t>
+            </a:r>
+          </a:p>
+        </p:txBody>
+      </p:sp>
+      <p:sp>
+        <p:nvSpPr>
+          <p:cNvPr id="9" name="TextBox 8"/>
+          <p:cNvSpPr txBox="1"/>
+          <p:nvPr/>
+        </p:nvSpPr>
+        <p:spPr>
+          <a:xfrm>
+            <a:off x="609600" y="1118197"/>
+            <a:ext cx="6985000" cy="146050"/>
+          </a:xfrm>
+          <a:prstGeom prst="rect">
+            <a:avLst/>
+          </a:prstGeom>
+          <a:noFill/>
+        </p:spPr>
+        <p:txBody>
+          <a:bodyPr wrap="none" lIns="0" rIns="0" tIns="0" bIns="0" anchor="ctr">
+            <a:noAutofit/>
+          </a:bodyPr>
+          <a:lstStyle/>
+          <a:p>
+            <a:pPr algn="l"/>
+            <a:r>
+              <a:rPr sz="950" b="0" i="0">
+                <a:solidFill>
+                  <a:srgbClr val="64707A"/>
+                </a:solidFill>
+                <a:latin typeface="Urbanist"/>
+                <a:ea typeface="Urbanist"/>
+                <a:cs typeface="Urbanist"/>
+              </a:rPr>
+              <a:t>One line under it saying what the page is for.</a:t>
+            </a:r>
+          </a:p>
+        </p:txBody>
+      </p:sp>
+      <p:sp>
+        <p:nvSpPr>
+          <p:cNvPr id="10" name="TextBox 9"/>
+          <p:cNvSpPr txBox="1"/>
+          <p:nvPr/>
+        </p:nvSpPr>
+        <p:spPr>
+          <a:xfrm>
+            <a:off x="609600" y="1631950"/>
+            <a:ext cx="3547466" cy="463550"/>
+          </a:xfrm>
+          <a:prstGeom prst="rect">
+            <a:avLst/>
+          </a:prstGeom>
+          <a:noFill/>
+        </p:spPr>
+        <p:txBody>
+          <a:bodyPr wrap="none" lIns="0" rIns="0" tIns="0" bIns="0" anchor="ctr">
+            <a:noAutofit/>
+          </a:bodyPr>
+          <a:lstStyle/>
+          <a:p>
+            <a:pPr algn="l"/>
+            <a:r>
+              <a:rPr sz="2600" b="1" i="0" spc="-104">
+                <a:solidFill>
+                  <a:srgbClr val="64707A"/>
+                </a:solidFill>
+                <a:latin typeface="Poppins"/>
+                <a:ea typeface="Poppins"/>
+                <a:cs typeface="Poppins"/>
+              </a:rPr>
+              <a:t>01</a:t>
+            </a:r>
+          </a:p>
+        </p:txBody>
+      </p:sp>
+      <p:sp>
+        <p:nvSpPr>
+          <p:cNvPr id="11" name="Rectangle 10"/>
+          <p:cNvSpPr/>
+          <p:nvPr/>
+        </p:nvSpPr>
+        <p:spPr>
+          <a:xfrm>
+            <a:off x="609600" y="2397722"/>
+            <a:ext cx="3547466" cy="12700"/>
+          </a:xfrm>
+          <a:prstGeom prst="rect">
+            <a:avLst/>
+          </a:prstGeom>
+          <a:solidFill>
+            <a:srgbClr val="EC2326"/>
+          </a:solidFill>
+          <a:ln>
+            <a:noFill/>
+          </a:ln>
+          <a:effectLst/>
+        </p:spPr>
+        <p:txBody>
+          <a:bodyPr rtlCol="0" anchor="ctr"/>
+          <a:lstStyle/>
+          <a:p>
+            <a:pPr algn="ctr"/>
+          </a:p>
+        </p:txBody>
+      </p:sp>
+      <p:sp>
+        <p:nvSpPr>
+          <p:cNvPr id="12" name="TextBox 11"/>
+          <p:cNvSpPr txBox="1"/>
+          <p:nvPr/>
+        </p:nvSpPr>
+        <p:spPr>
+          <a:xfrm>
+            <a:off x="609600" y="2114550"/>
+            <a:ext cx="3547466" cy="209550"/>
+          </a:xfrm>
+          <a:prstGeom prst="rect">
+            <a:avLst/>
+          </a:prstGeom>
+          <a:noFill/>
+        </p:spPr>
+        <p:txBody>
+          <a:bodyPr wrap="none" lIns="0" rIns="0" tIns="0" bIns="0" anchor="ctr">
+            <a:noAutofit/>
+          </a:bodyPr>
+          <a:lstStyle/>
+          <a:p>
+            <a:pPr algn="l"/>
+            <a:r>
+              <a:rPr sz="1200" b="0" i="0" spc="-24">
+                <a:solidFill>
+                  <a:srgbClr val="64707A"/>
+                </a:solidFill>
+                <a:latin typeface="Poppins SemiBold"/>
+                <a:ea typeface="Poppins SemiBold"/>
+                <a:cs typeface="Poppins SemiBold"/>
+              </a:rPr>
+              <a:t>Part name</a:t>
+            </a:r>
+          </a:p>
+        </p:txBody>
+      </p:sp>
+      <p:sp>
+        <p:nvSpPr>
+          <p:cNvPr id="13" name="TextBox 12"/>
+          <p:cNvSpPr txBox="1"/>
+          <p:nvPr/>
+        </p:nvSpPr>
+        <p:spPr>
+          <a:xfrm>
+            <a:off x="609600" y="2562822"/>
+            <a:ext cx="279400" cy="76200"/>
+          </a:xfrm>
+          <a:prstGeom prst="rect">
+            <a:avLst/>
+          </a:prstGeom>
+          <a:noFill/>
+        </p:spPr>
+        <p:txBody>
+          <a:bodyPr wrap="none" lIns="0" rIns="0" tIns="0" bIns="0" anchor="ctr">
+            <a:noAutofit/>
+          </a:bodyPr>
+          <a:lstStyle/>
+          <a:p>
+            <a:pPr algn="l"/>
+            <a:r>
+              <a:rPr sz="620" b="0" i="0" spc="100">
+                <a:solidFill>
+                  <a:srgbClr val="64707A"/>
+                </a:solidFill>
+                <a:latin typeface="League Spartan SemiBold"/>
+                <a:ea typeface="League Spartan SemiBold"/>
+                <a:cs typeface="League Spartan SemiBold"/>
+              </a:rPr>
+              <a:t>01.1</a:t>
+            </a:r>
+          </a:p>
+        </p:txBody>
+      </p:sp>
+      <p:sp>
+        <p:nvSpPr>
+          <p:cNvPr id="14" name="TextBox 13"/>
+          <p:cNvSpPr txBox="1"/>
+          <p:nvPr/>
+        </p:nvSpPr>
+        <p:spPr>
+          <a:xfrm>
+            <a:off x="977900" y="2518372"/>
+            <a:ext cx="3179166" cy="127000"/>
+          </a:xfrm>
+          <a:prstGeom prst="rect">
+            <a:avLst/>
+          </a:prstGeom>
+          <a:noFill/>
+        </p:spPr>
+        <p:txBody>
+          <a:bodyPr wrap="none" lIns="0" rIns="0" tIns="0" bIns="0" anchor="ctr">
+            <a:noAutofit/>
+          </a:bodyPr>
+          <a:lstStyle/>
+          <a:p>
+            <a:pPr algn="l"/>
+            <a:r>
+              <a:rPr sz="850" b="0" i="0">
+                <a:solidFill>
+                  <a:srgbClr val="64707A"/>
+                </a:solidFill>
+                <a:latin typeface="Urbanist Medium"/>
+                <a:ea typeface="Urbanist Medium"/>
+                <a:cs typeface="Urbanist Medium"/>
+              </a:rPr>
+              <a:t>What this section answers</a:t>
+            </a:r>
+          </a:p>
+        </p:txBody>
+      </p:sp>
+      <p:sp>
+        <p:nvSpPr>
+          <p:cNvPr id="15" name="TextBox 14"/>
+          <p:cNvSpPr txBox="1"/>
+          <p:nvPr/>
+        </p:nvSpPr>
+        <p:spPr>
+          <a:xfrm>
+            <a:off x="609600" y="2779319"/>
+            <a:ext cx="279400" cy="76200"/>
+          </a:xfrm>
+          <a:prstGeom prst="rect">
+            <a:avLst/>
+          </a:prstGeom>
+          <a:noFill/>
+        </p:spPr>
+        <p:txBody>
+          <a:bodyPr wrap="none" lIns="0" rIns="0" tIns="0" bIns="0" anchor="ctr">
+            <a:noAutofit/>
+          </a:bodyPr>
+          <a:lstStyle/>
+          <a:p>
+            <a:pPr algn="l"/>
+            <a:r>
+              <a:rPr sz="620" b="0" i="0" spc="100">
+                <a:solidFill>
+                  <a:srgbClr val="64707A"/>
+                </a:solidFill>
+                <a:latin typeface="League Spartan SemiBold"/>
+                <a:ea typeface="League Spartan SemiBold"/>
+                <a:cs typeface="League Spartan SemiBold"/>
+              </a:rPr>
+              <a:t>01.2</a:t>
+            </a:r>
+          </a:p>
+        </p:txBody>
+      </p:sp>
+      <p:sp>
+        <p:nvSpPr>
+          <p:cNvPr id="16" name="TextBox 15"/>
+          <p:cNvSpPr txBox="1"/>
+          <p:nvPr/>
+        </p:nvSpPr>
+        <p:spPr>
+          <a:xfrm>
+            <a:off x="977900" y="2734869"/>
+            <a:ext cx="3179166" cy="127000"/>
+          </a:xfrm>
+          <a:prstGeom prst="rect">
+            <a:avLst/>
+          </a:prstGeom>
+          <a:noFill/>
+        </p:spPr>
+        <p:txBody>
+          <a:bodyPr wrap="none" lIns="0" rIns="0" tIns="0" bIns="0" anchor="ctr">
+            <a:noAutofit/>
+          </a:bodyPr>
+          <a:lstStyle/>
+          <a:p>
+            <a:pPr algn="l"/>
+            <a:r>
+              <a:rPr sz="850" b="0" i="0">
+                <a:solidFill>
+                  <a:srgbClr val="64707A"/>
+                </a:solidFill>
+                <a:latin typeface="Urbanist Medium"/>
+                <a:ea typeface="Urbanist Medium"/>
+                <a:cs typeface="Urbanist Medium"/>
+              </a:rPr>
+              <a:t>What this section answers</a:t>
+            </a:r>
+          </a:p>
+        </p:txBody>
+      </p:sp>
+      <p:sp>
+        <p:nvSpPr>
+          <p:cNvPr id="17" name="TextBox 16"/>
+          <p:cNvSpPr txBox="1"/>
+          <p:nvPr/>
+        </p:nvSpPr>
+        <p:spPr>
+          <a:xfrm>
+            <a:off x="609600" y="2995809"/>
+            <a:ext cx="279400" cy="76200"/>
+          </a:xfrm>
+          <a:prstGeom prst="rect">
+            <a:avLst/>
+          </a:prstGeom>
+          <a:noFill/>
+        </p:spPr>
+        <p:txBody>
+          <a:bodyPr wrap="none" lIns="0" rIns="0" tIns="0" bIns="0" anchor="ctr">
+            <a:noAutofit/>
+          </a:bodyPr>
+          <a:lstStyle/>
+          <a:p>
+            <a:pPr algn="l"/>
+            <a:r>
+              <a:rPr sz="620" b="0" i="0" spc="100">
+                <a:solidFill>
+                  <a:srgbClr val="64707A"/>
+                </a:solidFill>
+                <a:latin typeface="League Spartan SemiBold"/>
+                <a:ea typeface="League Spartan SemiBold"/>
+                <a:cs typeface="League Spartan SemiBold"/>
+              </a:rPr>
+              <a:t>01.3</a:t>
+            </a:r>
+          </a:p>
+        </p:txBody>
+      </p:sp>
+      <p:sp>
+        <p:nvSpPr>
+          <p:cNvPr id="18" name="TextBox 17"/>
+          <p:cNvSpPr txBox="1"/>
+          <p:nvPr/>
+        </p:nvSpPr>
+        <p:spPr>
+          <a:xfrm>
+            <a:off x="977900" y="2951359"/>
+            <a:ext cx="3179166" cy="127000"/>
+          </a:xfrm>
+          <a:prstGeom prst="rect">
+            <a:avLst/>
+          </a:prstGeom>
+          <a:noFill/>
+        </p:spPr>
+        <p:txBody>
+          <a:bodyPr wrap="none" lIns="0" rIns="0" tIns="0" bIns="0" anchor="ctr">
+            <a:noAutofit/>
+          </a:bodyPr>
+          <a:lstStyle/>
+          <a:p>
+            <a:pPr algn="l"/>
+            <a:r>
+              <a:rPr sz="850" b="0" i="0">
+                <a:solidFill>
+                  <a:srgbClr val="64707A"/>
+                </a:solidFill>
+                <a:latin typeface="Urbanist Medium"/>
+                <a:ea typeface="Urbanist Medium"/>
+                <a:cs typeface="Urbanist Medium"/>
+              </a:rPr>
+              <a:t>What this section answers</a:t>
+            </a:r>
+          </a:p>
+        </p:txBody>
+      </p:sp>
+      <p:sp>
+        <p:nvSpPr>
+          <p:cNvPr id="19" name="TextBox 18"/>
+          <p:cNvSpPr txBox="1"/>
+          <p:nvPr/>
+        </p:nvSpPr>
+        <p:spPr>
+          <a:xfrm>
+            <a:off x="609600" y="3212306"/>
+            <a:ext cx="279400" cy="76200"/>
+          </a:xfrm>
+          <a:prstGeom prst="rect">
+            <a:avLst/>
+          </a:prstGeom>
+          <a:noFill/>
+        </p:spPr>
+        <p:txBody>
+          <a:bodyPr wrap="none" lIns="0" rIns="0" tIns="0" bIns="0" anchor="ctr">
+            <a:noAutofit/>
+          </a:bodyPr>
+          <a:lstStyle/>
+          <a:p>
+            <a:pPr algn="l"/>
+            <a:r>
+              <a:rPr sz="620" b="0" i="0" spc="100">
+                <a:solidFill>
+                  <a:srgbClr val="64707A"/>
+                </a:solidFill>
+                <a:latin typeface="League Spartan SemiBold"/>
+                <a:ea typeface="League Spartan SemiBold"/>
+                <a:cs typeface="League Spartan SemiBold"/>
+              </a:rPr>
+              <a:t>01.4</a:t>
+            </a:r>
+          </a:p>
+        </p:txBody>
+      </p:sp>
+      <p:sp>
+        <p:nvSpPr>
+          <p:cNvPr id="20" name="TextBox 19"/>
+          <p:cNvSpPr txBox="1"/>
+          <p:nvPr/>
+        </p:nvSpPr>
+        <p:spPr>
+          <a:xfrm>
+            <a:off x="977900" y="3167856"/>
+            <a:ext cx="3179166" cy="127000"/>
+          </a:xfrm>
+          <a:prstGeom prst="rect">
+            <a:avLst/>
+          </a:prstGeom>
+          <a:noFill/>
+        </p:spPr>
+        <p:txBody>
+          <a:bodyPr wrap="none" lIns="0" rIns="0" tIns="0" bIns="0" anchor="ctr">
+            <a:noAutofit/>
+          </a:bodyPr>
+          <a:lstStyle/>
+          <a:p>
+            <a:pPr algn="l"/>
+            <a:r>
+              <a:rPr sz="850" b="0" i="0">
+                <a:solidFill>
+                  <a:srgbClr val="64707A"/>
+                </a:solidFill>
+                <a:latin typeface="Urbanist Medium"/>
+                <a:ea typeface="Urbanist Medium"/>
+                <a:cs typeface="Urbanist Medium"/>
+              </a:rPr>
+              <a:t>What this section answers</a:t>
+            </a:r>
+          </a:p>
+        </p:txBody>
+      </p:sp>
+      <p:sp>
+        <p:nvSpPr>
+          <p:cNvPr id="21" name="TextBox 20"/>
+          <p:cNvSpPr txBox="1"/>
+          <p:nvPr/>
+        </p:nvSpPr>
+        <p:spPr>
+          <a:xfrm>
+            <a:off x="4322166" y="1631950"/>
+            <a:ext cx="3547567" cy="463550"/>
+          </a:xfrm>
+          <a:prstGeom prst="rect">
+            <a:avLst/>
+          </a:prstGeom>
+          <a:noFill/>
+        </p:spPr>
+        <p:txBody>
+          <a:bodyPr wrap="none" lIns="0" rIns="0" tIns="0" bIns="0" anchor="ctr">
+            <a:noAutofit/>
+          </a:bodyPr>
+          <a:lstStyle/>
+          <a:p>
+            <a:pPr algn="l"/>
+            <a:r>
+              <a:rPr sz="2600" b="1" i="0" spc="-104">
+                <a:solidFill>
+                  <a:srgbClr val="64707A"/>
+                </a:solidFill>
+                <a:latin typeface="Poppins"/>
+                <a:ea typeface="Poppins"/>
+                <a:cs typeface="Poppins"/>
+              </a:rPr>
+              <a:t>02</a:t>
+            </a:r>
+          </a:p>
+        </p:txBody>
+      </p:sp>
+      <p:sp>
+        <p:nvSpPr>
+          <p:cNvPr id="22" name="Rectangle 21"/>
+          <p:cNvSpPr/>
+          <p:nvPr/>
+        </p:nvSpPr>
+        <p:spPr>
+          <a:xfrm>
+            <a:off x="4322166" y="2397722"/>
+            <a:ext cx="3547567" cy="12700"/>
+          </a:xfrm>
+          <a:prstGeom prst="rect">
+            <a:avLst/>
+          </a:prstGeom>
+          <a:solidFill>
+            <a:srgbClr val="EC2326"/>
+          </a:solidFill>
+          <a:ln>
+            <a:noFill/>
+          </a:ln>
+          <a:effectLst/>
+        </p:spPr>
+        <p:txBody>
+          <a:bodyPr rtlCol="0" anchor="ctr"/>
+          <a:lstStyle/>
+          <a:p>
+            <a:pPr algn="ctr"/>
+          </a:p>
+        </p:txBody>
+      </p:sp>
+      <p:sp>
+        <p:nvSpPr>
+          <p:cNvPr id="23" name="TextBox 22"/>
+          <p:cNvSpPr txBox="1"/>
+          <p:nvPr/>
+        </p:nvSpPr>
+        <p:spPr>
+          <a:xfrm>
+            <a:off x="4322166" y="2114550"/>
+            <a:ext cx="3547567" cy="209550"/>
+          </a:xfrm>
+          <a:prstGeom prst="rect">
+            <a:avLst/>
+          </a:prstGeom>
+          <a:noFill/>
+        </p:spPr>
+        <p:txBody>
+          <a:bodyPr wrap="none" lIns="0" rIns="0" tIns="0" bIns="0" anchor="ctr">
+            <a:noAutofit/>
+          </a:bodyPr>
+          <a:lstStyle/>
+          <a:p>
+            <a:pPr algn="l"/>
+            <a:r>
+              <a:rPr sz="1200" b="0" i="0" spc="-24">
+                <a:solidFill>
+                  <a:srgbClr val="64707A"/>
+                </a:solidFill>
+                <a:latin typeface="Poppins SemiBold"/>
+                <a:ea typeface="Poppins SemiBold"/>
+                <a:cs typeface="Poppins SemiBold"/>
+              </a:rPr>
+              <a:t>Part name</a:t>
+            </a:r>
+          </a:p>
+        </p:txBody>
+      </p:sp>
+      <p:sp>
+        <p:nvSpPr>
+          <p:cNvPr id="24" name="TextBox 23"/>
+          <p:cNvSpPr txBox="1"/>
+          <p:nvPr/>
+        </p:nvSpPr>
+        <p:spPr>
+          <a:xfrm>
+            <a:off x="4322166" y="2562822"/>
+            <a:ext cx="279400" cy="76200"/>
+          </a:xfrm>
+          <a:prstGeom prst="rect">
+            <a:avLst/>
+          </a:prstGeom>
+          <a:noFill/>
+        </p:spPr>
+        <p:txBody>
+          <a:bodyPr wrap="none" lIns="0" rIns="0" tIns="0" bIns="0" anchor="ctr">
+            <a:noAutofit/>
+          </a:bodyPr>
+          <a:lstStyle/>
+          <a:p>
+            <a:pPr algn="l"/>
+            <a:r>
+              <a:rPr sz="620" b="0" i="0" spc="100">
+                <a:solidFill>
+                  <a:srgbClr val="64707A"/>
+                </a:solidFill>
+                <a:latin typeface="League Spartan SemiBold"/>
+                <a:ea typeface="League Spartan SemiBold"/>
+                <a:cs typeface="League Spartan SemiBold"/>
+              </a:rPr>
+              <a:t>02.1</a:t>
+            </a:r>
+          </a:p>
+        </p:txBody>
+      </p:sp>
+      <p:sp>
+        <p:nvSpPr>
+          <p:cNvPr id="25" name="TextBox 24"/>
+          <p:cNvSpPr txBox="1"/>
+          <p:nvPr/>
+        </p:nvSpPr>
+        <p:spPr>
+          <a:xfrm>
+            <a:off x="4690466" y="2518372"/>
+            <a:ext cx="3179267" cy="127000"/>
+          </a:xfrm>
+          <a:prstGeom prst="rect">
+            <a:avLst/>
+          </a:prstGeom>
+          <a:noFill/>
+        </p:spPr>
+        <p:txBody>
+          <a:bodyPr wrap="none" lIns="0" rIns="0" tIns="0" bIns="0" anchor="ctr">
+            <a:noAutofit/>
+          </a:bodyPr>
+          <a:lstStyle/>
+          <a:p>
+            <a:pPr algn="l"/>
+            <a:r>
+              <a:rPr sz="850" b="0" i="0">
+                <a:solidFill>
+                  <a:srgbClr val="64707A"/>
+                </a:solidFill>
+                <a:latin typeface="Urbanist Medium"/>
+                <a:ea typeface="Urbanist Medium"/>
+                <a:cs typeface="Urbanist Medium"/>
+              </a:rPr>
+              <a:t>What this section answers</a:t>
+            </a:r>
+          </a:p>
+        </p:txBody>
+      </p:sp>
+      <p:sp>
+        <p:nvSpPr>
+          <p:cNvPr id="26" name="TextBox 25"/>
+          <p:cNvSpPr txBox="1"/>
+          <p:nvPr/>
+        </p:nvSpPr>
+        <p:spPr>
+          <a:xfrm>
+            <a:off x="4322166" y="2779319"/>
+            <a:ext cx="279400" cy="76200"/>
+          </a:xfrm>
+          <a:prstGeom prst="rect">
+            <a:avLst/>
+          </a:prstGeom>
+          <a:noFill/>
+        </p:spPr>
+        <p:txBody>
+          <a:bodyPr wrap="none" lIns="0" rIns="0" tIns="0" bIns="0" anchor="ctr">
+            <a:noAutofit/>
+          </a:bodyPr>
+          <a:lstStyle/>
+          <a:p>
+            <a:pPr algn="l"/>
+            <a:r>
+              <a:rPr sz="620" b="0" i="0" spc="100">
+                <a:solidFill>
+                  <a:srgbClr val="64707A"/>
+                </a:solidFill>
+                <a:latin typeface="League Spartan SemiBold"/>
+                <a:ea typeface="League Spartan SemiBold"/>
+                <a:cs typeface="League Spartan SemiBold"/>
+              </a:rPr>
+              <a:t>02.2</a:t>
+            </a:r>
+          </a:p>
+        </p:txBody>
+      </p:sp>
+      <p:sp>
+        <p:nvSpPr>
+          <p:cNvPr id="27" name="TextBox 26"/>
+          <p:cNvSpPr txBox="1"/>
+          <p:nvPr/>
+        </p:nvSpPr>
+        <p:spPr>
+          <a:xfrm>
+            <a:off x="4690466" y="2734869"/>
+            <a:ext cx="3179267" cy="127000"/>
+          </a:xfrm>
+          <a:prstGeom prst="rect">
+            <a:avLst/>
+          </a:prstGeom>
+          <a:noFill/>
+        </p:spPr>
+        <p:txBody>
+          <a:bodyPr wrap="none" lIns="0" rIns="0" tIns="0" bIns="0" anchor="ctr">
+            <a:noAutofit/>
+          </a:bodyPr>
+          <a:lstStyle/>
+          <a:p>
+            <a:pPr algn="l"/>
+            <a:r>
+              <a:rPr sz="850" b="0" i="0">
+                <a:solidFill>
+                  <a:srgbClr val="64707A"/>
+                </a:solidFill>
+                <a:latin typeface="Urbanist Medium"/>
+                <a:ea typeface="Urbanist Medium"/>
+                <a:cs typeface="Urbanist Medium"/>
+              </a:rPr>
+              <a:t>What this section answers</a:t>
+            </a:r>
+          </a:p>
+        </p:txBody>
+      </p:sp>
+      <p:sp>
+        <p:nvSpPr>
+          <p:cNvPr id="28" name="TextBox 27"/>
+          <p:cNvSpPr txBox="1"/>
+          <p:nvPr/>
+        </p:nvSpPr>
+        <p:spPr>
+          <a:xfrm>
+            <a:off x="4322166" y="2995809"/>
+            <a:ext cx="279400" cy="76200"/>
+          </a:xfrm>
+          <a:prstGeom prst="rect">
+            <a:avLst/>
+          </a:prstGeom>
+          <a:noFill/>
+        </p:spPr>
+        <p:txBody>
+          <a:bodyPr wrap="none" lIns="0" rIns="0" tIns="0" bIns="0" anchor="ctr">
+            <a:noAutofit/>
+          </a:bodyPr>
+          <a:lstStyle/>
+          <a:p>
+            <a:pPr algn="l"/>
+            <a:r>
+              <a:rPr sz="620" b="0" i="0" spc="100">
+                <a:solidFill>
+                  <a:srgbClr val="64707A"/>
+                </a:solidFill>
+                <a:latin typeface="League Spartan SemiBold"/>
+                <a:ea typeface="League Spartan SemiBold"/>
+                <a:cs typeface="League Spartan SemiBold"/>
+              </a:rPr>
+              <a:t>02.3</a:t>
+            </a:r>
+          </a:p>
+        </p:txBody>
+      </p:sp>
+      <p:sp>
+        <p:nvSpPr>
+          <p:cNvPr id="29" name="TextBox 28"/>
+          <p:cNvSpPr txBox="1"/>
+          <p:nvPr/>
+        </p:nvSpPr>
+        <p:spPr>
+          <a:xfrm>
+            <a:off x="4690466" y="2951359"/>
+            <a:ext cx="3179267" cy="127000"/>
+          </a:xfrm>
+          <a:prstGeom prst="rect">
+            <a:avLst/>
+          </a:prstGeom>
+          <a:noFill/>
+        </p:spPr>
+        <p:txBody>
+          <a:bodyPr wrap="none" lIns="0" rIns="0" tIns="0" bIns="0" anchor="ctr">
+            <a:noAutofit/>
+          </a:bodyPr>
+          <a:lstStyle/>
+          <a:p>
+            <a:pPr algn="l"/>
+            <a:r>
+              <a:rPr sz="850" b="0" i="0">
+                <a:solidFill>
+                  <a:srgbClr val="64707A"/>
+                </a:solidFill>
+                <a:latin typeface="Urbanist Medium"/>
+                <a:ea typeface="Urbanist Medium"/>
+                <a:cs typeface="Urbanist Medium"/>
+              </a:rPr>
+              <a:t>What this section answers</a:t>
+            </a:r>
+          </a:p>
+        </p:txBody>
+      </p:sp>
+      <p:sp>
+        <p:nvSpPr>
+          <p:cNvPr id="30" name="TextBox 29"/>
+          <p:cNvSpPr txBox="1"/>
+          <p:nvPr/>
+        </p:nvSpPr>
+        <p:spPr>
+          <a:xfrm>
+            <a:off x="4322166" y="3212306"/>
+            <a:ext cx="279400" cy="76200"/>
+          </a:xfrm>
+          <a:prstGeom prst="rect">
+            <a:avLst/>
+          </a:prstGeom>
+          <a:noFill/>
+        </p:spPr>
+        <p:txBody>
+          <a:bodyPr wrap="none" lIns="0" rIns="0" tIns="0" bIns="0" anchor="ctr">
+            <a:noAutofit/>
+          </a:bodyPr>
+          <a:lstStyle/>
+          <a:p>
+            <a:pPr algn="l"/>
+            <a:r>
+              <a:rPr sz="620" b="0" i="0" spc="100">
+                <a:solidFill>
+                  <a:srgbClr val="64707A"/>
+                </a:solidFill>
+                <a:latin typeface="League Spartan SemiBold"/>
+                <a:ea typeface="League Spartan SemiBold"/>
+                <a:cs typeface="League Spartan SemiBold"/>
+              </a:rPr>
+              <a:t>02.4</a:t>
+            </a:r>
+          </a:p>
+        </p:txBody>
+      </p:sp>
+      <p:sp>
+        <p:nvSpPr>
+          <p:cNvPr id="31" name="TextBox 30"/>
+          <p:cNvSpPr txBox="1"/>
+          <p:nvPr/>
+        </p:nvSpPr>
+        <p:spPr>
+          <a:xfrm>
+            <a:off x="4690466" y="3167856"/>
+            <a:ext cx="3179267" cy="127000"/>
+          </a:xfrm>
+          <a:prstGeom prst="rect">
+            <a:avLst/>
+          </a:prstGeom>
+          <a:noFill/>
+        </p:spPr>
+        <p:txBody>
+          <a:bodyPr wrap="none" lIns="0" rIns="0" tIns="0" bIns="0" anchor="ctr">
+            <a:noAutofit/>
+          </a:bodyPr>
+          <a:lstStyle/>
+          <a:p>
+            <a:pPr algn="l"/>
+            <a:r>
+              <a:rPr sz="850" b="0" i="0">
+                <a:solidFill>
+                  <a:srgbClr val="64707A"/>
+                </a:solidFill>
+                <a:latin typeface="Urbanist Medium"/>
+                <a:ea typeface="Urbanist Medium"/>
+                <a:cs typeface="Urbanist Medium"/>
+              </a:rPr>
+              <a:t>What this section answers</a:t>
+            </a:r>
+          </a:p>
+        </p:txBody>
+      </p:sp>
+      <p:sp>
+        <p:nvSpPr>
+          <p:cNvPr id="32" name="TextBox 31"/>
+          <p:cNvSpPr txBox="1"/>
+          <p:nvPr/>
+        </p:nvSpPr>
+        <p:spPr>
+          <a:xfrm>
+            <a:off x="8034833" y="1631950"/>
+            <a:ext cx="3547567" cy="463550"/>
+          </a:xfrm>
+          <a:prstGeom prst="rect">
+            <a:avLst/>
+          </a:prstGeom>
+          <a:noFill/>
+        </p:spPr>
+        <p:txBody>
+          <a:bodyPr wrap="none" lIns="0" rIns="0" tIns="0" bIns="0" anchor="ctr">
+            <a:noAutofit/>
+          </a:bodyPr>
+          <a:lstStyle/>
+          <a:p>
+            <a:pPr algn="l"/>
+            <a:r>
+              <a:rPr sz="2600" b="1" i="0" spc="-104">
+                <a:solidFill>
+                  <a:srgbClr val="64707A"/>
+                </a:solidFill>
+                <a:latin typeface="Poppins"/>
+                <a:ea typeface="Poppins"/>
+                <a:cs typeface="Poppins"/>
+              </a:rPr>
+              <a:t>03</a:t>
+            </a:r>
+          </a:p>
+        </p:txBody>
+      </p:sp>
+      <p:sp>
+        <p:nvSpPr>
+          <p:cNvPr id="33" name="Rectangle 32"/>
+          <p:cNvSpPr/>
+          <p:nvPr/>
+        </p:nvSpPr>
+        <p:spPr>
+          <a:xfrm>
+            <a:off x="8034833" y="2397722"/>
+            <a:ext cx="3547567" cy="12700"/>
+          </a:xfrm>
+          <a:prstGeom prst="rect">
+            <a:avLst/>
+          </a:prstGeom>
+          <a:solidFill>
+            <a:srgbClr val="EC2326"/>
+          </a:solidFill>
+          <a:ln>
+            <a:noFill/>
+          </a:ln>
+          <a:effectLst/>
+        </p:spPr>
+        <p:txBody>
+          <a:bodyPr rtlCol="0" anchor="ctr"/>
+          <a:lstStyle/>
+          <a:p>
+            <a:pPr algn="ctr"/>
+          </a:p>
+        </p:txBody>
+      </p:sp>
+      <p:sp>
+        <p:nvSpPr>
+          <p:cNvPr id="34" name="TextBox 33"/>
+          <p:cNvSpPr txBox="1"/>
+          <p:nvPr/>
+        </p:nvSpPr>
+        <p:spPr>
+          <a:xfrm>
+            <a:off x="8034833" y="2114550"/>
+            <a:ext cx="3547567" cy="209550"/>
+          </a:xfrm>
+          <a:prstGeom prst="rect">
+            <a:avLst/>
+          </a:prstGeom>
+          <a:noFill/>
+        </p:spPr>
+        <p:txBody>
+          <a:bodyPr wrap="none" lIns="0" rIns="0" tIns="0" bIns="0" anchor="ctr">
+            <a:noAutofit/>
+          </a:bodyPr>
+          <a:lstStyle/>
+          <a:p>
+            <a:pPr algn="l"/>
+            <a:r>
+              <a:rPr sz="1200" b="0" i="0" spc="-24">
+                <a:solidFill>
+                  <a:srgbClr val="64707A"/>
+                </a:solidFill>
+                <a:latin typeface="Poppins SemiBold"/>
+                <a:ea typeface="Poppins SemiBold"/>
+                <a:cs typeface="Poppins SemiBold"/>
+              </a:rPr>
+              <a:t>Part name</a:t>
+            </a:r>
+          </a:p>
+        </p:txBody>
+      </p:sp>
+      <p:sp>
+        <p:nvSpPr>
+          <p:cNvPr id="35" name="TextBox 34"/>
+          <p:cNvSpPr txBox="1"/>
+          <p:nvPr/>
+        </p:nvSpPr>
+        <p:spPr>
+          <a:xfrm>
+            <a:off x="8034833" y="2562822"/>
+            <a:ext cx="279400" cy="76200"/>
+          </a:xfrm>
+          <a:prstGeom prst="rect">
+            <a:avLst/>
+          </a:prstGeom>
+          <a:noFill/>
+        </p:spPr>
+        <p:txBody>
+          <a:bodyPr wrap="none" lIns="0" rIns="0" tIns="0" bIns="0" anchor="ctr">
+            <a:noAutofit/>
+          </a:bodyPr>
+          <a:lstStyle/>
+          <a:p>
+            <a:pPr algn="l"/>
+            <a:r>
+              <a:rPr sz="620" b="0" i="0" spc="100">
+                <a:solidFill>
+                  <a:srgbClr val="64707A"/>
+                </a:solidFill>
+                <a:latin typeface="League Spartan SemiBold"/>
+                <a:ea typeface="League Spartan SemiBold"/>
+                <a:cs typeface="League Spartan SemiBold"/>
+              </a:rPr>
+              <a:t>03.1</a:t>
+            </a:r>
+          </a:p>
+        </p:txBody>
+      </p:sp>
+      <p:sp>
+        <p:nvSpPr>
+          <p:cNvPr id="36" name="TextBox 35"/>
+          <p:cNvSpPr txBox="1"/>
+          <p:nvPr/>
+        </p:nvSpPr>
+        <p:spPr>
+          <a:xfrm>
+            <a:off x="8403133" y="2518372"/>
+            <a:ext cx="3179267" cy="127000"/>
+          </a:xfrm>
+          <a:prstGeom prst="rect">
+            <a:avLst/>
+          </a:prstGeom>
+          <a:noFill/>
+        </p:spPr>
+        <p:txBody>
+          <a:bodyPr wrap="none" lIns="0" rIns="0" tIns="0" bIns="0" anchor="ctr">
+            <a:noAutofit/>
+          </a:bodyPr>
+          <a:lstStyle/>
+          <a:p>
+            <a:pPr algn="l"/>
+            <a:r>
+              <a:rPr sz="850" b="0" i="0">
+                <a:solidFill>
+                  <a:srgbClr val="64707A"/>
+                </a:solidFill>
+                <a:latin typeface="Urbanist Medium"/>
+                <a:ea typeface="Urbanist Medium"/>
+                <a:cs typeface="Urbanist Medium"/>
+              </a:rPr>
+              <a:t>What this section answers</a:t>
+            </a:r>
+          </a:p>
+        </p:txBody>
+      </p:sp>
+      <p:sp>
+        <p:nvSpPr>
+          <p:cNvPr id="37" name="TextBox 36"/>
+          <p:cNvSpPr txBox="1"/>
+          <p:nvPr/>
+        </p:nvSpPr>
+        <p:spPr>
+          <a:xfrm>
+            <a:off x="8034833" y="2779319"/>
+            <a:ext cx="279400" cy="76200"/>
+          </a:xfrm>
+          <a:prstGeom prst="rect">
+            <a:avLst/>
+          </a:prstGeom>
+          <a:noFill/>
+        </p:spPr>
+        <p:txBody>
+          <a:bodyPr wrap="none" lIns="0" rIns="0" tIns="0" bIns="0" anchor="ctr">
+            <a:noAutofit/>
+          </a:bodyPr>
+          <a:lstStyle/>
+          <a:p>
+            <a:pPr algn="l"/>
+            <a:r>
+              <a:rPr sz="620" b="0" i="0" spc="100">
+                <a:solidFill>
+                  <a:srgbClr val="64707A"/>
+                </a:solidFill>
+                <a:latin typeface="League Spartan SemiBold"/>
+                <a:ea typeface="League Spartan SemiBold"/>
+                <a:cs typeface="League Spartan SemiBold"/>
+              </a:rPr>
+              <a:t>03.2</a:t>
+            </a:r>
+          </a:p>
+        </p:txBody>
+      </p:sp>
+      <p:sp>
+        <p:nvSpPr>
+          <p:cNvPr id="38" name="TextBox 37"/>
+          <p:cNvSpPr txBox="1"/>
+          <p:nvPr/>
+        </p:nvSpPr>
+        <p:spPr>
+          <a:xfrm>
+            <a:off x="8403133" y="2734869"/>
+            <a:ext cx="3179267" cy="127000"/>
+          </a:xfrm>
+          <a:prstGeom prst="rect">
+            <a:avLst/>
+          </a:prstGeom>
+          <a:noFill/>
+        </p:spPr>
+        <p:txBody>
+          <a:bodyPr wrap="none" lIns="0" rIns="0" tIns="0" bIns="0" anchor="ctr">
+            <a:noAutofit/>
+          </a:bodyPr>
+          <a:lstStyle/>
+          <a:p>
+            <a:pPr algn="l"/>
+            <a:r>
+              <a:rPr sz="850" b="0" i="0">
+                <a:solidFill>
+                  <a:srgbClr val="64707A"/>
+                </a:solidFill>
+                <a:latin typeface="Urbanist Medium"/>
+                <a:ea typeface="Urbanist Medium"/>
+                <a:cs typeface="Urbanist Medium"/>
+              </a:rPr>
+              <a:t>What this section answers</a:t>
+            </a:r>
+          </a:p>
+        </p:txBody>
+      </p:sp>
+      <p:sp>
+        <p:nvSpPr>
+          <p:cNvPr id="39" name="TextBox 38"/>
+          <p:cNvSpPr txBox="1"/>
+          <p:nvPr/>
+        </p:nvSpPr>
+        <p:spPr>
+          <a:xfrm>
+            <a:off x="8034833" y="2995809"/>
+            <a:ext cx="279400" cy="76200"/>
+          </a:xfrm>
+          <a:prstGeom prst="rect">
+            <a:avLst/>
+          </a:prstGeom>
+          <a:noFill/>
+        </p:spPr>
+        <p:txBody>
+          <a:bodyPr wrap="none" lIns="0" rIns="0" tIns="0" bIns="0" anchor="ctr">
+            <a:noAutofit/>
+          </a:bodyPr>
+          <a:lstStyle/>
+          <a:p>
+            <a:pPr algn="l"/>
+            <a:r>
+              <a:rPr sz="620" b="0" i="0" spc="100">
+                <a:solidFill>
+                  <a:srgbClr val="64707A"/>
+                </a:solidFill>
+                <a:latin typeface="League Spartan SemiBold"/>
+                <a:ea typeface="League Spartan SemiBold"/>
+                <a:cs typeface="League Spartan SemiBold"/>
+              </a:rPr>
+              <a:t>03.3</a:t>
+            </a:r>
+          </a:p>
+        </p:txBody>
+      </p:sp>
+      <p:sp>
+        <p:nvSpPr>
+          <p:cNvPr id="40" name="TextBox 39"/>
+          <p:cNvSpPr txBox="1"/>
+          <p:nvPr/>
+        </p:nvSpPr>
+        <p:spPr>
+          <a:xfrm>
+            <a:off x="8403133" y="2951359"/>
+            <a:ext cx="3179267" cy="127000"/>
+          </a:xfrm>
+          <a:prstGeom prst="rect">
+            <a:avLst/>
+          </a:prstGeom>
+          <a:noFill/>
+        </p:spPr>
+        <p:txBody>
+          <a:bodyPr wrap="none" lIns="0" rIns="0" tIns="0" bIns="0" anchor="ctr">
+            <a:noAutofit/>
+          </a:bodyPr>
+          <a:lstStyle/>
+          <a:p>
+            <a:pPr algn="l"/>
+            <a:r>
+              <a:rPr sz="850" b="0" i="0">
+                <a:solidFill>
+                  <a:srgbClr val="64707A"/>
+                </a:solidFill>
+                <a:latin typeface="Urbanist Medium"/>
+                <a:ea typeface="Urbanist Medium"/>
+                <a:cs typeface="Urbanist Medium"/>
+              </a:rPr>
+              <a:t>What this section answers</a:t>
+            </a:r>
+          </a:p>
+        </p:txBody>
+      </p:sp>
+      <p:sp>
+        <p:nvSpPr>
+          <p:cNvPr id="41" name="TextBox 40"/>
+          <p:cNvSpPr txBox="1"/>
+          <p:nvPr/>
+        </p:nvSpPr>
+        <p:spPr>
+          <a:xfrm>
+            <a:off x="8034833" y="3212306"/>
+            <a:ext cx="279400" cy="76200"/>
+          </a:xfrm>
+          <a:prstGeom prst="rect">
+            <a:avLst/>
+          </a:prstGeom>
+          <a:noFill/>
+        </p:spPr>
+        <p:txBody>
+          <a:bodyPr wrap="none" lIns="0" rIns="0" tIns="0" bIns="0" anchor="ctr">
+            <a:noAutofit/>
+          </a:bodyPr>
+          <a:lstStyle/>
+          <a:p>
+            <a:pPr algn="l"/>
+            <a:r>
+              <a:rPr sz="620" b="0" i="0" spc="100">
+                <a:solidFill>
+                  <a:srgbClr val="64707A"/>
+                </a:solidFill>
+                <a:latin typeface="League Spartan SemiBold"/>
+                <a:ea typeface="League Spartan SemiBold"/>
+                <a:cs typeface="League Spartan SemiBold"/>
+              </a:rPr>
+              <a:t>03.4</a:t>
+            </a:r>
+          </a:p>
+        </p:txBody>
+      </p:sp>
+      <p:sp>
+        <p:nvSpPr>
+          <p:cNvPr id="42" name="TextBox 41"/>
+          <p:cNvSpPr txBox="1"/>
+          <p:nvPr/>
+        </p:nvSpPr>
+        <p:spPr>
+          <a:xfrm>
+            <a:off x="8403133" y="3167856"/>
+            <a:ext cx="3179267" cy="127000"/>
+          </a:xfrm>
+          <a:prstGeom prst="rect">
+            <a:avLst/>
+          </a:prstGeom>
+          <a:noFill/>
+        </p:spPr>
+        <p:txBody>
+          <a:bodyPr wrap="none" lIns="0" rIns="0" tIns="0" bIns="0" anchor="ctr">
+            <a:noAutofit/>
+          </a:bodyPr>
+          <a:lstStyle/>
+          <a:p>
+            <a:pPr algn="l"/>
+            <a:r>
+              <a:rPr sz="850" b="0" i="0">
+                <a:solidFill>
+                  <a:srgbClr val="64707A"/>
+                </a:solidFill>
+                <a:latin typeface="Urbanist Medium"/>
+                <a:ea typeface="Urbanist Medium"/>
+                <a:cs typeface="Urbanist Medium"/>
+              </a:rPr>
+              <a:t>What this section answers</a:t>
+            </a:r>
+          </a:p>
+        </p:txBody>
+      </p:sp>
+      <p:sp>
+        <p:nvSpPr>
+          <p:cNvPr id="43" name="TextBox 42"/>
+          <p:cNvSpPr txBox="1"/>
+          <p:nvPr/>
+        </p:nvSpPr>
+        <p:spPr>
+          <a:xfrm>
+            <a:off x="609600" y="6445250"/>
+            <a:ext cx="111919" cy="76200"/>
+          </a:xfrm>
+          <a:prstGeom prst="rect">
+            <a:avLst/>
+          </a:prstGeom>
+          <a:noFill/>
+        </p:spPr>
+        <p:txBody>
+          <a:bodyPr wrap="none" lIns="0" rIns="0" tIns="0" bIns="0" anchor="ctr">
+            <a:noAutofit/>
+          </a:bodyPr>
+          <a:lstStyle/>
+          <a:p>
+            <a:pPr algn="l"/>
+            <a:r>
+              <a:rPr sz="680" b="0" i="0" spc="148">
+                <a:solidFill>
+                  <a:srgbClr val="64707A"/>
+                </a:solidFill>
+                <a:latin typeface="League Spartan Medium"/>
+                <a:ea typeface="League Spartan Medium"/>
+                <a:cs typeface="League Spartan Medium"/>
+              </a:rPr>
+              <a:t>18</a:t>
+            </a:r>
+          </a:p>
+        </p:txBody>
+      </p:sp>
+      <p:sp>
+        <p:nvSpPr>
+          <p:cNvPr id="44" name="TextBox 43"/>
+          <p:cNvSpPr txBox="1"/>
+          <p:nvPr/>
+        </p:nvSpPr>
+        <p:spPr>
+          <a:xfrm>
+            <a:off x="11154969" y="6429375"/>
+            <a:ext cx="427438" cy="76200"/>
+          </a:xfrm>
+          <a:prstGeom prst="rect">
+            <a:avLst/>
+          </a:prstGeom>
+          <a:noFill/>
+        </p:spPr>
+        <p:txBody>
+          <a:bodyPr wrap="none" lIns="0" rIns="0" tIns="0" bIns="0" anchor="ctr">
+            <a:noAutofit/>
+          </a:bodyPr>
+          <a:lstStyle/>
+          <a:p>
+            <a:pPr algn="l"/>
+            <a:r>
+              <a:rPr sz="680" b="0" i="0" spc="148">
+                <a:solidFill>
+                  <a:srgbClr val="64707A"/>
+                </a:solidFill>
+                <a:latin typeface="League Spartan"/>
+                <a:ea typeface="League Spartan"/>
+                <a:cs typeface="League Spartan"/>
+              </a:rPr>
+              <a:t>AGENDA</a:t>
+            </a:r>
+          </a:p>
+        </p:txBody>
+      </p:sp>
+    </p:spTree>
+  </p:cSld>
+  <p:clrMapOvr>
+    <a:masterClrMapping/>
+  </p:clrMapOvr>
+</p:sld>
+</file>
+
 <file path=ppt/slides/slide2.xml><?xml version="1.0" encoding="utf-8"?>
 <p:sld xmlns:a="http://schemas.openxmlformats.org/drawingml/2006/main" xmlns:p="http://schemas.openxmlformats.org/presentationml/2006/main" xmlns:r="http://schemas.openxmlformats.org/officeDocument/2006/relationships">
   <p:cSld>
@@ -18456,6 +20346,1343 @@
                 <a:cs typeface="League Spartan"/>
               </a:rPr>
               <a:t>TITLE</a:t>
+            </a:r>
+          </a:p>
+        </p:txBody>
+      </p:sp>
+    </p:spTree>
+  </p:cSld>
+  <p:clrMapOvr>
+    <a:masterClrMapping/>
+  </p:clrMapOvr>
+</p:sld>
+</file>
+
+<file path=ppt/slides/slide20.xml><?xml version="1.0" encoding="utf-8"?>
+<p:sld xmlns:a="http://schemas.openxmlformats.org/drawingml/2006/main" xmlns:p="http://schemas.openxmlformats.org/presentationml/2006/main" xmlns:r="http://schemas.openxmlformats.org/officeDocument/2006/relationships">
+  <p:cSld>
+    <p:spTree>
+      <p:nvGrpSpPr>
+        <p:cNvPr id="1" name=""/>
+        <p:cNvGrpSpPr/>
+        <p:nvPr/>
+      </p:nvGrpSpPr>
+      <p:grpSpPr/>
+      <p:sp>
+        <p:nvSpPr>
+          <p:cNvPr id="2" name="Rectangle 1"/>
+          <p:cNvSpPr/>
+          <p:nvPr/>
+        </p:nvSpPr>
+        <p:spPr>
+          <a:xfrm>
+            <a:off x="0" y="0"/>
+            <a:ext cx="12192000" cy="6858000"/>
+          </a:xfrm>
+          <a:prstGeom prst="rect">
+            <a:avLst/>
+          </a:prstGeom>
+          <a:solidFill>
+            <a:srgbClr val="F6F7F9"/>
+          </a:solidFill>
+          <a:ln>
+            <a:noFill/>
+          </a:ln>
+          <a:effectLst/>
+        </p:spPr>
+        <p:txBody>
+          <a:bodyPr rtlCol="0" anchor="ctr"/>
+          <a:lstStyle/>
+          <a:p>
+            <a:pPr algn="ctr"/>
+          </a:p>
+        </p:txBody>
+      </p:sp>
+      <p:sp>
+        <p:nvSpPr>
+          <p:cNvPr id="3" name="Rectangle 2"/>
+          <p:cNvSpPr/>
+          <p:nvPr/>
+        </p:nvSpPr>
+        <p:spPr>
+          <a:xfrm>
+            <a:off x="609600" y="381000"/>
+            <a:ext cx="235445" cy="165100"/>
+          </a:xfrm>
+          <a:prstGeom prst="rect">
+            <a:avLst/>
+          </a:prstGeom>
+          <a:solidFill>
+            <a:srgbClr val="EC2326"/>
+          </a:solidFill>
+          <a:ln>
+            <a:noFill/>
+          </a:ln>
+          <a:effectLst/>
+        </p:spPr>
+        <p:txBody>
+          <a:bodyPr rtlCol="0" anchor="ctr"/>
+          <a:lstStyle/>
+          <a:p>
+            <a:pPr algn="ctr"/>
+          </a:p>
+        </p:txBody>
+      </p:sp>
+      <p:sp>
+        <p:nvSpPr>
+          <p:cNvPr id="4" name="TextBox 3"/>
+          <p:cNvSpPr txBox="1"/>
+          <p:nvPr/>
+        </p:nvSpPr>
+        <p:spPr>
+          <a:xfrm>
+            <a:off x="609600" y="425450"/>
+            <a:ext cx="235445" cy="82550"/>
+          </a:xfrm>
+          <a:prstGeom prst="rect">
+            <a:avLst/>
+          </a:prstGeom>
+          <a:noFill/>
+        </p:spPr>
+        <p:txBody>
+          <a:bodyPr wrap="none" lIns="69850" rIns="69850" tIns="0" bIns="0" anchor="ctr">
+            <a:noAutofit/>
+          </a:bodyPr>
+          <a:lstStyle/>
+          <a:p>
+            <a:pPr algn="l"/>
+            <a:r>
+              <a:rPr sz="700" b="0" i="0" spc="70">
+                <a:solidFill>
+                  <a:srgbClr val="FFFFFF"/>
+                </a:solidFill>
+                <a:latin typeface="League Spartan SemiBold"/>
+                <a:ea typeface="League Spartan SemiBold"/>
+                <a:cs typeface="League Spartan SemiBold"/>
+              </a:rPr>
+              <a:t>19</a:t>
+            </a:r>
+          </a:p>
+        </p:txBody>
+      </p:sp>
+      <p:sp>
+        <p:nvSpPr>
+          <p:cNvPr id="5" name="TextBox 4"/>
+          <p:cNvSpPr txBox="1"/>
+          <p:nvPr/>
+        </p:nvSpPr>
+        <p:spPr>
+          <a:xfrm>
+            <a:off x="946645" y="414338"/>
+            <a:ext cx="957859" cy="88900"/>
+          </a:xfrm>
+          <a:prstGeom prst="rect">
+            <a:avLst/>
+          </a:prstGeom>
+          <a:noFill/>
+        </p:spPr>
+        <p:txBody>
+          <a:bodyPr wrap="none" lIns="0" rIns="0" tIns="0" bIns="0" anchor="ctr">
+            <a:noAutofit/>
+          </a:bodyPr>
+          <a:lstStyle/>
+          <a:p>
+            <a:pPr algn="l"/>
+            <a:r>
+              <a:rPr sz="780" b="0" i="0" spc="186">
+                <a:solidFill>
+                  <a:srgbClr val="101A2B"/>
+                </a:solidFill>
+                <a:latin typeface="League Spartan SemiBold"/>
+                <a:ea typeface="League Spartan SemiBold"/>
+                <a:cs typeface="League Spartan SemiBold"/>
+              </a:rPr>
+              <a:t>SECTION NAME</a:t>
+            </a:r>
+          </a:p>
+        </p:txBody>
+      </p:sp>
+      <p:pic>
+        <p:nvPicPr>
+          <p:cNvPr id="6" name="Picture 5" descr="iaq-logo-tag.png"/>
+          <p:cNvPicPr>
+            <a:picLocks noChangeAspect="1"/>
+          </p:cNvPicPr>
+          <p:nvPr/>
+        </p:nvPicPr>
+        <p:blipFill>
+          <a:blip r:embed="rId2"/>
+          <a:stretch>
+            <a:fillRect/>
+          </a:stretch>
+        </p:blipFill>
+        <p:spPr>
+          <a:xfrm>
+            <a:off x="10947400" y="304800"/>
+            <a:ext cx="635000" cy="317500"/>
+          </a:xfrm>
+          <a:prstGeom prst="rect">
+            <a:avLst/>
+          </a:prstGeom>
+        </p:spPr>
+      </p:pic>
+      <p:sp>
+        <p:nvSpPr>
+          <p:cNvPr id="7" name="Rectangle 6"/>
+          <p:cNvSpPr/>
+          <p:nvPr/>
+        </p:nvSpPr>
+        <p:spPr>
+          <a:xfrm>
+            <a:off x="609600" y="1438872"/>
+            <a:ext cx="10972800" cy="6350"/>
+          </a:xfrm>
+          <a:prstGeom prst="rect">
+            <a:avLst/>
+          </a:prstGeom>
+          <a:solidFill>
+            <a:srgbClr val="D5DBE2"/>
+          </a:solidFill>
+          <a:ln>
+            <a:noFill/>
+          </a:ln>
+          <a:effectLst/>
+        </p:spPr>
+        <p:txBody>
+          <a:bodyPr rtlCol="0" anchor="ctr"/>
+          <a:lstStyle/>
+          <a:p>
+            <a:pPr algn="ctr"/>
+          </a:p>
+        </p:txBody>
+      </p:sp>
+      <p:sp>
+        <p:nvSpPr>
+          <p:cNvPr id="8" name="TextBox 7"/>
+          <p:cNvSpPr txBox="1"/>
+          <p:nvPr/>
+        </p:nvSpPr>
+        <p:spPr>
+          <a:xfrm>
+            <a:off x="609600" y="768350"/>
+            <a:ext cx="10972800" cy="304800"/>
+          </a:xfrm>
+          <a:prstGeom prst="rect">
+            <a:avLst/>
+          </a:prstGeom>
+          <a:noFill/>
+        </p:spPr>
+        <p:txBody>
+          <a:bodyPr wrap="none" lIns="0" rIns="0" tIns="0" bIns="0" anchor="ctr">
+            <a:noAutofit/>
+          </a:bodyPr>
+          <a:lstStyle/>
+          <a:p>
+            <a:pPr algn="l"/>
+            <a:r>
+              <a:rPr sz="1700" b="0" i="0" spc="-34">
+                <a:solidFill>
+                  <a:srgbClr val="64707A"/>
+                </a:solidFill>
+                <a:latin typeface="Poppins SemiBold"/>
+                <a:ea typeface="Poppins SemiBold"/>
+                <a:cs typeface="Poppins SemiBold"/>
+              </a:rPr>
+              <a:t>Page title</a:t>
+            </a:r>
+          </a:p>
+        </p:txBody>
+      </p:sp>
+      <p:sp>
+        <p:nvSpPr>
+          <p:cNvPr id="9" name="TextBox 8"/>
+          <p:cNvSpPr txBox="1"/>
+          <p:nvPr/>
+        </p:nvSpPr>
+        <p:spPr>
+          <a:xfrm>
+            <a:off x="609600" y="1118197"/>
+            <a:ext cx="6985000" cy="146050"/>
+          </a:xfrm>
+          <a:prstGeom prst="rect">
+            <a:avLst/>
+          </a:prstGeom>
+          <a:noFill/>
+        </p:spPr>
+        <p:txBody>
+          <a:bodyPr wrap="none" lIns="0" rIns="0" tIns="0" bIns="0" anchor="ctr">
+            <a:noAutofit/>
+          </a:bodyPr>
+          <a:lstStyle/>
+          <a:p>
+            <a:pPr algn="l"/>
+            <a:r>
+              <a:rPr sz="950" b="0" i="0">
+                <a:solidFill>
+                  <a:srgbClr val="64707A"/>
+                </a:solidFill>
+                <a:latin typeface="Urbanist"/>
+                <a:ea typeface="Urbanist"/>
+                <a:cs typeface="Urbanist"/>
+              </a:rPr>
+              <a:t>One line under it saying what the page is for.</a:t>
+            </a:r>
+          </a:p>
+        </p:txBody>
+      </p:sp>
+      <p:sp>
+        <p:nvSpPr>
+          <p:cNvPr id="10" name="TextBox 9"/>
+          <p:cNvSpPr txBox="1"/>
+          <p:nvPr/>
+        </p:nvSpPr>
+        <p:spPr>
+          <a:xfrm>
+            <a:off x="609600" y="2946400"/>
+            <a:ext cx="7112000" cy="806450"/>
+          </a:xfrm>
+          <a:prstGeom prst="rect">
+            <a:avLst/>
+          </a:prstGeom>
+          <a:noFill/>
+        </p:spPr>
+        <p:txBody>
+          <a:bodyPr wrap="none" lIns="0" rIns="0" tIns="0" bIns="0" anchor="ctr">
+            <a:noAutofit/>
+          </a:bodyPr>
+          <a:lstStyle/>
+          <a:p>
+            <a:pPr algn="l"/>
+            <a:r>
+              <a:rPr sz="4500" b="1" i="0">
+                <a:solidFill>
+                  <a:srgbClr val="64707A"/>
+                </a:solidFill>
+                <a:latin typeface="Poppins"/>
+                <a:ea typeface="Poppins"/>
+                <a:cs typeface="Poppins"/>
+              </a:rPr>
+              <a:t>“</a:t>
+            </a:r>
+          </a:p>
+        </p:txBody>
+      </p:sp>
+      <p:sp>
+        <p:nvSpPr>
+          <p:cNvPr id="11" name="TextBox 10"/>
+          <p:cNvSpPr txBox="1"/>
+          <p:nvPr/>
+        </p:nvSpPr>
+        <p:spPr>
+          <a:xfrm>
+            <a:off x="609600" y="3683000"/>
+            <a:ext cx="7112000" cy="638175"/>
+          </a:xfrm>
+          <a:prstGeom prst="rect">
+            <a:avLst/>
+          </a:prstGeom>
+          <a:noFill/>
+        </p:spPr>
+        <p:txBody>
+          <a:bodyPr wrap="square" lIns="0" rIns="0" tIns="0" bIns="0" anchor="ctr">
+            <a:noAutofit/>
+          </a:bodyPr>
+          <a:lstStyle/>
+          <a:p>
+            <a:pPr algn="l">
+              <a:lnSpc>
+                <a:spcPts val="2375"/>
+              </a:lnSpc>
+            </a:pPr>
+            <a:r>
+              <a:rPr sz="1900" b="0" i="0" spc="-38">
+                <a:solidFill>
+                  <a:srgbClr val="64707A"/>
+                </a:solidFill>
+                <a:latin typeface="Poppins SemiBold"/>
+                <a:ea typeface="Poppins SemiBold"/>
+                <a:cs typeface="Poppins SemiBold"/>
+              </a:rPr>
+              <a:t>The quotation, two lines at most. Cut it back until only the part worth repeating is left.</a:t>
+            </a:r>
+          </a:p>
+        </p:txBody>
+      </p:sp>
+      <p:sp>
+        <p:nvSpPr>
+          <p:cNvPr id="12" name="Rectangle 11"/>
+          <p:cNvSpPr/>
+          <p:nvPr/>
+        </p:nvSpPr>
+        <p:spPr>
+          <a:xfrm>
+            <a:off x="609600" y="4483100"/>
+            <a:ext cx="7112000" cy="12700"/>
+          </a:xfrm>
+          <a:prstGeom prst="rect">
+            <a:avLst/>
+          </a:prstGeom>
+          <a:solidFill>
+            <a:srgbClr val="EC2326"/>
+          </a:solidFill>
+          <a:ln>
+            <a:noFill/>
+          </a:ln>
+          <a:effectLst/>
+        </p:spPr>
+        <p:txBody>
+          <a:bodyPr rtlCol="0" anchor="ctr"/>
+          <a:lstStyle/>
+          <a:p>
+            <a:pPr algn="ctr"/>
+          </a:p>
+        </p:txBody>
+      </p:sp>
+      <p:sp>
+        <p:nvSpPr>
+          <p:cNvPr id="13" name="TextBox 12"/>
+          <p:cNvSpPr txBox="1"/>
+          <p:nvPr/>
+        </p:nvSpPr>
+        <p:spPr>
+          <a:xfrm>
+            <a:off x="609600" y="4622800"/>
+            <a:ext cx="7112000" cy="139700"/>
+          </a:xfrm>
+          <a:prstGeom prst="rect">
+            <a:avLst/>
+          </a:prstGeom>
+          <a:noFill/>
+        </p:spPr>
+        <p:txBody>
+          <a:bodyPr wrap="none" lIns="0" rIns="0" tIns="0" bIns="0" anchor="ctr">
+            <a:noAutofit/>
+          </a:bodyPr>
+          <a:lstStyle/>
+          <a:p>
+            <a:pPr algn="l"/>
+            <a:r>
+              <a:rPr sz="900" b="0" i="0">
+                <a:solidFill>
+                  <a:srgbClr val="64707A"/>
+                </a:solidFill>
+                <a:latin typeface="Urbanist SemiBold"/>
+                <a:ea typeface="Urbanist SemiBold"/>
+                <a:cs typeface="Urbanist SemiBold"/>
+              </a:rPr>
+              <a:t>Name of the person</a:t>
+            </a:r>
+          </a:p>
+        </p:txBody>
+      </p:sp>
+      <p:sp>
+        <p:nvSpPr>
+          <p:cNvPr id="14" name="TextBox 13"/>
+          <p:cNvSpPr txBox="1"/>
+          <p:nvPr/>
+        </p:nvSpPr>
+        <p:spPr>
+          <a:xfrm>
+            <a:off x="609600" y="4794250"/>
+            <a:ext cx="7112000" cy="76200"/>
+          </a:xfrm>
+          <a:prstGeom prst="rect">
+            <a:avLst/>
+          </a:prstGeom>
+          <a:noFill/>
+        </p:spPr>
+        <p:txBody>
+          <a:bodyPr wrap="none" lIns="0" rIns="0" tIns="0" bIns="0" anchor="ctr">
+            <a:noAutofit/>
+          </a:bodyPr>
+          <a:lstStyle/>
+          <a:p>
+            <a:pPr algn="l"/>
+            <a:r>
+              <a:rPr sz="620" b="0" i="0" spc="125">
+                <a:solidFill>
+                  <a:srgbClr val="64707A"/>
+                </a:solidFill>
+                <a:latin typeface="League Spartan SemiBold"/>
+                <a:ea typeface="League Spartan SemiBold"/>
+                <a:cs typeface="League Spartan SemiBold"/>
+              </a:rPr>
+              <a:t>ROLE · ORGANISATION</a:t>
+            </a:r>
+          </a:p>
+        </p:txBody>
+      </p:sp>
+      <p:sp>
+        <p:nvSpPr>
+          <p:cNvPr id="15" name="Rectangle 14"/>
+          <p:cNvSpPr/>
+          <p:nvPr/>
+        </p:nvSpPr>
+        <p:spPr>
+          <a:xfrm>
+            <a:off x="8026400" y="1701800"/>
+            <a:ext cx="3556000" cy="4648200"/>
+          </a:xfrm>
+          <a:prstGeom prst="rect">
+            <a:avLst/>
+          </a:prstGeom>
+          <a:solidFill>
+            <a:srgbClr val="FFFFFF"/>
+          </a:solidFill>
+          <a:ln>
+            <a:noFill/>
+          </a:ln>
+          <a:effectLst/>
+        </p:spPr>
+        <p:txBody>
+          <a:bodyPr rtlCol="0" anchor="ctr"/>
+          <a:lstStyle/>
+          <a:p>
+            <a:pPr algn="ctr"/>
+          </a:p>
+        </p:txBody>
+      </p:sp>
+      <p:pic>
+        <p:nvPicPr>
+          <p:cNvPr id="16" name="Picture 15" descr="refs-crew.jpg"/>
+          <p:cNvPicPr>
+            <a:picLocks noChangeAspect="1"/>
+          </p:cNvPicPr>
+          <p:nvPr/>
+        </p:nvPicPr>
+        <p:blipFill>
+          <a:blip r:embed="rId3"/>
+          <a:srcRect l="5883" r="5883"/>
+          <a:stretch>
+            <a:fillRect/>
+          </a:stretch>
+        </p:blipFill>
+        <p:spPr>
+          <a:xfrm>
+            <a:off x="8026400" y="1701800"/>
+            <a:ext cx="3556000" cy="4648200"/>
+          </a:xfrm>
+          <a:prstGeom prst="rect">
+            <a:avLst/>
+          </a:prstGeom>
+        </p:spPr>
+      </p:pic>
+      <p:sp>
+        <p:nvSpPr>
+          <p:cNvPr id="17" name="TextBox 16"/>
+          <p:cNvSpPr txBox="1"/>
+          <p:nvPr/>
+        </p:nvSpPr>
+        <p:spPr>
+          <a:xfrm>
+            <a:off x="609600" y="6445250"/>
+            <a:ext cx="112020" cy="76200"/>
+          </a:xfrm>
+          <a:prstGeom prst="rect">
+            <a:avLst/>
+          </a:prstGeom>
+          <a:noFill/>
+        </p:spPr>
+        <p:txBody>
+          <a:bodyPr wrap="none" lIns="0" rIns="0" tIns="0" bIns="0" anchor="ctr">
+            <a:noAutofit/>
+          </a:bodyPr>
+          <a:lstStyle/>
+          <a:p>
+            <a:pPr algn="l"/>
+            <a:r>
+              <a:rPr sz="680" b="0" i="0" spc="148">
+                <a:solidFill>
+                  <a:srgbClr val="64707A"/>
+                </a:solidFill>
+                <a:latin typeface="League Spartan Medium"/>
+                <a:ea typeface="League Spartan Medium"/>
+                <a:cs typeface="League Spartan Medium"/>
+              </a:rPr>
+              <a:t>19</a:t>
+            </a:r>
+          </a:p>
+        </p:txBody>
+      </p:sp>
+      <p:sp>
+        <p:nvSpPr>
+          <p:cNvPr id="18" name="TextBox 17"/>
+          <p:cNvSpPr txBox="1"/>
+          <p:nvPr/>
+        </p:nvSpPr>
+        <p:spPr>
+          <a:xfrm>
+            <a:off x="11226902" y="6429375"/>
+            <a:ext cx="355498" cy="76200"/>
+          </a:xfrm>
+          <a:prstGeom prst="rect">
+            <a:avLst/>
+          </a:prstGeom>
+          <a:noFill/>
+        </p:spPr>
+        <p:txBody>
+          <a:bodyPr wrap="none" lIns="0" rIns="0" tIns="0" bIns="0" anchor="ctr">
+            <a:noAutofit/>
+          </a:bodyPr>
+          <a:lstStyle/>
+          <a:p>
+            <a:pPr algn="l"/>
+            <a:r>
+              <a:rPr sz="680" b="0" i="0" spc="148">
+                <a:solidFill>
+                  <a:srgbClr val="64707A"/>
+                </a:solidFill>
+                <a:latin typeface="League Spartan"/>
+                <a:ea typeface="League Spartan"/>
+                <a:cs typeface="League Spartan"/>
+              </a:rPr>
+              <a:t>QUOTE</a:t>
+            </a:r>
+          </a:p>
+        </p:txBody>
+      </p:sp>
+    </p:spTree>
+  </p:cSld>
+  <p:clrMapOvr>
+    <a:masterClrMapping/>
+  </p:clrMapOvr>
+</p:sld>
+</file>
+
+<file path=ppt/slides/slide21.xml><?xml version="1.0" encoding="utf-8"?>
+<p:sld xmlns:a="http://schemas.openxmlformats.org/drawingml/2006/main" xmlns:p="http://schemas.openxmlformats.org/presentationml/2006/main" xmlns:r="http://schemas.openxmlformats.org/officeDocument/2006/relationships">
+  <p:cSld>
+    <p:spTree>
+      <p:nvGrpSpPr>
+        <p:cNvPr id="1" name=""/>
+        <p:cNvGrpSpPr/>
+        <p:nvPr/>
+      </p:nvGrpSpPr>
+      <p:grpSpPr/>
+      <p:sp>
+        <p:nvSpPr>
+          <p:cNvPr id="2" name="Rectangle 1"/>
+          <p:cNvSpPr/>
+          <p:nvPr/>
+        </p:nvSpPr>
+        <p:spPr>
+          <a:xfrm>
+            <a:off x="0" y="0"/>
+            <a:ext cx="12192000" cy="6858000"/>
+          </a:xfrm>
+          <a:prstGeom prst="rect">
+            <a:avLst/>
+          </a:prstGeom>
+          <a:solidFill>
+            <a:srgbClr val="F6F7F9"/>
+          </a:solidFill>
+          <a:ln>
+            <a:noFill/>
+          </a:ln>
+          <a:effectLst/>
+        </p:spPr>
+        <p:txBody>
+          <a:bodyPr rtlCol="0" anchor="ctr"/>
+          <a:lstStyle/>
+          <a:p>
+            <a:pPr algn="ctr"/>
+          </a:p>
+        </p:txBody>
+      </p:sp>
+      <p:sp>
+        <p:nvSpPr>
+          <p:cNvPr id="3" name="Rectangle 2"/>
+          <p:cNvSpPr/>
+          <p:nvPr/>
+        </p:nvSpPr>
+        <p:spPr>
+          <a:xfrm>
+            <a:off x="609600" y="381000"/>
+            <a:ext cx="259658" cy="165100"/>
+          </a:xfrm>
+          <a:prstGeom prst="rect">
+            <a:avLst/>
+          </a:prstGeom>
+          <a:solidFill>
+            <a:srgbClr val="EC2326"/>
+          </a:solidFill>
+          <a:ln>
+            <a:noFill/>
+          </a:ln>
+          <a:effectLst/>
+        </p:spPr>
+        <p:txBody>
+          <a:bodyPr rtlCol="0" anchor="ctr"/>
+          <a:lstStyle/>
+          <a:p>
+            <a:pPr algn="ctr"/>
+          </a:p>
+        </p:txBody>
+      </p:sp>
+      <p:sp>
+        <p:nvSpPr>
+          <p:cNvPr id="4" name="TextBox 3"/>
+          <p:cNvSpPr txBox="1"/>
+          <p:nvPr/>
+        </p:nvSpPr>
+        <p:spPr>
+          <a:xfrm>
+            <a:off x="609600" y="425450"/>
+            <a:ext cx="259658" cy="82550"/>
+          </a:xfrm>
+          <a:prstGeom prst="rect">
+            <a:avLst/>
+          </a:prstGeom>
+          <a:noFill/>
+        </p:spPr>
+        <p:txBody>
+          <a:bodyPr wrap="none" lIns="69850" rIns="69850" tIns="0" bIns="0" anchor="ctr">
+            <a:noAutofit/>
+          </a:bodyPr>
+          <a:lstStyle/>
+          <a:p>
+            <a:pPr algn="l"/>
+            <a:r>
+              <a:rPr sz="700" b="0" i="0" spc="70">
+                <a:solidFill>
+                  <a:srgbClr val="FFFFFF"/>
+                </a:solidFill>
+                <a:latin typeface="League Spartan SemiBold"/>
+                <a:ea typeface="League Spartan SemiBold"/>
+                <a:cs typeface="League Spartan SemiBold"/>
+              </a:rPr>
+              <a:t>20</a:t>
+            </a:r>
+          </a:p>
+        </p:txBody>
+      </p:sp>
+      <p:sp>
+        <p:nvSpPr>
+          <p:cNvPr id="5" name="TextBox 4"/>
+          <p:cNvSpPr txBox="1"/>
+          <p:nvPr/>
+        </p:nvSpPr>
+        <p:spPr>
+          <a:xfrm>
+            <a:off x="970858" y="414338"/>
+            <a:ext cx="957859" cy="88900"/>
+          </a:xfrm>
+          <a:prstGeom prst="rect">
+            <a:avLst/>
+          </a:prstGeom>
+          <a:noFill/>
+        </p:spPr>
+        <p:txBody>
+          <a:bodyPr wrap="none" lIns="0" rIns="0" tIns="0" bIns="0" anchor="ctr">
+            <a:noAutofit/>
+          </a:bodyPr>
+          <a:lstStyle/>
+          <a:p>
+            <a:pPr algn="l"/>
+            <a:r>
+              <a:rPr sz="780" b="0" i="0" spc="186">
+                <a:solidFill>
+                  <a:srgbClr val="101A2B"/>
+                </a:solidFill>
+                <a:latin typeface="League Spartan SemiBold"/>
+                <a:ea typeface="League Spartan SemiBold"/>
+                <a:cs typeface="League Spartan SemiBold"/>
+              </a:rPr>
+              <a:t>SECTION NAME</a:t>
+            </a:r>
+          </a:p>
+        </p:txBody>
+      </p:sp>
+      <p:pic>
+        <p:nvPicPr>
+          <p:cNvPr id="6" name="Picture 5" descr="iaq-logo-tag.png"/>
+          <p:cNvPicPr>
+            <a:picLocks noChangeAspect="1"/>
+          </p:cNvPicPr>
+          <p:nvPr/>
+        </p:nvPicPr>
+        <p:blipFill>
+          <a:blip r:embed="rId2"/>
+          <a:stretch>
+            <a:fillRect/>
+          </a:stretch>
+        </p:blipFill>
+        <p:spPr>
+          <a:xfrm>
+            <a:off x="10947400" y="304800"/>
+            <a:ext cx="635000" cy="317500"/>
+          </a:xfrm>
+          <a:prstGeom prst="rect">
+            <a:avLst/>
+          </a:prstGeom>
+        </p:spPr>
+      </p:pic>
+      <p:sp>
+        <p:nvSpPr>
+          <p:cNvPr id="7" name="Rectangle 6"/>
+          <p:cNvSpPr/>
+          <p:nvPr/>
+        </p:nvSpPr>
+        <p:spPr>
+          <a:xfrm>
+            <a:off x="609600" y="1438872"/>
+            <a:ext cx="10972800" cy="6350"/>
+          </a:xfrm>
+          <a:prstGeom prst="rect">
+            <a:avLst/>
+          </a:prstGeom>
+          <a:solidFill>
+            <a:srgbClr val="D5DBE2"/>
+          </a:solidFill>
+          <a:ln>
+            <a:noFill/>
+          </a:ln>
+          <a:effectLst/>
+        </p:spPr>
+        <p:txBody>
+          <a:bodyPr rtlCol="0" anchor="ctr"/>
+          <a:lstStyle/>
+          <a:p>
+            <a:pPr algn="ctr"/>
+          </a:p>
+        </p:txBody>
+      </p:sp>
+      <p:sp>
+        <p:nvSpPr>
+          <p:cNvPr id="8" name="TextBox 7"/>
+          <p:cNvSpPr txBox="1"/>
+          <p:nvPr/>
+        </p:nvSpPr>
+        <p:spPr>
+          <a:xfrm>
+            <a:off x="609600" y="768350"/>
+            <a:ext cx="10972800" cy="304800"/>
+          </a:xfrm>
+          <a:prstGeom prst="rect">
+            <a:avLst/>
+          </a:prstGeom>
+          <a:noFill/>
+        </p:spPr>
+        <p:txBody>
+          <a:bodyPr wrap="none" lIns="0" rIns="0" tIns="0" bIns="0" anchor="ctr">
+            <a:noAutofit/>
+          </a:bodyPr>
+          <a:lstStyle/>
+          <a:p>
+            <a:pPr algn="l"/>
+            <a:r>
+              <a:rPr sz="1700" b="0" i="0" spc="-34">
+                <a:solidFill>
+                  <a:srgbClr val="64707A"/>
+                </a:solidFill>
+                <a:latin typeface="Poppins SemiBold"/>
+                <a:ea typeface="Poppins SemiBold"/>
+                <a:cs typeface="Poppins SemiBold"/>
+              </a:rPr>
+              <a:t>Page title</a:t>
+            </a:r>
+          </a:p>
+        </p:txBody>
+      </p:sp>
+      <p:sp>
+        <p:nvSpPr>
+          <p:cNvPr id="9" name="TextBox 8"/>
+          <p:cNvSpPr txBox="1"/>
+          <p:nvPr/>
+        </p:nvSpPr>
+        <p:spPr>
+          <a:xfrm>
+            <a:off x="609600" y="1118197"/>
+            <a:ext cx="6985000" cy="146050"/>
+          </a:xfrm>
+          <a:prstGeom prst="rect">
+            <a:avLst/>
+          </a:prstGeom>
+          <a:noFill/>
+        </p:spPr>
+        <p:txBody>
+          <a:bodyPr wrap="none" lIns="0" rIns="0" tIns="0" bIns="0" anchor="ctr">
+            <a:noAutofit/>
+          </a:bodyPr>
+          <a:lstStyle/>
+          <a:p>
+            <a:pPr algn="l"/>
+            <a:r>
+              <a:rPr sz="950" b="0" i="0">
+                <a:solidFill>
+                  <a:srgbClr val="64707A"/>
+                </a:solidFill>
+                <a:latin typeface="Urbanist"/>
+                <a:ea typeface="Urbanist"/>
+                <a:cs typeface="Urbanist"/>
+              </a:rPr>
+              <a:t>One line under it saying what the page is for.</a:t>
+            </a:r>
+          </a:p>
+        </p:txBody>
+      </p:sp>
+      <p:sp>
+        <p:nvSpPr>
+          <p:cNvPr id="10" name="Rectangle 9"/>
+          <p:cNvSpPr/>
+          <p:nvPr/>
+        </p:nvSpPr>
+        <p:spPr>
+          <a:xfrm>
+            <a:off x="609600" y="1701800"/>
+            <a:ext cx="5403850" cy="4174630"/>
+          </a:xfrm>
+          <a:prstGeom prst="rect">
+            <a:avLst/>
+          </a:prstGeom>
+          <a:solidFill>
+            <a:srgbClr val="FFFFFF"/>
+          </a:solidFill>
+          <a:ln>
+            <a:noFill/>
+          </a:ln>
+          <a:effectLst/>
+        </p:spPr>
+        <p:txBody>
+          <a:bodyPr rtlCol="0" anchor="ctr"/>
+          <a:lstStyle/>
+          <a:p>
+            <a:pPr algn="ctr"/>
+          </a:p>
+        </p:txBody>
+      </p:sp>
+      <p:sp>
+        <p:nvSpPr>
+          <p:cNvPr id="11" name="Rectangle 10"/>
+          <p:cNvSpPr/>
+          <p:nvPr/>
+        </p:nvSpPr>
+        <p:spPr>
+          <a:xfrm>
+            <a:off x="609600" y="1701800"/>
+            <a:ext cx="567830" cy="190500"/>
+          </a:xfrm>
+          <a:prstGeom prst="rect">
+            <a:avLst/>
+          </a:prstGeom>
+          <a:solidFill>
+            <a:srgbClr val="101A2B"/>
+          </a:solidFill>
+          <a:ln>
+            <a:noFill/>
+          </a:ln>
+          <a:effectLst/>
+        </p:spPr>
+        <p:txBody>
+          <a:bodyPr rtlCol="0" anchor="ctr"/>
+          <a:lstStyle/>
+          <a:p>
+            <a:pPr algn="ctr"/>
+          </a:p>
+        </p:txBody>
+      </p:sp>
+      <p:sp>
+        <p:nvSpPr>
+          <p:cNvPr id="12" name="TextBox 11"/>
+          <p:cNvSpPr txBox="1"/>
+          <p:nvPr/>
+        </p:nvSpPr>
+        <p:spPr>
+          <a:xfrm>
+            <a:off x="609600" y="1758950"/>
+            <a:ext cx="567830" cy="76200"/>
+          </a:xfrm>
+          <a:prstGeom prst="rect">
+            <a:avLst/>
+          </a:prstGeom>
+          <a:noFill/>
+        </p:spPr>
+        <p:txBody>
+          <a:bodyPr wrap="none" lIns="101600" rIns="101600" tIns="0" bIns="0" anchor="ctr">
+            <a:noAutofit/>
+          </a:bodyPr>
+          <a:lstStyle/>
+          <a:p>
+            <a:pPr algn="l"/>
+            <a:r>
+              <a:rPr sz="620" b="0" i="0" spc="125">
+                <a:solidFill>
+                  <a:srgbClr val="FFFFFF"/>
+                </a:solidFill>
+                <a:latin typeface="League Spartan SemiBold"/>
+                <a:ea typeface="League Spartan SemiBold"/>
+                <a:cs typeface="League Spartan SemiBold"/>
+              </a:rPr>
+              <a:t>BEFORE</a:t>
+            </a:r>
+          </a:p>
+        </p:txBody>
+      </p:sp>
+      <p:pic>
+        <p:nvPicPr>
+          <p:cNvPr id="13" name="Picture 12" descr="about-facility.jpg"/>
+          <p:cNvPicPr>
+            <a:picLocks noChangeAspect="1"/>
+          </p:cNvPicPr>
+          <p:nvPr/>
+        </p:nvPicPr>
+        <p:blipFill>
+          <a:blip r:embed="rId3"/>
+          <a:srcRect l="17639" r="17639"/>
+          <a:stretch>
+            <a:fillRect/>
+          </a:stretch>
+        </p:blipFill>
+        <p:spPr>
+          <a:xfrm>
+            <a:off x="609600" y="1701800"/>
+            <a:ext cx="5403850" cy="4174630"/>
+          </a:xfrm>
+          <a:prstGeom prst="rect">
+            <a:avLst/>
+          </a:prstGeom>
+        </p:spPr>
+      </p:pic>
+      <p:sp>
+        <p:nvSpPr>
+          <p:cNvPr id="14" name="TextBox 13"/>
+          <p:cNvSpPr txBox="1"/>
+          <p:nvPr/>
+        </p:nvSpPr>
+        <p:spPr>
+          <a:xfrm>
+            <a:off x="609600" y="5971680"/>
+            <a:ext cx="5403850" cy="196850"/>
+          </a:xfrm>
+          <a:prstGeom prst="rect">
+            <a:avLst/>
+          </a:prstGeom>
+          <a:noFill/>
+        </p:spPr>
+        <p:txBody>
+          <a:bodyPr wrap="none" lIns="0" rIns="0" tIns="0" bIns="0" anchor="ctr">
+            <a:noAutofit/>
+          </a:bodyPr>
+          <a:lstStyle/>
+          <a:p>
+            <a:pPr algn="l"/>
+            <a:r>
+              <a:rPr sz="1100" b="0" i="0" spc="-22">
+                <a:solidFill>
+                  <a:srgbClr val="64707A"/>
+                </a:solidFill>
+                <a:latin typeface="Poppins SemiBold"/>
+                <a:ea typeface="Poppins SemiBold"/>
+                <a:cs typeface="Poppins SemiBold"/>
+              </a:rPr>
+              <a:t>What it was</a:t>
+            </a:r>
+          </a:p>
+        </p:txBody>
+      </p:sp>
+      <p:sp>
+        <p:nvSpPr>
+          <p:cNvPr id="15" name="TextBox 14"/>
+          <p:cNvSpPr txBox="1"/>
+          <p:nvPr/>
+        </p:nvSpPr>
+        <p:spPr>
+          <a:xfrm>
+            <a:off x="609600" y="6215463"/>
+            <a:ext cx="5403850" cy="120650"/>
+          </a:xfrm>
+          <a:prstGeom prst="rect">
+            <a:avLst/>
+          </a:prstGeom>
+          <a:noFill/>
+        </p:spPr>
+        <p:txBody>
+          <a:bodyPr wrap="none" lIns="0" rIns="0" tIns="0" bIns="0" anchor="ctr">
+            <a:noAutofit/>
+          </a:bodyPr>
+          <a:lstStyle/>
+          <a:p>
+            <a:pPr algn="l"/>
+            <a:r>
+              <a:rPr sz="800" b="0" i="0">
+                <a:solidFill>
+                  <a:srgbClr val="64707A"/>
+                </a:solidFill>
+                <a:latin typeface="Urbanist"/>
+                <a:ea typeface="Urbanist"/>
+                <a:cs typeface="Urbanist"/>
+              </a:rPr>
+              <a:t>One or two sentences on the state it started in.</a:t>
+            </a:r>
+          </a:p>
+        </p:txBody>
+      </p:sp>
+      <p:sp>
+        <p:nvSpPr>
+          <p:cNvPr id="16" name="Rectangle 15"/>
+          <p:cNvSpPr/>
+          <p:nvPr/>
+        </p:nvSpPr>
+        <p:spPr>
+          <a:xfrm>
+            <a:off x="6178550" y="1701800"/>
+            <a:ext cx="5403850" cy="4174630"/>
+          </a:xfrm>
+          <a:prstGeom prst="rect">
+            <a:avLst/>
+          </a:prstGeom>
+          <a:solidFill>
+            <a:srgbClr val="FFFFFF"/>
+          </a:solidFill>
+          <a:ln>
+            <a:noFill/>
+          </a:ln>
+          <a:effectLst/>
+        </p:spPr>
+        <p:txBody>
+          <a:bodyPr rtlCol="0" anchor="ctr"/>
+          <a:lstStyle/>
+          <a:p>
+            <a:pPr algn="ctr"/>
+          </a:p>
+        </p:txBody>
+      </p:sp>
+      <p:sp>
+        <p:nvSpPr>
+          <p:cNvPr id="17" name="Rectangle 16"/>
+          <p:cNvSpPr/>
+          <p:nvPr/>
+        </p:nvSpPr>
+        <p:spPr>
+          <a:xfrm>
+            <a:off x="6178550" y="1701800"/>
+            <a:ext cx="499370" cy="190500"/>
+          </a:xfrm>
+          <a:prstGeom prst="rect">
+            <a:avLst/>
+          </a:prstGeom>
+          <a:solidFill>
+            <a:srgbClr val="EC2326"/>
+          </a:solidFill>
+          <a:ln>
+            <a:noFill/>
+          </a:ln>
+          <a:effectLst/>
+        </p:spPr>
+        <p:txBody>
+          <a:bodyPr rtlCol="0" anchor="ctr"/>
+          <a:lstStyle/>
+          <a:p>
+            <a:pPr algn="ctr"/>
+          </a:p>
+        </p:txBody>
+      </p:sp>
+      <p:sp>
+        <p:nvSpPr>
+          <p:cNvPr id="18" name="TextBox 17"/>
+          <p:cNvSpPr txBox="1"/>
+          <p:nvPr/>
+        </p:nvSpPr>
+        <p:spPr>
+          <a:xfrm>
+            <a:off x="6178550" y="1758950"/>
+            <a:ext cx="499370" cy="76200"/>
+          </a:xfrm>
+          <a:prstGeom prst="rect">
+            <a:avLst/>
+          </a:prstGeom>
+          <a:noFill/>
+        </p:spPr>
+        <p:txBody>
+          <a:bodyPr wrap="none" lIns="101600" rIns="101600" tIns="0" bIns="0" anchor="ctr">
+            <a:noAutofit/>
+          </a:bodyPr>
+          <a:lstStyle/>
+          <a:p>
+            <a:pPr algn="l"/>
+            <a:r>
+              <a:rPr sz="620" b="0" i="0" spc="125">
+                <a:solidFill>
+                  <a:srgbClr val="FFFFFF"/>
+                </a:solidFill>
+                <a:latin typeface="League Spartan SemiBold"/>
+                <a:ea typeface="League Spartan SemiBold"/>
+                <a:cs typeface="League Spartan SemiBold"/>
+              </a:rPr>
+              <a:t>AFTER</a:t>
+            </a:r>
+          </a:p>
+        </p:txBody>
+      </p:sp>
+      <p:pic>
+        <p:nvPicPr>
+          <p:cNvPr id="19" name="Picture 18" descr="glance-cleanroom.jpg"/>
+          <p:cNvPicPr>
+            <a:picLocks noChangeAspect="1"/>
+          </p:cNvPicPr>
+          <p:nvPr/>
+        </p:nvPicPr>
+        <p:blipFill>
+          <a:blip r:embed="rId4"/>
+          <a:srcRect t="15233" b="15233"/>
+          <a:stretch>
+            <a:fillRect/>
+          </a:stretch>
+        </p:blipFill>
+        <p:spPr>
+          <a:xfrm>
+            <a:off x="6178550" y="1701800"/>
+            <a:ext cx="5403850" cy="4174630"/>
+          </a:xfrm>
+          <a:prstGeom prst="rect">
+            <a:avLst/>
+          </a:prstGeom>
+        </p:spPr>
+      </p:pic>
+      <p:sp>
+        <p:nvSpPr>
+          <p:cNvPr id="20" name="TextBox 19"/>
+          <p:cNvSpPr txBox="1"/>
+          <p:nvPr/>
+        </p:nvSpPr>
+        <p:spPr>
+          <a:xfrm>
+            <a:off x="6178550" y="5971680"/>
+            <a:ext cx="5403850" cy="196850"/>
+          </a:xfrm>
+          <a:prstGeom prst="rect">
+            <a:avLst/>
+          </a:prstGeom>
+          <a:noFill/>
+        </p:spPr>
+        <p:txBody>
+          <a:bodyPr wrap="none" lIns="0" rIns="0" tIns="0" bIns="0" anchor="ctr">
+            <a:noAutofit/>
+          </a:bodyPr>
+          <a:lstStyle/>
+          <a:p>
+            <a:pPr algn="l"/>
+            <a:r>
+              <a:rPr sz="1100" b="0" i="0" spc="-22">
+                <a:solidFill>
+                  <a:srgbClr val="64707A"/>
+                </a:solidFill>
+                <a:latin typeface="Poppins SemiBold"/>
+                <a:ea typeface="Poppins SemiBold"/>
+                <a:cs typeface="Poppins SemiBold"/>
+              </a:rPr>
+              <a:t>What it became</a:t>
+            </a:r>
+          </a:p>
+        </p:txBody>
+      </p:sp>
+      <p:sp>
+        <p:nvSpPr>
+          <p:cNvPr id="21" name="TextBox 20"/>
+          <p:cNvSpPr txBox="1"/>
+          <p:nvPr/>
+        </p:nvSpPr>
+        <p:spPr>
+          <a:xfrm>
+            <a:off x="6178550" y="6215463"/>
+            <a:ext cx="5403850" cy="120650"/>
+          </a:xfrm>
+          <a:prstGeom prst="rect">
+            <a:avLst/>
+          </a:prstGeom>
+          <a:noFill/>
+        </p:spPr>
+        <p:txBody>
+          <a:bodyPr wrap="none" lIns="0" rIns="0" tIns="0" bIns="0" anchor="ctr">
+            <a:noAutofit/>
+          </a:bodyPr>
+          <a:lstStyle/>
+          <a:p>
+            <a:pPr algn="l"/>
+            <a:r>
+              <a:rPr sz="800" b="0" i="0">
+                <a:solidFill>
+                  <a:srgbClr val="64707A"/>
+                </a:solidFill>
+                <a:latin typeface="Urbanist"/>
+                <a:ea typeface="Urbanist"/>
+                <a:cs typeface="Urbanist"/>
+              </a:rPr>
+              <a:t>One or two sentences on the state it ended in.</a:t>
+            </a:r>
+          </a:p>
+        </p:txBody>
+      </p:sp>
+      <p:sp>
+        <p:nvSpPr>
+          <p:cNvPr id="22" name="TextBox 21"/>
+          <p:cNvSpPr txBox="1"/>
+          <p:nvPr/>
+        </p:nvSpPr>
+        <p:spPr>
+          <a:xfrm>
+            <a:off x="609600" y="6445250"/>
+            <a:ext cx="135236" cy="76200"/>
+          </a:xfrm>
+          <a:prstGeom prst="rect">
+            <a:avLst/>
+          </a:prstGeom>
+          <a:noFill/>
+        </p:spPr>
+        <p:txBody>
+          <a:bodyPr wrap="none" lIns="0" rIns="0" tIns="0" bIns="0" anchor="ctr">
+            <a:noAutofit/>
+          </a:bodyPr>
+          <a:lstStyle/>
+          <a:p>
+            <a:pPr algn="l"/>
+            <a:r>
+              <a:rPr sz="680" b="0" i="0" spc="148">
+                <a:solidFill>
+                  <a:srgbClr val="64707A"/>
+                </a:solidFill>
+                <a:latin typeface="League Spartan Medium"/>
+                <a:ea typeface="League Spartan Medium"/>
+                <a:cs typeface="League Spartan Medium"/>
+              </a:rPr>
+              <a:t>20</a:t>
+            </a:r>
+          </a:p>
+        </p:txBody>
+      </p:sp>
+      <p:sp>
+        <p:nvSpPr>
+          <p:cNvPr id="23" name="TextBox 22"/>
+          <p:cNvSpPr txBox="1"/>
+          <p:nvPr/>
+        </p:nvSpPr>
+        <p:spPr>
+          <a:xfrm>
+            <a:off x="10569080" y="6429375"/>
+            <a:ext cx="1013320" cy="76200"/>
+          </a:xfrm>
+          <a:prstGeom prst="rect">
+            <a:avLst/>
+          </a:prstGeom>
+          <a:noFill/>
+        </p:spPr>
+        <p:txBody>
+          <a:bodyPr wrap="none" lIns="0" rIns="0" tIns="0" bIns="0" anchor="ctr">
+            <a:noAutofit/>
+          </a:bodyPr>
+          <a:lstStyle/>
+          <a:p>
+            <a:pPr algn="l"/>
+            <a:r>
+              <a:rPr sz="680" b="0" i="0" spc="148">
+                <a:solidFill>
+                  <a:srgbClr val="64707A"/>
+                </a:solidFill>
+                <a:latin typeface="League Spartan"/>
+                <a:ea typeface="League Spartan"/>
+                <a:cs typeface="League Spartan"/>
+              </a:rPr>
+              <a:t>BEFORE AND AFTER</a:t>
             </a:r>
           </a:p>
         </p:txBody>

</xml_diff>

<commit_message>
Name the latin face as the latin face, and nothing else
Every run was naming its typeface three times over: as the latin font,
the east-asian font and the complex-script font. For a reader that has
the font, no difference. For one that does not, naming a latin face as
the east-asian font sends it down its symbol fallback, which is how a
missing Urbanist came back on screen as circles, triangles and arrows
while Poppins, which that machine had, read fine.

Runs now name the latin face only. The layouts and the master are cut
from the same pages, so they carry the correction too. The nine faces
stay embedded, the deck ships with its own font folder and a note that
says to install them first, and a PDF goes with it for anyone who
cannot.

Co-Authored-By: Claude Opus 5 <noreply@anthropic.com>
Claude-Session: https://claude.ai/code/session_01J2vuPhCFFpRn7AimXuA7Hp
</commit_message>
<xml_diff>
--- a/iaq-deck/template/IAQ-Master-Template-2026.pptx
+++ b/iaq-deck/template/IAQ-Master-Template-2026.pptx
@@ -3205,8 +3205,6 @@
                   <a:srgbClr val="101A2B"/>
                 </a:solidFill>
                 <a:latin typeface="League Spartan SemiBold"/>
-                <a:ea typeface="League Spartan SemiBold"/>
-                <a:cs typeface="League Spartan SemiBold"/>
               </a:rPr>
               <a:t>IAQ TECHNOLOGY INTERNATIONAL SDN BHD</a:t>
             </a:r>
@@ -3296,8 +3294,6 @@
                   <a:srgbClr val="EC2326"/>
                 </a:solidFill>
                 <a:latin typeface="Poppins SemiBold"/>
-                <a:ea typeface="Poppins SemiBold"/>
-                <a:cs typeface="Poppins SemiBold"/>
               </a:rPr>
               <a:t>Master template</a:t>
             </a:r>
@@ -3333,10 +3329,8 @@
                   <a:srgbClr val="64707A"/>
                 </a:solidFill>
                 <a:latin typeface="Urbanist"/>
-                <a:ea typeface="Urbanist"/>
-                <a:cs typeface="Urbanist"/>
-              </a:rPr>
-              <a:t>Seventeen layouts to build a new slide from. Copy the page you need and type into it.</a:t>
+              </a:rPr>
+              <a:t>Every layout in the set. Copy the page you need and type into it.</a:t>
             </a:r>
           </a:p>
         </p:txBody>
@@ -3370,8 +3364,6 @@
                   <a:srgbClr val="EC2326"/>
                 </a:solidFill>
                 <a:latin typeface="League Spartan SemiBold"/>
-                <a:ea typeface="League Spartan SemiBold"/>
-                <a:cs typeface="League Spartan SemiBold"/>
               </a:rPr>
               <a:t>01</a:t>
             </a:r>
@@ -3407,8 +3399,6 @@
                   <a:srgbClr val="101A2B"/>
                 </a:solidFill>
                 <a:latin typeface="Poppins SemiBold"/>
-                <a:ea typeface="Poppins SemiBold"/>
-                <a:cs typeface="Poppins SemiBold"/>
               </a:rPr>
               <a:t>Title</a:t>
             </a:r>
@@ -3444,8 +3434,6 @@
                   <a:srgbClr val="64707A"/>
                 </a:solidFill>
                 <a:latin typeface="Urbanist"/>
-                <a:ea typeface="Urbanist"/>
-                <a:cs typeface="Urbanist"/>
               </a:rPr>
               <a:t>Open a deck or a chapter of one.</a:t>
             </a:r>
@@ -3481,8 +3469,6 @@
                   <a:srgbClr val="EC2326"/>
                 </a:solidFill>
                 <a:latin typeface="League Spartan SemiBold"/>
-                <a:ea typeface="League Spartan SemiBold"/>
-                <a:cs typeface="League Spartan SemiBold"/>
               </a:rPr>
               <a:t>02</a:t>
             </a:r>
@@ -3518,8 +3504,6 @@
                   <a:srgbClr val="101A2B"/>
                 </a:solidFill>
                 <a:latin typeface="Poppins SemiBold"/>
-                <a:ea typeface="Poppins SemiBold"/>
-                <a:cs typeface="Poppins SemiBold"/>
               </a:rPr>
               <a:t>Section divider</a:t>
             </a:r>
@@ -3555,8 +3539,6 @@
                   <a:srgbClr val="64707A"/>
                 </a:solidFill>
                 <a:latin typeface="Urbanist"/>
-                <a:ea typeface="Urbanist"/>
-                <a:cs typeface="Urbanist"/>
               </a:rPr>
               <a:t>Open a new part of the deck.</a:t>
             </a:r>
@@ -3592,8 +3574,6 @@
                   <a:srgbClr val="EC2326"/>
                 </a:solidFill>
                 <a:latin typeface="League Spartan SemiBold"/>
-                <a:ea typeface="League Spartan SemiBold"/>
-                <a:cs typeface="League Spartan SemiBold"/>
               </a:rPr>
               <a:t>03</a:t>
             </a:r>
@@ -3629,8 +3609,6 @@
                   <a:srgbClr val="101A2B"/>
                 </a:solidFill>
                 <a:latin typeface="Poppins SemiBold"/>
-                <a:ea typeface="Poppins SemiBold"/>
-                <a:cs typeface="Poppins SemiBold"/>
               </a:rPr>
               <a:t>Statement</a:t>
             </a:r>
@@ -3666,8 +3644,6 @@
                   <a:srgbClr val="64707A"/>
                 </a:solidFill>
                 <a:latin typeface="Urbanist"/>
-                <a:ea typeface="Urbanist"/>
-                <a:cs typeface="Urbanist"/>
               </a:rPr>
               <a:t>One argument, said plainly, with a photograph.</a:t>
             </a:r>
@@ -3703,8 +3679,6 @@
                   <a:srgbClr val="EC2326"/>
                 </a:solidFill>
                 <a:latin typeface="League Spartan SemiBold"/>
-                <a:ea typeface="League Spartan SemiBold"/>
-                <a:cs typeface="League Spartan SemiBold"/>
               </a:rPr>
               <a:t>04</a:t>
             </a:r>
@@ -3740,8 +3714,6 @@
                   <a:srgbClr val="101A2B"/>
                 </a:solidFill>
                 <a:latin typeface="Poppins SemiBold"/>
-                <a:ea typeface="Poppins SemiBold"/>
-                <a:cs typeface="Poppins SemiBold"/>
               </a:rPr>
               <a:t>Highlights</a:t>
             </a:r>
@@ -3777,8 +3749,6 @@
                   <a:srgbClr val="64707A"/>
                 </a:solidFill>
                 <a:latin typeface="Urbanist"/>
-                <a:ea typeface="Urbanist"/>
-                <a:cs typeface="Urbanist"/>
               </a:rPr>
               <a:t>Three or four figures that carry the page.</a:t>
             </a:r>
@@ -3814,8 +3784,6 @@
                   <a:srgbClr val="EC2326"/>
                 </a:solidFill>
                 <a:latin typeface="League Spartan SemiBold"/>
-                <a:ea typeface="League Spartan SemiBold"/>
-                <a:cs typeface="League Spartan SemiBold"/>
               </a:rPr>
               <a:t>05</a:t>
             </a:r>
@@ -3851,8 +3819,6 @@
                   <a:srgbClr val="101A2B"/>
                 </a:solidFill>
                 <a:latin typeface="Poppins SemiBold"/>
-                <a:ea typeface="Poppins SemiBold"/>
-                <a:cs typeface="Poppins SemiBold"/>
               </a:rPr>
               <a:t>Icon cards</a:t>
             </a:r>
@@ -3888,8 +3854,6 @@
                   <a:srgbClr val="64707A"/>
                 </a:solidFill>
                 <a:latin typeface="Urbanist"/>
-                <a:ea typeface="Urbanist"/>
-                <a:cs typeface="Urbanist"/>
               </a:rPr>
               <a:t>A set of capabilities, services or principles.</a:t>
             </a:r>
@@ -3925,8 +3889,6 @@
                   <a:srgbClr val="EC2326"/>
                 </a:solidFill>
                 <a:latin typeface="League Spartan SemiBold"/>
-                <a:ea typeface="League Spartan SemiBold"/>
-                <a:cs typeface="League Spartan SemiBold"/>
               </a:rPr>
               <a:t>06</a:t>
             </a:r>
@@ -3962,8 +3924,6 @@
                   <a:srgbClr val="101A2B"/>
                 </a:solidFill>
                 <a:latin typeface="Poppins SemiBold"/>
-                <a:ea typeface="Poppins SemiBold"/>
-                <a:cs typeface="Poppins SemiBold"/>
               </a:rPr>
               <a:t>Comparison</a:t>
             </a:r>
@@ -3999,8 +3959,6 @@
                   <a:srgbClr val="64707A"/>
                 </a:solidFill>
                 <a:latin typeface="Urbanist"/>
-                <a:ea typeface="Urbanist"/>
-                <a:cs typeface="Urbanist"/>
               </a:rPr>
               <a:t>Two or three options read side by side.</a:t>
             </a:r>
@@ -4036,8 +3994,6 @@
                   <a:srgbClr val="EC2326"/>
                 </a:solidFill>
                 <a:latin typeface="League Spartan SemiBold"/>
-                <a:ea typeface="League Spartan SemiBold"/>
-                <a:cs typeface="League Spartan SemiBold"/>
               </a:rPr>
               <a:t>07</a:t>
             </a:r>
@@ -4073,8 +4029,6 @@
                   <a:srgbClr val="101A2B"/>
                 </a:solidFill>
                 <a:latin typeface="Poppins SemiBold"/>
-                <a:ea typeface="Poppins SemiBold"/>
-                <a:cs typeface="Poppins SemiBold"/>
               </a:rPr>
               <a:t>Org chart · reporting tree</a:t>
             </a:r>
@@ -4110,8 +4064,6 @@
                   <a:srgbClr val="64707A"/>
                 </a:solidFill>
                 <a:latin typeface="Urbanist"/>
-                <a:ea typeface="Urbanist"/>
-                <a:cs typeface="Urbanist"/>
               </a:rPr>
               <a:t>Who reports to whom, three levels at most.</a:t>
             </a:r>
@@ -4147,8 +4099,6 @@
                   <a:srgbClr val="EC2326"/>
                 </a:solidFill>
                 <a:latin typeface="League Spartan SemiBold"/>
-                <a:ea typeface="League Spartan SemiBold"/>
-                <a:cs typeface="League Spartan SemiBold"/>
               </a:rPr>
               <a:t>08</a:t>
             </a:r>
@@ -4184,8 +4134,6 @@
                   <a:srgbClr val="101A2B"/>
                 </a:solidFill>
                 <a:latin typeface="Poppins SemiBold"/>
-                <a:ea typeface="Poppins SemiBold"/>
-                <a:cs typeface="Poppins SemiBold"/>
               </a:rPr>
               <a:t>Org chart · flat team band</a:t>
             </a:r>
@@ -4221,8 +4169,6 @@
                   <a:srgbClr val="64707A"/>
                 </a:solidFill>
                 <a:latin typeface="Urbanist"/>
-                <a:ea typeface="Urbanist"/>
-                <a:cs typeface="Urbanist"/>
               </a:rPr>
               <a:t>A team of peers, no hierarchy implied.</a:t>
             </a:r>
@@ -4258,8 +4204,6 @@
                   <a:srgbClr val="EC2326"/>
                 </a:solidFill>
                 <a:latin typeface="League Spartan SemiBold"/>
-                <a:ea typeface="League Spartan SemiBold"/>
-                <a:cs typeface="League Spartan SemiBold"/>
               </a:rPr>
               <a:t>09</a:t>
             </a:r>
@@ -4295,8 +4239,6 @@
                   <a:srgbClr val="101A2B"/>
                 </a:solidFill>
                 <a:latin typeface="Poppins SemiBold"/>
-                <a:ea typeface="Poppins SemiBold"/>
-                <a:cs typeface="Poppins SemiBold"/>
               </a:rPr>
               <a:t>Org chart · group structure</a:t>
             </a:r>
@@ -4332,8 +4274,6 @@
                   <a:srgbClr val="64707A"/>
                 </a:solidFill>
                 <a:latin typeface="Urbanist"/>
-                <a:ea typeface="Urbanist"/>
-                <a:cs typeface="Urbanist"/>
               </a:rPr>
               <a:t>A holding company and the businesses under it.</a:t>
             </a:r>
@@ -4369,8 +4309,6 @@
                   <a:srgbClr val="EC2326"/>
                 </a:solidFill>
                 <a:latin typeface="League Spartan SemiBold"/>
-                <a:ea typeface="League Spartan SemiBold"/>
-                <a:cs typeface="League Spartan SemiBold"/>
               </a:rPr>
               <a:t>10</a:t>
             </a:r>
@@ -4406,8 +4344,6 @@
                   <a:srgbClr val="101A2B"/>
                 </a:solidFill>
                 <a:latin typeface="Poppins SemiBold"/>
-                <a:ea typeface="Poppins SemiBold"/>
-                <a:cs typeface="Poppins SemiBold"/>
               </a:rPr>
               <a:t>Process</a:t>
             </a:r>
@@ -4443,8 +4379,6 @@
                   <a:srgbClr val="64707A"/>
                 </a:solidFill>
                 <a:latin typeface="Urbanist"/>
-                <a:ea typeface="Urbanist"/>
-                <a:cs typeface="Urbanist"/>
               </a:rPr>
               <a:t>Stages that run in order, start to finish.</a:t>
             </a:r>
@@ -4480,8 +4414,6 @@
                   <a:srgbClr val="EC2326"/>
                 </a:solidFill>
                 <a:latin typeface="League Spartan SemiBold"/>
-                <a:ea typeface="League Spartan SemiBold"/>
-                <a:cs typeface="League Spartan SemiBold"/>
               </a:rPr>
               <a:t>11</a:t>
             </a:r>
@@ -4517,8 +4449,6 @@
                   <a:srgbClr val="101A2B"/>
                 </a:solidFill>
                 <a:latin typeface="Poppins SemiBold"/>
-                <a:ea typeface="Poppins SemiBold"/>
-                <a:cs typeface="Poppins SemiBold"/>
               </a:rPr>
               <a:t>Timeline</a:t>
             </a:r>
@@ -4554,8 +4484,6 @@
                   <a:srgbClr val="64707A"/>
                 </a:solidFill>
                 <a:latin typeface="Urbanist"/>
-                <a:ea typeface="Urbanist"/>
-                <a:cs typeface="Urbanist"/>
               </a:rPr>
               <a:t>Dates in order, with what happened at each.</a:t>
             </a:r>
@@ -4591,8 +4519,6 @@
                   <a:srgbClr val="EC2326"/>
                 </a:solidFill>
                 <a:latin typeface="League Spartan SemiBold"/>
-                <a:ea typeface="League Spartan SemiBold"/>
-                <a:cs typeface="League Spartan SemiBold"/>
               </a:rPr>
               <a:t>12</a:t>
             </a:r>
@@ -4628,8 +4554,6 @@
                   <a:srgbClr val="101A2B"/>
                 </a:solidFill>
                 <a:latin typeface="Poppins SemiBold"/>
-                <a:ea typeface="Poppins SemiBold"/>
-                <a:cs typeface="Poppins SemiBold"/>
               </a:rPr>
               <a:t>Infographic</a:t>
             </a:r>
@@ -4665,8 +4589,6 @@
                   <a:srgbClr val="64707A"/>
                 </a:solidFill>
                 <a:latin typeface="Urbanist"/>
-                <a:ea typeface="Urbanist"/>
-                <a:cs typeface="Urbanist"/>
               </a:rPr>
               <a:t>One visual in the middle, the parts around it.</a:t>
             </a:r>
@@ -4702,8 +4624,6 @@
                   <a:srgbClr val="EC2326"/>
                 </a:solidFill>
                 <a:latin typeface="League Spartan SemiBold"/>
-                <a:ea typeface="League Spartan SemiBold"/>
-                <a:cs typeface="League Spartan SemiBold"/>
               </a:rPr>
               <a:t>13</a:t>
             </a:r>
@@ -4739,8 +4659,6 @@
                   <a:srgbClr val="101A2B"/>
                 </a:solidFill>
                 <a:latin typeface="Poppins SemiBold"/>
-                <a:ea typeface="Poppins SemiBold"/>
-                <a:cs typeface="Poppins SemiBold"/>
               </a:rPr>
               <a:t>Image and specs</a:t>
             </a:r>
@@ -4776,8 +4694,6 @@
                   <a:srgbClr val="64707A"/>
                 </a:solidFill>
                 <a:latin typeface="Urbanist"/>
-                <a:ea typeface="Urbanist"/>
-                <a:cs typeface="Urbanist"/>
               </a:rPr>
               <a:t>One project or product, pictured and specified.</a:t>
             </a:r>
@@ -4813,8 +4729,6 @@
                   <a:srgbClr val="EC2326"/>
                 </a:solidFill>
                 <a:latin typeface="League Spartan SemiBold"/>
-                <a:ea typeface="League Spartan SemiBold"/>
-                <a:cs typeface="League Spartan SemiBold"/>
               </a:rPr>
               <a:t>14</a:t>
             </a:r>
@@ -4850,8 +4764,6 @@
                   <a:srgbClr val="101A2B"/>
                 </a:solidFill>
                 <a:latin typeface="Poppins SemiBold"/>
-                <a:ea typeface="Poppins SemiBold"/>
-                <a:cs typeface="Poppins SemiBold"/>
               </a:rPr>
               <a:t>Programme</a:t>
             </a:r>
@@ -4887,8 +4799,6 @@
                   <a:srgbClr val="64707A"/>
                 </a:solidFill>
                 <a:latin typeface="Urbanist"/>
-                <a:ea typeface="Urbanist"/>
-                <a:cs typeface="Urbanist"/>
               </a:rPr>
               <a:t>Work packages against a calendar.</a:t>
             </a:r>
@@ -4924,8 +4834,6 @@
                   <a:srgbClr val="EC2326"/>
                 </a:solidFill>
                 <a:latin typeface="League Spartan SemiBold"/>
-                <a:ea typeface="League Spartan SemiBold"/>
-                <a:cs typeface="League Spartan SemiBold"/>
               </a:rPr>
               <a:t>15</a:t>
             </a:r>
@@ -4961,8 +4869,6 @@
                   <a:srgbClr val="101A2B"/>
                 </a:solidFill>
                 <a:latin typeface="Poppins SemiBold"/>
-                <a:ea typeface="Poppins SemiBold"/>
-                <a:cs typeface="Poppins SemiBold"/>
               </a:rPr>
               <a:t>Table</a:t>
             </a:r>
@@ -4998,8 +4904,6 @@
                   <a:srgbClr val="64707A"/>
                 </a:solidFill>
                 <a:latin typeface="Urbanist"/>
-                <a:ea typeface="Urbanist"/>
-                <a:cs typeface="Urbanist"/>
               </a:rPr>
               <a:t>Rows and columns, where the detail has to be exact.</a:t>
             </a:r>
@@ -5035,8 +4939,6 @@
                   <a:srgbClr val="EC2326"/>
                 </a:solidFill>
                 <a:latin typeface="League Spartan SemiBold"/>
-                <a:ea typeface="League Spartan SemiBold"/>
-                <a:cs typeface="League Spartan SemiBold"/>
               </a:rPr>
               <a:t>16</a:t>
             </a:r>
@@ -5072,8 +4974,6 @@
                   <a:srgbClr val="101A2B"/>
                 </a:solidFill>
                 <a:latin typeface="Poppins SemiBold"/>
-                <a:ea typeface="Poppins SemiBold"/>
-                <a:cs typeface="Poppins SemiBold"/>
               </a:rPr>
               <a:t>Full-bleed image</a:t>
             </a:r>
@@ -5109,8 +5009,6 @@
                   <a:srgbClr val="64707A"/>
                 </a:solidFill>
                 <a:latin typeface="Urbanist"/>
-                <a:ea typeface="Urbanist"/>
-                <a:cs typeface="Urbanist"/>
               </a:rPr>
               <a:t>Let one photograph carry the page.</a:t>
             </a:r>
@@ -5146,8 +5044,6 @@
                   <a:srgbClr val="EC2326"/>
                 </a:solidFill>
                 <a:latin typeface="League Spartan SemiBold"/>
-                <a:ea typeface="League Spartan SemiBold"/>
-                <a:cs typeface="League Spartan SemiBold"/>
               </a:rPr>
               <a:t>17</a:t>
             </a:r>
@@ -5183,8 +5079,6 @@
                   <a:srgbClr val="101A2B"/>
                 </a:solidFill>
                 <a:latin typeface="Poppins SemiBold"/>
-                <a:ea typeface="Poppins SemiBold"/>
-                <a:cs typeface="Poppins SemiBold"/>
               </a:rPr>
               <a:t>Closing</a:t>
             </a:r>
@@ -5220,8 +5114,6 @@
                   <a:srgbClr val="64707A"/>
                 </a:solidFill>
                 <a:latin typeface="Urbanist"/>
-                <a:ea typeface="Urbanist"/>
-                <a:cs typeface="Urbanist"/>
               </a:rPr>
               <a:t>End the deck: the ask, and how to reach you.</a:t>
             </a:r>
@@ -5257,8 +5149,6 @@
                   <a:srgbClr val="EC2326"/>
                 </a:solidFill>
                 <a:latin typeface="League Spartan SemiBold"/>
-                <a:ea typeface="League Spartan SemiBold"/>
-                <a:cs typeface="League Spartan SemiBold"/>
               </a:rPr>
               <a:t>18</a:t>
             </a:r>
@@ -5294,8 +5184,6 @@
                   <a:srgbClr val="101A2B"/>
                 </a:solidFill>
                 <a:latin typeface="Poppins SemiBold"/>
-                <a:ea typeface="Poppins SemiBold"/>
-                <a:cs typeface="Poppins SemiBold"/>
               </a:rPr>
               <a:t>Agenda</a:t>
             </a:r>
@@ -5331,8 +5219,6 @@
                   <a:srgbClr val="64707A"/>
                 </a:solidFill>
                 <a:latin typeface="Urbanist"/>
-                <a:ea typeface="Urbanist"/>
-                <a:cs typeface="Urbanist"/>
               </a:rPr>
               <a:t>What the deck covers, before it covers it.</a:t>
             </a:r>
@@ -5368,8 +5254,6 @@
                   <a:srgbClr val="EC2326"/>
                 </a:solidFill>
                 <a:latin typeface="League Spartan SemiBold"/>
-                <a:ea typeface="League Spartan SemiBold"/>
-                <a:cs typeface="League Spartan SemiBold"/>
               </a:rPr>
               <a:t>19</a:t>
             </a:r>
@@ -5405,8 +5289,6 @@
                   <a:srgbClr val="101A2B"/>
                 </a:solidFill>
                 <a:latin typeface="Poppins SemiBold"/>
-                <a:ea typeface="Poppins SemiBold"/>
-                <a:cs typeface="Poppins SemiBold"/>
               </a:rPr>
               <a:t>Quote</a:t>
             </a:r>
@@ -5442,8 +5324,6 @@
                   <a:srgbClr val="64707A"/>
                 </a:solidFill>
                 <a:latin typeface="Urbanist"/>
-                <a:ea typeface="Urbanist"/>
-                <a:cs typeface="Urbanist"/>
               </a:rPr>
               <a:t>Let a client, or the board, say it instead of you.</a:t>
             </a:r>
@@ -5479,8 +5359,6 @@
                   <a:srgbClr val="EC2326"/>
                 </a:solidFill>
                 <a:latin typeface="League Spartan SemiBold"/>
-                <a:ea typeface="League Spartan SemiBold"/>
-                <a:cs typeface="League Spartan SemiBold"/>
               </a:rPr>
               <a:t>20</a:t>
             </a:r>
@@ -5516,8 +5394,6 @@
                   <a:srgbClr val="101A2B"/>
                 </a:solidFill>
                 <a:latin typeface="Poppins SemiBold"/>
-                <a:ea typeface="Poppins SemiBold"/>
-                <a:cs typeface="Poppins SemiBold"/>
               </a:rPr>
               <a:t>Before and after</a:t>
             </a:r>
@@ -5553,8 +5429,6 @@
                   <a:srgbClr val="64707A"/>
                 </a:solidFill>
                 <a:latin typeface="Urbanist"/>
-                <a:ea typeface="Urbanist"/>
-                <a:cs typeface="Urbanist"/>
               </a:rPr>
               <a:t>Two states of the same thing, side by side.</a:t>
             </a:r>
@@ -5590,8 +5464,6 @@
                   <a:srgbClr val="64707A"/>
                 </a:solidFill>
                 <a:latin typeface="League Spartan Medium"/>
-                <a:ea typeface="League Spartan Medium"/>
-                <a:cs typeface="League Spartan Medium"/>
               </a:rPr>
               <a:t>00</a:t>
             </a:r>
@@ -5627,8 +5499,6 @@
                   <a:srgbClr val="64707A"/>
                 </a:solidFill>
                 <a:latin typeface="League Spartan"/>
-                <a:ea typeface="League Spartan"/>
-                <a:cs typeface="League Spartan"/>
               </a:rPr>
               <a:t>CONTENTS</a:t>
             </a:r>
@@ -5742,8 +5612,6 @@
                   <a:srgbClr val="FFFFFF"/>
                 </a:solidFill>
                 <a:latin typeface="League Spartan SemiBold"/>
-                <a:ea typeface="League Spartan SemiBold"/>
-                <a:cs typeface="League Spartan SemiBold"/>
               </a:rPr>
               <a:t>09</a:t>
             </a:r>
@@ -5779,8 +5647,6 @@
                   <a:srgbClr val="101A2B"/>
                 </a:solidFill>
                 <a:latin typeface="League Spartan SemiBold"/>
-                <a:ea typeface="League Spartan SemiBold"/>
-                <a:cs typeface="League Spartan SemiBold"/>
               </a:rPr>
               <a:t>SECTION NAME</a:t>
             </a:r>
@@ -5870,8 +5736,6 @@
                   <a:srgbClr val="64707A"/>
                 </a:solidFill>
                 <a:latin typeface="Poppins SemiBold"/>
-                <a:ea typeface="Poppins SemiBold"/>
-                <a:cs typeface="Poppins SemiBold"/>
               </a:rPr>
               <a:t>Page title</a:t>
             </a:r>
@@ -5907,8 +5771,6 @@
                   <a:srgbClr val="64707A"/>
                 </a:solidFill>
                 <a:latin typeface="Urbanist"/>
-                <a:ea typeface="Urbanist"/>
-                <a:cs typeface="Urbanist"/>
               </a:rPr>
               <a:t>One line under it saying what the page is for.</a:t>
             </a:r>
@@ -5974,8 +5836,6 @@
                   <a:srgbClr val="64707A"/>
                 </a:solidFill>
                 <a:latin typeface="League Spartan SemiBold"/>
-                <a:ea typeface="League Spartan SemiBold"/>
-                <a:cs typeface="League Spartan SemiBold"/>
               </a:rPr>
               <a:t>HOLDING</a:t>
             </a:r>
@@ -6011,8 +5871,6 @@
                   <a:srgbClr val="64707A"/>
                 </a:solidFill>
                 <a:latin typeface="Poppins SemiBold"/>
-                <a:ea typeface="Poppins SemiBold"/>
-                <a:cs typeface="Poppins SemiBold"/>
               </a:rPr>
               <a:t>Parent company name</a:t>
             </a:r>
@@ -6048,8 +5906,6 @@
                   <a:srgbClr val="64707A"/>
                 </a:solidFill>
                 <a:latin typeface="Urbanist"/>
-                <a:ea typeface="Urbanist"/>
-                <a:cs typeface="Urbanist"/>
               </a:rPr>
               <a:t>Incorporated 0000</a:t>
             </a:r>
@@ -6295,8 +6151,6 @@
                   <a:srgbClr val="64707A"/>
                 </a:solidFill>
                 <a:latin typeface="League Spartan SemiBold"/>
-                <a:ea typeface="League Spartan SemiBold"/>
-                <a:cs typeface="League Spartan SemiBold"/>
               </a:rPr>
               <a:t>COMPANY 00</a:t>
             </a:r>
@@ -6332,8 +6186,6 @@
                   <a:srgbClr val="64707A"/>
                 </a:solidFill>
                 <a:latin typeface="Poppins SemiBold"/>
-                <a:ea typeface="Poppins SemiBold"/>
-                <a:cs typeface="Poppins SemiBold"/>
               </a:rPr>
               <a:t>Business name</a:t>
             </a:r>
@@ -6399,8 +6251,6 @@
                   <a:srgbClr val="64707A"/>
                 </a:solidFill>
                 <a:latin typeface="Urbanist"/>
-                <a:ea typeface="Urbanist"/>
-                <a:cs typeface="Urbanist"/>
               </a:rPr>
               <a:t>What it does</a:t>
             </a:r>
@@ -6466,8 +6316,6 @@
                   <a:srgbClr val="64707A"/>
                 </a:solidFill>
                 <a:latin typeface="Urbanist"/>
-                <a:ea typeface="Urbanist"/>
-                <a:cs typeface="Urbanist"/>
               </a:rPr>
               <a:t>What it does</a:t>
             </a:r>
@@ -6533,8 +6381,6 @@
                   <a:srgbClr val="64707A"/>
                 </a:solidFill>
                 <a:latin typeface="Urbanist"/>
-                <a:ea typeface="Urbanist"/>
-                <a:cs typeface="Urbanist"/>
               </a:rPr>
               <a:t>Where it works</a:t>
             </a:r>
@@ -6600,8 +6446,6 @@
                   <a:srgbClr val="64707A"/>
                 </a:solidFill>
                 <a:latin typeface="League Spartan SemiBold"/>
-                <a:ea typeface="League Spartan SemiBold"/>
-                <a:cs typeface="League Spartan SemiBold"/>
               </a:rPr>
               <a:t>COMPANY 00</a:t>
             </a:r>
@@ -6637,8 +6481,6 @@
                   <a:srgbClr val="64707A"/>
                 </a:solidFill>
                 <a:latin typeface="Poppins SemiBold"/>
-                <a:ea typeface="Poppins SemiBold"/>
-                <a:cs typeface="Poppins SemiBold"/>
               </a:rPr>
               <a:t>Business name</a:t>
             </a:r>
@@ -6704,8 +6546,6 @@
                   <a:srgbClr val="64707A"/>
                 </a:solidFill>
                 <a:latin typeface="Urbanist"/>
-                <a:ea typeface="Urbanist"/>
-                <a:cs typeface="Urbanist"/>
               </a:rPr>
               <a:t>What it does</a:t>
             </a:r>
@@ -6771,8 +6611,6 @@
                   <a:srgbClr val="64707A"/>
                 </a:solidFill>
                 <a:latin typeface="Urbanist"/>
-                <a:ea typeface="Urbanist"/>
-                <a:cs typeface="Urbanist"/>
               </a:rPr>
               <a:t>What it does</a:t>
             </a:r>
@@ -6838,8 +6676,6 @@
                   <a:srgbClr val="64707A"/>
                 </a:solidFill>
                 <a:latin typeface="Urbanist"/>
-                <a:ea typeface="Urbanist"/>
-                <a:cs typeface="Urbanist"/>
               </a:rPr>
               <a:t>Where it works</a:t>
             </a:r>
@@ -6905,8 +6741,6 @@
                   <a:srgbClr val="64707A"/>
                 </a:solidFill>
                 <a:latin typeface="League Spartan SemiBold"/>
-                <a:ea typeface="League Spartan SemiBold"/>
-                <a:cs typeface="League Spartan SemiBold"/>
               </a:rPr>
               <a:t>COMPANY 00</a:t>
             </a:r>
@@ -6942,8 +6776,6 @@
                   <a:srgbClr val="64707A"/>
                 </a:solidFill>
                 <a:latin typeface="Poppins SemiBold"/>
-                <a:ea typeface="Poppins SemiBold"/>
-                <a:cs typeface="Poppins SemiBold"/>
               </a:rPr>
               <a:t>Business name</a:t>
             </a:r>
@@ -7009,8 +6841,6 @@
                   <a:srgbClr val="64707A"/>
                 </a:solidFill>
                 <a:latin typeface="Urbanist"/>
-                <a:ea typeface="Urbanist"/>
-                <a:cs typeface="Urbanist"/>
               </a:rPr>
               <a:t>What it does</a:t>
             </a:r>
@@ -7076,8 +6906,6 @@
                   <a:srgbClr val="64707A"/>
                 </a:solidFill>
                 <a:latin typeface="Urbanist"/>
-                <a:ea typeface="Urbanist"/>
-                <a:cs typeface="Urbanist"/>
               </a:rPr>
               <a:t>What it does</a:t>
             </a:r>
@@ -7143,8 +6971,6 @@
                   <a:srgbClr val="64707A"/>
                 </a:solidFill>
                 <a:latin typeface="Urbanist"/>
-                <a:ea typeface="Urbanist"/>
-                <a:cs typeface="Urbanist"/>
               </a:rPr>
               <a:t>Where it works</a:t>
             </a:r>
@@ -7210,8 +7036,6 @@
                   <a:srgbClr val="64707A"/>
                 </a:solidFill>
                 <a:latin typeface="League Spartan SemiBold"/>
-                <a:ea typeface="League Spartan SemiBold"/>
-                <a:cs typeface="League Spartan SemiBold"/>
               </a:rPr>
               <a:t>COMPANY 00</a:t>
             </a:r>
@@ -7247,8 +7071,6 @@
                   <a:srgbClr val="64707A"/>
                 </a:solidFill>
                 <a:latin typeface="Poppins SemiBold"/>
-                <a:ea typeface="Poppins SemiBold"/>
-                <a:cs typeface="Poppins SemiBold"/>
               </a:rPr>
               <a:t>Business name</a:t>
             </a:r>
@@ -7314,8 +7136,6 @@
                   <a:srgbClr val="64707A"/>
                 </a:solidFill>
                 <a:latin typeface="Urbanist"/>
-                <a:ea typeface="Urbanist"/>
-                <a:cs typeface="Urbanist"/>
               </a:rPr>
               <a:t>What it does</a:t>
             </a:r>
@@ -7381,8 +7201,6 @@
                   <a:srgbClr val="64707A"/>
                 </a:solidFill>
                 <a:latin typeface="Urbanist"/>
-                <a:ea typeface="Urbanist"/>
-                <a:cs typeface="Urbanist"/>
               </a:rPr>
               <a:t>What it does</a:t>
             </a:r>
@@ -7448,8 +7266,6 @@
                   <a:srgbClr val="64707A"/>
                 </a:solidFill>
                 <a:latin typeface="Urbanist"/>
-                <a:ea typeface="Urbanist"/>
-                <a:cs typeface="Urbanist"/>
               </a:rPr>
               <a:t>Where it works</a:t>
             </a:r>
@@ -7485,8 +7301,6 @@
                   <a:srgbClr val="64707A"/>
                 </a:solidFill>
                 <a:latin typeface="League Spartan Medium"/>
-                <a:ea typeface="League Spartan Medium"/>
-                <a:cs typeface="League Spartan Medium"/>
               </a:rPr>
               <a:t>09</a:t>
             </a:r>
@@ -7522,8 +7336,6 @@
                   <a:srgbClr val="64707A"/>
                 </a:solidFill>
                 <a:latin typeface="League Spartan"/>
-                <a:ea typeface="League Spartan"/>
-                <a:cs typeface="League Spartan"/>
               </a:rPr>
               <a:t>ORG CHART · GROUP STRUCTURE</a:t>
             </a:r>
@@ -7637,8 +7449,6 @@
                   <a:srgbClr val="FFFFFF"/>
                 </a:solidFill>
                 <a:latin typeface="League Spartan SemiBold"/>
-                <a:ea typeface="League Spartan SemiBold"/>
-                <a:cs typeface="League Spartan SemiBold"/>
               </a:rPr>
               <a:t>10</a:t>
             </a:r>
@@ -7674,8 +7484,6 @@
                   <a:srgbClr val="101A2B"/>
                 </a:solidFill>
                 <a:latin typeface="League Spartan SemiBold"/>
-                <a:ea typeface="League Spartan SemiBold"/>
-                <a:cs typeface="League Spartan SemiBold"/>
               </a:rPr>
               <a:t>SECTION NAME</a:t>
             </a:r>
@@ -7765,8 +7573,6 @@
                   <a:srgbClr val="64707A"/>
                 </a:solidFill>
                 <a:latin typeface="Poppins SemiBold"/>
-                <a:ea typeface="Poppins SemiBold"/>
-                <a:cs typeface="Poppins SemiBold"/>
               </a:rPr>
               <a:t>Page title</a:t>
             </a:r>
@@ -7802,8 +7608,6 @@
                   <a:srgbClr val="64707A"/>
                 </a:solidFill>
                 <a:latin typeface="Urbanist"/>
-                <a:ea typeface="Urbanist"/>
-                <a:cs typeface="Urbanist"/>
               </a:rPr>
               <a:t>One line under it saying what the page is for.</a:t>
             </a:r>
@@ -7899,8 +7703,6 @@
                   <a:srgbClr val="64707A"/>
                 </a:solidFill>
                 <a:latin typeface="League Spartan SemiBold"/>
-                <a:ea typeface="League Spartan SemiBold"/>
-                <a:cs typeface="League Spartan SemiBold"/>
               </a:rPr>
               <a:t>PROCESS NAME</a:t>
             </a:r>
@@ -7936,8 +7738,6 @@
                   <a:srgbClr val="64707A"/>
                 </a:solidFill>
                 <a:latin typeface="Urbanist"/>
-                <a:ea typeface="Urbanist"/>
-                <a:cs typeface="Urbanist"/>
               </a:rPr>
               <a:t>One sentence saying what the process is and where it starts.</a:t>
             </a:r>
@@ -8091,8 +7891,6 @@
                   <a:srgbClr val="FFFFFF"/>
                 </a:solidFill>
                 <a:latin typeface="League Spartan SemiBold"/>
-                <a:ea typeface="League Spartan SemiBold"/>
-                <a:cs typeface="League Spartan SemiBold"/>
               </a:rPr>
               <a:t>01</a:t>
             </a:r>
@@ -8128,8 +7926,6 @@
                   <a:srgbClr val="64707A"/>
                 </a:solidFill>
                 <a:latin typeface="Poppins SemiBold"/>
-                <a:ea typeface="Poppins SemiBold"/>
-                <a:cs typeface="Poppins SemiBold"/>
               </a:rPr>
               <a:t>Stage name</a:t>
             </a:r>
@@ -8165,8 +7961,6 @@
                   <a:srgbClr val="64707A"/>
                 </a:solidFill>
                 <a:latin typeface="Urbanist"/>
-                <a:ea typeface="Urbanist"/>
-                <a:cs typeface="Urbanist"/>
               </a:rPr>
               <a:t>Three or four words</a:t>
             </a:r>
@@ -8320,8 +8114,6 @@
                   <a:srgbClr val="FFFFFF"/>
                 </a:solidFill>
                 <a:latin typeface="League Spartan SemiBold"/>
-                <a:ea typeface="League Spartan SemiBold"/>
-                <a:cs typeface="League Spartan SemiBold"/>
               </a:rPr>
               <a:t>02</a:t>
             </a:r>
@@ -8357,8 +8149,6 @@
                   <a:srgbClr val="64707A"/>
                 </a:solidFill>
                 <a:latin typeface="Poppins SemiBold"/>
-                <a:ea typeface="Poppins SemiBold"/>
-                <a:cs typeface="Poppins SemiBold"/>
               </a:rPr>
               <a:t>Stage name</a:t>
             </a:r>
@@ -8394,8 +8184,6 @@
                   <a:srgbClr val="64707A"/>
                 </a:solidFill>
                 <a:latin typeface="Urbanist"/>
-                <a:ea typeface="Urbanist"/>
-                <a:cs typeface="Urbanist"/>
               </a:rPr>
               <a:t>Three or four words</a:t>
             </a:r>
@@ -8549,8 +8337,6 @@
                   <a:srgbClr val="FFFFFF"/>
                 </a:solidFill>
                 <a:latin typeface="League Spartan SemiBold"/>
-                <a:ea typeface="League Spartan SemiBold"/>
-                <a:cs typeface="League Spartan SemiBold"/>
               </a:rPr>
               <a:t>03</a:t>
             </a:r>
@@ -8586,8 +8372,6 @@
                   <a:srgbClr val="64707A"/>
                 </a:solidFill>
                 <a:latin typeface="Poppins SemiBold"/>
-                <a:ea typeface="Poppins SemiBold"/>
-                <a:cs typeface="Poppins SemiBold"/>
               </a:rPr>
               <a:t>Stage name</a:t>
             </a:r>
@@ -8623,8 +8407,6 @@
                   <a:srgbClr val="64707A"/>
                 </a:solidFill>
                 <a:latin typeface="Urbanist"/>
-                <a:ea typeface="Urbanist"/>
-                <a:cs typeface="Urbanist"/>
               </a:rPr>
               <a:t>Three or four words</a:t>
             </a:r>
@@ -8778,8 +8560,6 @@
                   <a:srgbClr val="FFFFFF"/>
                 </a:solidFill>
                 <a:latin typeface="League Spartan SemiBold"/>
-                <a:ea typeface="League Spartan SemiBold"/>
-                <a:cs typeface="League Spartan SemiBold"/>
               </a:rPr>
               <a:t>04</a:t>
             </a:r>
@@ -8815,8 +8595,6 @@
                   <a:srgbClr val="64707A"/>
                 </a:solidFill>
                 <a:latin typeface="Poppins SemiBold"/>
-                <a:ea typeface="Poppins SemiBold"/>
-                <a:cs typeface="Poppins SemiBold"/>
               </a:rPr>
               <a:t>Stage name</a:t>
             </a:r>
@@ -8852,8 +8630,6 @@
                   <a:srgbClr val="64707A"/>
                 </a:solidFill>
                 <a:latin typeface="Urbanist"/>
-                <a:ea typeface="Urbanist"/>
-                <a:cs typeface="Urbanist"/>
               </a:rPr>
               <a:t>Three or four words</a:t>
             </a:r>
@@ -8975,8 +8751,6 @@
                   <a:srgbClr val="FFFFFF"/>
                 </a:solidFill>
                 <a:latin typeface="League Spartan SemiBold"/>
-                <a:ea typeface="League Spartan SemiBold"/>
-                <a:cs typeface="League Spartan SemiBold"/>
               </a:rPr>
               <a:t>05</a:t>
             </a:r>
@@ -9012,8 +8786,6 @@
                   <a:srgbClr val="64707A"/>
                 </a:solidFill>
                 <a:latin typeface="Poppins SemiBold"/>
-                <a:ea typeface="Poppins SemiBold"/>
-                <a:cs typeface="Poppins SemiBold"/>
               </a:rPr>
               <a:t>Stage name</a:t>
             </a:r>
@@ -9049,8 +8821,6 @@
                   <a:srgbClr val="64707A"/>
                 </a:solidFill>
                 <a:latin typeface="Urbanist"/>
-                <a:ea typeface="Urbanist"/>
-                <a:cs typeface="Urbanist"/>
               </a:rPr>
               <a:t>Three or four words</a:t>
             </a:r>
@@ -9086,8 +8856,6 @@
                   <a:srgbClr val="64707A"/>
                 </a:solidFill>
                 <a:latin typeface="League Spartan Medium"/>
-                <a:ea typeface="League Spartan Medium"/>
-                <a:cs typeface="League Spartan Medium"/>
               </a:rPr>
               <a:t>10</a:t>
             </a:r>
@@ -9123,8 +8891,6 @@
                   <a:srgbClr val="64707A"/>
                 </a:solidFill>
                 <a:latin typeface="League Spartan"/>
-                <a:ea typeface="League Spartan"/>
-                <a:cs typeface="League Spartan"/>
               </a:rPr>
               <a:t>PROCESS</a:t>
             </a:r>
@@ -9238,8 +9004,6 @@
                   <a:srgbClr val="FFFFFF"/>
                 </a:solidFill>
                 <a:latin typeface="League Spartan SemiBold"/>
-                <a:ea typeface="League Spartan SemiBold"/>
-                <a:cs typeface="League Spartan SemiBold"/>
               </a:rPr>
               <a:t>11</a:t>
             </a:r>
@@ -9275,8 +9039,6 @@
                   <a:srgbClr val="101A2B"/>
                 </a:solidFill>
                 <a:latin typeface="League Spartan SemiBold"/>
-                <a:ea typeface="League Spartan SemiBold"/>
-                <a:cs typeface="League Spartan SemiBold"/>
               </a:rPr>
               <a:t>SECTION NAME</a:t>
             </a:r>
@@ -9366,8 +9128,6 @@
                   <a:srgbClr val="64707A"/>
                 </a:solidFill>
                 <a:latin typeface="Poppins SemiBold"/>
-                <a:ea typeface="Poppins SemiBold"/>
-                <a:cs typeface="Poppins SemiBold"/>
               </a:rPr>
               <a:t>Page title</a:t>
             </a:r>
@@ -9403,8 +9163,6 @@
                   <a:srgbClr val="64707A"/>
                 </a:solidFill>
                 <a:latin typeface="Urbanist"/>
-                <a:ea typeface="Urbanist"/>
-                <a:cs typeface="Urbanist"/>
               </a:rPr>
               <a:t>One line under it saying what the page is for.</a:t>
             </a:r>
@@ -9440,8 +9198,6 @@
                   <a:srgbClr val="64707A"/>
                 </a:solidFill>
                 <a:latin typeface="Poppins SemiBold"/>
-                <a:ea typeface="Poppins SemiBold"/>
-                <a:cs typeface="Poppins SemiBold"/>
               </a:rPr>
               <a:t>Event</a:t>
             </a:r>
@@ -9477,8 +9233,6 @@
                   <a:srgbClr val="64707A"/>
                 </a:solidFill>
                 <a:latin typeface="Urbanist"/>
-                <a:ea typeface="Urbanist"/>
-                <a:cs typeface="Urbanist"/>
               </a:rPr>
               <a:t>One line on what happened</a:t>
             </a:r>
@@ -9514,8 +9268,6 @@
                   <a:srgbClr val="64707A"/>
                 </a:solidFill>
                 <a:latin typeface="Poppins SemiBold"/>
-                <a:ea typeface="Poppins SemiBold"/>
-                <a:cs typeface="Poppins SemiBold"/>
               </a:rPr>
               <a:t>Event</a:t>
             </a:r>
@@ -9551,8 +9303,6 @@
                   <a:srgbClr val="64707A"/>
                 </a:solidFill>
                 <a:latin typeface="Urbanist"/>
-                <a:ea typeface="Urbanist"/>
-                <a:cs typeface="Urbanist"/>
               </a:rPr>
               <a:t>One line on what happened</a:t>
             </a:r>
@@ -9588,8 +9338,6 @@
                   <a:srgbClr val="64707A"/>
                 </a:solidFill>
                 <a:latin typeface="Poppins SemiBold"/>
-                <a:ea typeface="Poppins SemiBold"/>
-                <a:cs typeface="Poppins SemiBold"/>
               </a:rPr>
               <a:t>Event</a:t>
             </a:r>
@@ -9625,8 +9373,6 @@
                   <a:srgbClr val="64707A"/>
                 </a:solidFill>
                 <a:latin typeface="Urbanist"/>
-                <a:ea typeface="Urbanist"/>
-                <a:cs typeface="Urbanist"/>
               </a:rPr>
               <a:t>One line on what happened</a:t>
             </a:r>
@@ -9726,8 +9472,6 @@
                   <a:srgbClr val="64707A"/>
                 </a:solidFill>
                 <a:latin typeface="League Spartan SemiBold"/>
-                <a:ea typeface="League Spartan SemiBold"/>
-                <a:cs typeface="League Spartan SemiBold"/>
               </a:rPr>
               <a:t>0000</a:t>
             </a:r>
@@ -9795,8 +9539,6 @@
                   <a:srgbClr val="64707A"/>
                 </a:solidFill>
                 <a:latin typeface="League Spartan SemiBold"/>
-                <a:ea typeface="League Spartan SemiBold"/>
-                <a:cs typeface="League Spartan SemiBold"/>
               </a:rPr>
               <a:t>0000</a:t>
             </a:r>
@@ -9864,8 +9606,6 @@
                   <a:srgbClr val="64707A"/>
                 </a:solidFill>
                 <a:latin typeface="League Spartan SemiBold"/>
-                <a:ea typeface="League Spartan SemiBold"/>
-                <a:cs typeface="League Spartan SemiBold"/>
               </a:rPr>
               <a:t>0000</a:t>
             </a:r>
@@ -9933,8 +9673,6 @@
                   <a:srgbClr val="64707A"/>
                 </a:solidFill>
                 <a:latin typeface="League Spartan SemiBold"/>
-                <a:ea typeface="League Spartan SemiBold"/>
-                <a:cs typeface="League Spartan SemiBold"/>
               </a:rPr>
               <a:t>0000</a:t>
             </a:r>
@@ -10002,8 +9740,6 @@
                   <a:srgbClr val="64707A"/>
                 </a:solidFill>
                 <a:latin typeface="League Spartan SemiBold"/>
-                <a:ea typeface="League Spartan SemiBold"/>
-                <a:cs typeface="League Spartan SemiBold"/>
               </a:rPr>
               <a:t>0000</a:t>
             </a:r>
@@ -10039,8 +9775,6 @@
                   <a:srgbClr val="64707A"/>
                 </a:solidFill>
                 <a:latin typeface="Poppins SemiBold"/>
-                <a:ea typeface="Poppins SemiBold"/>
-                <a:cs typeface="Poppins SemiBold"/>
               </a:rPr>
               <a:t>Event</a:t>
             </a:r>
@@ -10076,8 +9810,6 @@
                   <a:srgbClr val="64707A"/>
                 </a:solidFill>
                 <a:latin typeface="Urbanist"/>
-                <a:ea typeface="Urbanist"/>
-                <a:cs typeface="Urbanist"/>
               </a:rPr>
               <a:t>One line on what happened</a:t>
             </a:r>
@@ -10113,8 +9845,6 @@
                   <a:srgbClr val="64707A"/>
                 </a:solidFill>
                 <a:latin typeface="Poppins SemiBold"/>
-                <a:ea typeface="Poppins SemiBold"/>
-                <a:cs typeface="Poppins SemiBold"/>
               </a:rPr>
               <a:t>Event</a:t>
             </a:r>
@@ -10150,8 +9880,6 @@
                   <a:srgbClr val="64707A"/>
                 </a:solidFill>
                 <a:latin typeface="Urbanist"/>
-                <a:ea typeface="Urbanist"/>
-                <a:cs typeface="Urbanist"/>
               </a:rPr>
               <a:t>One line on what happened</a:t>
             </a:r>
@@ -10187,8 +9915,6 @@
                   <a:srgbClr val="64707A"/>
                 </a:solidFill>
                 <a:latin typeface="League Spartan Medium"/>
-                <a:ea typeface="League Spartan Medium"/>
-                <a:cs typeface="League Spartan Medium"/>
               </a:rPr>
               <a:t>11</a:t>
             </a:r>
@@ -10224,8 +9950,6 @@
                   <a:srgbClr val="64707A"/>
                 </a:solidFill>
                 <a:latin typeface="League Spartan"/>
-                <a:ea typeface="League Spartan"/>
-                <a:cs typeface="League Spartan"/>
               </a:rPr>
               <a:t>TIMELINE</a:t>
             </a:r>
@@ -10339,8 +10063,6 @@
                   <a:srgbClr val="FFFFFF"/>
                 </a:solidFill>
                 <a:latin typeface="League Spartan SemiBold"/>
-                <a:ea typeface="League Spartan SemiBold"/>
-                <a:cs typeface="League Spartan SemiBold"/>
               </a:rPr>
               <a:t>12</a:t>
             </a:r>
@@ -10376,8 +10098,6 @@
                   <a:srgbClr val="101A2B"/>
                 </a:solidFill>
                 <a:latin typeface="League Spartan SemiBold"/>
-                <a:ea typeface="League Spartan SemiBold"/>
-                <a:cs typeface="League Spartan SemiBold"/>
               </a:rPr>
               <a:t>SECTION NAME</a:t>
             </a:r>
@@ -10467,8 +10187,6 @@
                   <a:srgbClr val="64707A"/>
                 </a:solidFill>
                 <a:latin typeface="Poppins SemiBold"/>
-                <a:ea typeface="Poppins SemiBold"/>
-                <a:cs typeface="Poppins SemiBold"/>
               </a:rPr>
               <a:t>Page title</a:t>
             </a:r>
@@ -10504,8 +10222,6 @@
                   <a:srgbClr val="64707A"/>
                 </a:solidFill>
                 <a:latin typeface="Urbanist"/>
-                <a:ea typeface="Urbanist"/>
-                <a:cs typeface="Urbanist"/>
               </a:rPr>
               <a:t>One line under it saying what the page is for.</a:t>
             </a:r>
@@ -10627,8 +10343,6 @@
                   <a:srgbClr val="64707A"/>
                 </a:solidFill>
                 <a:latin typeface="League Spartan SemiBold"/>
-                <a:ea typeface="League Spartan SemiBold"/>
-                <a:cs typeface="League Spartan SemiBold"/>
               </a:rPr>
               <a:t>01</a:t>
             </a:r>
@@ -10664,8 +10378,6 @@
                   <a:srgbClr val="64707A"/>
                 </a:solidFill>
                 <a:latin typeface="Poppins SemiBold"/>
-                <a:ea typeface="Poppins SemiBold"/>
-                <a:cs typeface="Poppins SemiBold"/>
               </a:rPr>
               <a:t>Part name</a:t>
             </a:r>
@@ -10701,8 +10413,6 @@
                   <a:srgbClr val="64707A"/>
                 </a:solidFill>
                 <a:latin typeface="Urbanist"/>
-                <a:ea typeface="Urbanist"/>
-                <a:cs typeface="Urbanist"/>
               </a:rPr>
               <a:t>What it covers, four words</a:t>
             </a:r>
@@ -10824,8 +10534,6 @@
                   <a:srgbClr val="64707A"/>
                 </a:solidFill>
                 <a:latin typeface="League Spartan SemiBold"/>
-                <a:ea typeface="League Spartan SemiBold"/>
-                <a:cs typeface="League Spartan SemiBold"/>
               </a:rPr>
               <a:t>02</a:t>
             </a:r>
@@ -10861,8 +10569,6 @@
                   <a:srgbClr val="64707A"/>
                 </a:solidFill>
                 <a:latin typeface="Poppins SemiBold"/>
-                <a:ea typeface="Poppins SemiBold"/>
-                <a:cs typeface="Poppins SemiBold"/>
               </a:rPr>
               <a:t>Part name</a:t>
             </a:r>
@@ -10898,8 +10604,6 @@
                   <a:srgbClr val="64707A"/>
                 </a:solidFill>
                 <a:latin typeface="Urbanist"/>
-                <a:ea typeface="Urbanist"/>
-                <a:cs typeface="Urbanist"/>
               </a:rPr>
               <a:t>What it covers, four words</a:t>
             </a:r>
@@ -11021,8 +10725,6 @@
                   <a:srgbClr val="64707A"/>
                 </a:solidFill>
                 <a:latin typeface="League Spartan SemiBold"/>
-                <a:ea typeface="League Spartan SemiBold"/>
-                <a:cs typeface="League Spartan SemiBold"/>
               </a:rPr>
               <a:t>03</a:t>
             </a:r>
@@ -11058,8 +10760,6 @@
                   <a:srgbClr val="64707A"/>
                 </a:solidFill>
                 <a:latin typeface="Poppins SemiBold"/>
-                <a:ea typeface="Poppins SemiBold"/>
-                <a:cs typeface="Poppins SemiBold"/>
               </a:rPr>
               <a:t>Part name</a:t>
             </a:r>
@@ -11095,8 +10795,6 @@
                   <a:srgbClr val="64707A"/>
                 </a:solidFill>
                 <a:latin typeface="Urbanist"/>
-                <a:ea typeface="Urbanist"/>
-                <a:cs typeface="Urbanist"/>
               </a:rPr>
               <a:t>What it covers, four words</a:t>
             </a:r>
@@ -11162,8 +10860,6 @@
                   <a:srgbClr val="64707A"/>
                 </a:solidFill>
                 <a:latin typeface="League Spartan SemiBold"/>
-                <a:ea typeface="League Spartan SemiBold"/>
-                <a:cs typeface="League Spartan SemiBold"/>
               </a:rPr>
               <a:t>CAPTION OVER THE VISUAL</a:t>
             </a:r>
@@ -11223,8 +10919,6 @@
                   <a:srgbClr val="64707A"/>
                 </a:solidFill>
                 <a:latin typeface="Urbanist"/>
-                <a:ea typeface="Urbanist"/>
-                <a:cs typeface="Urbanist"/>
               </a:rPr>
               <a:t>One sentence under the visual saying what the whole thing adds up to.</a:t>
             </a:r>
@@ -11346,8 +11040,6 @@
                   <a:srgbClr val="64707A"/>
                 </a:solidFill>
                 <a:latin typeface="League Spartan SemiBold"/>
-                <a:ea typeface="League Spartan SemiBold"/>
-                <a:cs typeface="League Spartan SemiBold"/>
               </a:rPr>
               <a:t>04</a:t>
             </a:r>
@@ -11383,8 +11075,6 @@
                   <a:srgbClr val="64707A"/>
                 </a:solidFill>
                 <a:latin typeface="Poppins SemiBold"/>
-                <a:ea typeface="Poppins SemiBold"/>
-                <a:cs typeface="Poppins SemiBold"/>
               </a:rPr>
               <a:t>Part name</a:t>
             </a:r>
@@ -11420,8 +11110,6 @@
                   <a:srgbClr val="64707A"/>
                 </a:solidFill>
                 <a:latin typeface="Urbanist"/>
-                <a:ea typeface="Urbanist"/>
-                <a:cs typeface="Urbanist"/>
               </a:rPr>
               <a:t>What it covers, four words</a:t>
             </a:r>
@@ -11543,8 +11231,6 @@
                   <a:srgbClr val="64707A"/>
                 </a:solidFill>
                 <a:latin typeface="League Spartan SemiBold"/>
-                <a:ea typeface="League Spartan SemiBold"/>
-                <a:cs typeface="League Spartan SemiBold"/>
               </a:rPr>
               <a:t>05</a:t>
             </a:r>
@@ -11580,8 +11266,6 @@
                   <a:srgbClr val="64707A"/>
                 </a:solidFill>
                 <a:latin typeface="Poppins SemiBold"/>
-                <a:ea typeface="Poppins SemiBold"/>
-                <a:cs typeface="Poppins SemiBold"/>
               </a:rPr>
               <a:t>Part name</a:t>
             </a:r>
@@ -11617,8 +11301,6 @@
                   <a:srgbClr val="64707A"/>
                 </a:solidFill>
                 <a:latin typeface="Urbanist"/>
-                <a:ea typeface="Urbanist"/>
-                <a:cs typeface="Urbanist"/>
               </a:rPr>
               <a:t>What it covers, four words</a:t>
             </a:r>
@@ -11740,8 +11422,6 @@
                   <a:srgbClr val="64707A"/>
                 </a:solidFill>
                 <a:latin typeface="League Spartan SemiBold"/>
-                <a:ea typeface="League Spartan SemiBold"/>
-                <a:cs typeface="League Spartan SemiBold"/>
               </a:rPr>
               <a:t>06</a:t>
             </a:r>
@@ -11777,8 +11457,6 @@
                   <a:srgbClr val="64707A"/>
                 </a:solidFill>
                 <a:latin typeface="Poppins SemiBold"/>
-                <a:ea typeface="Poppins SemiBold"/>
-                <a:cs typeface="Poppins SemiBold"/>
               </a:rPr>
               <a:t>Part name</a:t>
             </a:r>
@@ -11814,8 +11492,6 @@
                   <a:srgbClr val="64707A"/>
                 </a:solidFill>
                 <a:latin typeface="Urbanist"/>
-                <a:ea typeface="Urbanist"/>
-                <a:cs typeface="Urbanist"/>
               </a:rPr>
               <a:t>What it covers, four words</a:t>
             </a:r>
@@ -11851,8 +11527,6 @@
                   <a:srgbClr val="64707A"/>
                 </a:solidFill>
                 <a:latin typeface="League Spartan Medium"/>
-                <a:ea typeface="League Spartan Medium"/>
-                <a:cs typeface="League Spartan Medium"/>
               </a:rPr>
               <a:t>12</a:t>
             </a:r>
@@ -11888,8 +11562,6 @@
                   <a:srgbClr val="64707A"/>
                 </a:solidFill>
                 <a:latin typeface="League Spartan"/>
-                <a:ea typeface="League Spartan"/>
-                <a:cs typeface="League Spartan"/>
               </a:rPr>
               <a:t>INFOGRAPHIC</a:t>
             </a:r>
@@ -12003,8 +11675,6 @@
                   <a:srgbClr val="FFFFFF"/>
                 </a:solidFill>
                 <a:latin typeface="League Spartan SemiBold"/>
-                <a:ea typeface="League Spartan SemiBold"/>
-                <a:cs typeface="League Spartan SemiBold"/>
               </a:rPr>
               <a:t>13</a:t>
             </a:r>
@@ -12040,8 +11710,6 @@
                   <a:srgbClr val="101A2B"/>
                 </a:solidFill>
                 <a:latin typeface="League Spartan SemiBold"/>
-                <a:ea typeface="League Spartan SemiBold"/>
-                <a:cs typeface="League Spartan SemiBold"/>
               </a:rPr>
               <a:t>SECTION NAME</a:t>
             </a:r>
@@ -12131,8 +11799,6 @@
                   <a:srgbClr val="64707A"/>
                 </a:solidFill>
                 <a:latin typeface="Poppins SemiBold"/>
-                <a:ea typeface="Poppins SemiBold"/>
-                <a:cs typeface="Poppins SemiBold"/>
               </a:rPr>
               <a:t>Page title</a:t>
             </a:r>
@@ -12168,8 +11834,6 @@
                   <a:srgbClr val="64707A"/>
                 </a:solidFill>
                 <a:latin typeface="Urbanist"/>
-                <a:ea typeface="Urbanist"/>
-                <a:cs typeface="Urbanist"/>
               </a:rPr>
               <a:t>One line under it saying what the page is for.</a:t>
             </a:r>
@@ -12260,8 +11924,6 @@
                   <a:srgbClr val="64707A"/>
                 </a:solidFill>
                 <a:latin typeface="League Spartan SemiBold"/>
-                <a:ea typeface="League Spartan SemiBold"/>
-                <a:cs typeface="League Spartan SemiBold"/>
               </a:rPr>
               <a:t>LOCATION · WHAT KIND OF FACILITY</a:t>
             </a:r>
@@ -12297,8 +11959,6 @@
                   <a:srgbClr val="64707A"/>
                 </a:solidFill>
                 <a:latin typeface="Poppins SemiBold"/>
-                <a:ea typeface="Poppins SemiBold"/>
-                <a:cs typeface="Poppins SemiBold"/>
               </a:rPr>
               <a:t>Project or product name</a:t>
             </a:r>
@@ -12364,8 +12024,6 @@
                   <a:srgbClr val="64707A"/>
                 </a:solidFill>
                 <a:latin typeface="League Spartan SemiBold"/>
-                <a:ea typeface="League Spartan SemiBold"/>
-                <a:cs typeface="League Spartan SemiBold"/>
               </a:rPr>
               <a:t>SERVICE LINE</a:t>
             </a:r>
@@ -12431,8 +12089,6 @@
                   <a:srgbClr val="64707A"/>
                 </a:solidFill>
                 <a:latin typeface="League Spartan SemiBold"/>
-                <a:ea typeface="League Spartan SemiBold"/>
-                <a:cs typeface="League Spartan SemiBold"/>
               </a:rPr>
               <a:t>SERVICE LINE</a:t>
             </a:r>
@@ -12498,8 +12154,6 @@
                   <a:srgbClr val="64707A"/>
                 </a:solidFill>
                 <a:latin typeface="League Spartan SemiBold"/>
-                <a:ea typeface="League Spartan SemiBold"/>
-                <a:cs typeface="League Spartan SemiBold"/>
               </a:rPr>
               <a:t>SERVICE LINE</a:t>
             </a:r>
@@ -12535,8 +12189,6 @@
                   <a:srgbClr val="64707A"/>
                 </a:solidFill>
                 <a:latin typeface="League Spartan SemiBold"/>
-                <a:ea typeface="League Spartan SemiBold"/>
-                <a:cs typeface="League Spartan SemiBold"/>
               </a:rPr>
               <a:t>DESCRIPTION</a:t>
             </a:r>
@@ -12572,8 +12224,6 @@
                   <a:srgbClr val="64707A"/>
                 </a:solidFill>
                 <a:latin typeface="Urbanist"/>
-                <a:ea typeface="Urbanist"/>
-                <a:cs typeface="Urbanist"/>
               </a:rPr>
               <a:t>One sentence on what the job was</a:t>
             </a:r>
@@ -12609,8 +12259,6 @@
                   <a:srgbClr val="64707A"/>
                 </a:solidFill>
                 <a:latin typeface="League Spartan SemiBold"/>
-                <a:ea typeface="League Spartan SemiBold"/>
-                <a:cs typeface="League Spartan SemiBold"/>
               </a:rPr>
               <a:t>SCOPE</a:t>
             </a:r>
@@ -12646,8 +12294,6 @@
                   <a:srgbClr val="64707A"/>
                 </a:solidFill>
                 <a:latin typeface="Urbanist"/>
-                <a:ea typeface="Urbanist"/>
-                <a:cs typeface="Urbanist"/>
               </a:rPr>
               <a:t>What was in the contract</a:t>
             </a:r>
@@ -12683,8 +12329,6 @@
                   <a:srgbClr val="64707A"/>
                 </a:solidFill>
                 <a:latin typeface="League Spartan SemiBold"/>
-                <a:ea typeface="League Spartan SemiBold"/>
-                <a:cs typeface="League Spartan SemiBold"/>
               </a:rPr>
               <a:t>CLEANROOM</a:t>
             </a:r>
@@ -12720,8 +12364,6 @@
                   <a:srgbClr val="64707A"/>
                 </a:solidFill>
                 <a:latin typeface="Urbanist"/>
-                <a:ea typeface="Urbanist"/>
-                <a:cs typeface="Urbanist"/>
               </a:rPr>
               <a:t>Class or grade, if it applies</a:t>
             </a:r>
@@ -12757,8 +12399,6 @@
                   <a:srgbClr val="64707A"/>
                 </a:solidFill>
                 <a:latin typeface="League Spartan SemiBold"/>
-                <a:ea typeface="League Spartan SemiBold"/>
-                <a:cs typeface="League Spartan SemiBold"/>
               </a:rPr>
               <a:t>COMPLETED</a:t>
             </a:r>
@@ -12794,8 +12434,6 @@
                   <a:srgbClr val="64707A"/>
                 </a:solidFill>
                 <a:latin typeface="Urbanist"/>
-                <a:ea typeface="Urbanist"/>
-                <a:cs typeface="Urbanist"/>
               </a:rPr>
               <a:t>Year</a:t>
             </a:r>
@@ -12831,8 +12469,6 @@
                   <a:srgbClr val="64707A"/>
                 </a:solidFill>
                 <a:latin typeface="League Spartan Medium"/>
-                <a:ea typeface="League Spartan Medium"/>
-                <a:cs typeface="League Spartan Medium"/>
               </a:rPr>
               <a:t>13</a:t>
             </a:r>
@@ -12868,8 +12504,6 @@
                   <a:srgbClr val="64707A"/>
                 </a:solidFill>
                 <a:latin typeface="League Spartan"/>
-                <a:ea typeface="League Spartan"/>
-                <a:cs typeface="League Spartan"/>
               </a:rPr>
               <a:t>IMAGE AND SPECS</a:t>
             </a:r>
@@ -12983,8 +12617,6 @@
                   <a:srgbClr val="FFFFFF"/>
                 </a:solidFill>
                 <a:latin typeface="League Spartan SemiBold"/>
-                <a:ea typeface="League Spartan SemiBold"/>
-                <a:cs typeface="League Spartan SemiBold"/>
               </a:rPr>
               <a:t>14</a:t>
             </a:r>
@@ -13020,8 +12652,6 @@
                   <a:srgbClr val="101A2B"/>
                 </a:solidFill>
                 <a:latin typeface="League Spartan SemiBold"/>
-                <a:ea typeface="League Spartan SemiBold"/>
-                <a:cs typeface="League Spartan SemiBold"/>
               </a:rPr>
               <a:t>SECTION NAME</a:t>
             </a:r>
@@ -13111,8 +12741,6 @@
                   <a:srgbClr val="64707A"/>
                 </a:solidFill>
                 <a:latin typeface="Poppins SemiBold"/>
-                <a:ea typeface="Poppins SemiBold"/>
-                <a:cs typeface="Poppins SemiBold"/>
               </a:rPr>
               <a:t>Page title</a:t>
             </a:r>
@@ -13148,8 +12776,6 @@
                   <a:srgbClr val="64707A"/>
                 </a:solidFill>
                 <a:latin typeface="Urbanist"/>
-                <a:ea typeface="Urbanist"/>
-                <a:cs typeface="Urbanist"/>
               </a:rPr>
               <a:t>One line under it saying what the page is for.</a:t>
             </a:r>
@@ -13185,8 +12811,6 @@
                   <a:srgbClr val="64707A"/>
                 </a:solidFill>
                 <a:latin typeface="League Spartan SemiBold"/>
-                <a:ea typeface="League Spartan SemiBold"/>
-                <a:cs typeface="League Spartan SemiBold"/>
               </a:rPr>
               <a:t>PERIOD</a:t>
             </a:r>
@@ -13222,8 +12846,6 @@
                   <a:srgbClr val="64707A"/>
                 </a:solidFill>
                 <a:latin typeface="League Spartan SemiBold"/>
-                <a:ea typeface="League Spartan SemiBold"/>
-                <a:cs typeface="League Spartan SemiBold"/>
               </a:rPr>
               <a:t>PERIOD</a:t>
             </a:r>
@@ -13259,8 +12881,6 @@
                   <a:srgbClr val="64707A"/>
                 </a:solidFill>
                 <a:latin typeface="League Spartan SemiBold"/>
-                <a:ea typeface="League Spartan SemiBold"/>
-                <a:cs typeface="League Spartan SemiBold"/>
               </a:rPr>
               <a:t>PERIOD</a:t>
             </a:r>
@@ -13296,8 +12916,6 @@
                   <a:srgbClr val="64707A"/>
                 </a:solidFill>
                 <a:latin typeface="League Spartan SemiBold"/>
-                <a:ea typeface="League Spartan SemiBold"/>
-                <a:cs typeface="League Spartan SemiBold"/>
               </a:rPr>
               <a:t>PERIOD</a:t>
             </a:r>
@@ -13333,8 +12951,6 @@
                   <a:srgbClr val="64707A"/>
                 </a:solidFill>
                 <a:latin typeface="League Spartan SemiBold"/>
-                <a:ea typeface="League Spartan SemiBold"/>
-                <a:cs typeface="League Spartan SemiBold"/>
               </a:rPr>
               <a:t>PERIOD</a:t>
             </a:r>
@@ -13370,8 +12986,6 @@
                   <a:srgbClr val="64707A"/>
                 </a:solidFill>
                 <a:latin typeface="League Spartan SemiBold"/>
-                <a:ea typeface="League Spartan SemiBold"/>
-                <a:cs typeface="League Spartan SemiBold"/>
               </a:rPr>
               <a:t>PERIOD</a:t>
             </a:r>
@@ -13407,8 +13021,6 @@
                   <a:srgbClr val="101A2B"/>
                 </a:solidFill>
                 <a:latin typeface="Urbanist SemiBold"/>
-                <a:ea typeface="Urbanist SemiBold"/>
-                <a:cs typeface="Urbanist SemiBold"/>
               </a:rPr>
               <a:t>Work package</a:t>
             </a:r>
@@ -13444,8 +13056,6 @@
                   <a:srgbClr val="64707A"/>
                 </a:solidFill>
                 <a:latin typeface="Urbanist"/>
-                <a:ea typeface="Urbanist"/>
-                <a:cs typeface="Urbanist"/>
               </a:rPr>
               <a:t>What is in it</a:t>
             </a:r>
@@ -13541,8 +13151,6 @@
                   <a:srgbClr val="FFFFFF"/>
                 </a:solidFill>
                 <a:latin typeface="League Spartan SemiBold"/>
-                <a:ea typeface="League Spartan SemiBold"/>
-                <a:cs typeface="League Spartan SemiBold"/>
               </a:rPr>
               <a:t>Milestone</a:t>
             </a:r>
@@ -13578,8 +13186,6 @@
                   <a:srgbClr val="101A2B"/>
                 </a:solidFill>
                 <a:latin typeface="Urbanist SemiBold"/>
-                <a:ea typeface="Urbanist SemiBold"/>
-                <a:cs typeface="Urbanist SemiBold"/>
               </a:rPr>
               <a:t>Work package</a:t>
             </a:r>
@@ -13615,8 +13221,6 @@
                   <a:srgbClr val="64707A"/>
                 </a:solidFill>
                 <a:latin typeface="Urbanist"/>
-                <a:ea typeface="Urbanist"/>
-                <a:cs typeface="Urbanist"/>
               </a:rPr>
               <a:t>What is in it</a:t>
             </a:r>
@@ -13714,8 +13318,6 @@
                   <a:srgbClr val="101A2B"/>
                 </a:solidFill>
                 <a:latin typeface="Urbanist SemiBold"/>
-                <a:ea typeface="Urbanist SemiBold"/>
-                <a:cs typeface="Urbanist SemiBold"/>
               </a:rPr>
               <a:t>Work package</a:t>
             </a:r>
@@ -13751,8 +13353,6 @@
                   <a:srgbClr val="64707A"/>
                 </a:solidFill>
                 <a:latin typeface="Urbanist"/>
-                <a:ea typeface="Urbanist"/>
-                <a:cs typeface="Urbanist"/>
               </a:rPr>
               <a:t>What is in it</a:t>
             </a:r>
@@ -13848,8 +13448,6 @@
                   <a:srgbClr val="101A2B"/>
                 </a:solidFill>
                 <a:latin typeface="Urbanist SemiBold"/>
-                <a:ea typeface="Urbanist SemiBold"/>
-                <a:cs typeface="Urbanist SemiBold"/>
               </a:rPr>
               <a:t>Work package</a:t>
             </a:r>
@@ -13885,8 +13483,6 @@
                   <a:srgbClr val="64707A"/>
                 </a:solidFill>
                 <a:latin typeface="Urbanist"/>
-                <a:ea typeface="Urbanist"/>
-                <a:cs typeface="Urbanist"/>
               </a:rPr>
               <a:t>What is in it</a:t>
             </a:r>
@@ -13982,8 +13578,6 @@
                   <a:srgbClr val="101A2B"/>
                 </a:solidFill>
                 <a:latin typeface="Urbanist SemiBold"/>
-                <a:ea typeface="Urbanist SemiBold"/>
-                <a:cs typeface="Urbanist SemiBold"/>
               </a:rPr>
               <a:t>Work package</a:t>
             </a:r>
@@ -14019,8 +13613,6 @@
                   <a:srgbClr val="64707A"/>
                 </a:solidFill>
                 <a:latin typeface="Urbanist"/>
-                <a:ea typeface="Urbanist"/>
-                <a:cs typeface="Urbanist"/>
               </a:rPr>
               <a:t>What is in it</a:t>
             </a:r>
@@ -14116,8 +13708,6 @@
                   <a:srgbClr val="101A2B"/>
                 </a:solidFill>
                 <a:latin typeface="Urbanist SemiBold"/>
-                <a:ea typeface="Urbanist SemiBold"/>
-                <a:cs typeface="Urbanist SemiBold"/>
               </a:rPr>
               <a:t>Work package</a:t>
             </a:r>
@@ -14153,8 +13743,6 @@
                   <a:srgbClr val="64707A"/>
                 </a:solidFill>
                 <a:latin typeface="Urbanist"/>
-                <a:ea typeface="Urbanist"/>
-                <a:cs typeface="Urbanist"/>
               </a:rPr>
               <a:t>What is in it</a:t>
             </a:r>
@@ -14250,8 +13838,6 @@
                   <a:srgbClr val="FFFFFF"/>
                 </a:solidFill>
                 <a:latin typeface="League Spartan SemiBold"/>
-                <a:ea typeface="League Spartan SemiBold"/>
-                <a:cs typeface="League Spartan SemiBold"/>
               </a:rPr>
               <a:t>Milestone</a:t>
             </a:r>
@@ -14287,8 +13873,6 @@
                   <a:srgbClr val="64707A"/>
                 </a:solidFill>
                 <a:latin typeface="League Spartan Medium"/>
-                <a:ea typeface="League Spartan Medium"/>
-                <a:cs typeface="League Spartan Medium"/>
               </a:rPr>
               <a:t>14</a:t>
             </a:r>
@@ -14324,8 +13908,6 @@
                   <a:srgbClr val="64707A"/>
                 </a:solidFill>
                 <a:latin typeface="League Spartan"/>
-                <a:ea typeface="League Spartan"/>
-                <a:cs typeface="League Spartan"/>
               </a:rPr>
               <a:t>PROGRAMME</a:t>
             </a:r>
@@ -14439,8 +14021,6 @@
                   <a:srgbClr val="FFFFFF"/>
                 </a:solidFill>
                 <a:latin typeface="League Spartan SemiBold"/>
-                <a:ea typeface="League Spartan SemiBold"/>
-                <a:cs typeface="League Spartan SemiBold"/>
               </a:rPr>
               <a:t>15</a:t>
             </a:r>
@@ -14476,8 +14056,6 @@
                   <a:srgbClr val="101A2B"/>
                 </a:solidFill>
                 <a:latin typeface="League Spartan SemiBold"/>
-                <a:ea typeface="League Spartan SemiBold"/>
-                <a:cs typeface="League Spartan SemiBold"/>
               </a:rPr>
               <a:t>SECTION NAME</a:t>
             </a:r>
@@ -14567,8 +14145,6 @@
                   <a:srgbClr val="64707A"/>
                 </a:solidFill>
                 <a:latin typeface="Poppins SemiBold"/>
-                <a:ea typeface="Poppins SemiBold"/>
-                <a:cs typeface="Poppins SemiBold"/>
               </a:rPr>
               <a:t>Page title</a:t>
             </a:r>
@@ -14604,8 +14180,6 @@
                   <a:srgbClr val="64707A"/>
                 </a:solidFill>
                 <a:latin typeface="Urbanist"/>
-                <a:ea typeface="Urbanist"/>
-                <a:cs typeface="Urbanist"/>
               </a:rPr>
               <a:t>One line under it saying what the page is for.</a:t>
             </a:r>
@@ -14671,8 +14245,6 @@
                   <a:srgbClr val="FFFFFF"/>
                 </a:solidFill>
                 <a:latin typeface="League Spartan SemiBold"/>
-                <a:ea typeface="League Spartan SemiBold"/>
-                <a:cs typeface="League Spartan SemiBold"/>
               </a:rPr>
               <a:t>COLUMN</a:t>
             </a:r>
@@ -14738,8 +14310,6 @@
                   <a:srgbClr val="FFFFFF"/>
                 </a:solidFill>
                 <a:latin typeface="League Spartan SemiBold"/>
-                <a:ea typeface="League Spartan SemiBold"/>
-                <a:cs typeface="League Spartan SemiBold"/>
               </a:rPr>
               <a:t>COLUMN</a:t>
             </a:r>
@@ -14805,8 +14375,6 @@
                   <a:srgbClr val="FFFFFF"/>
                 </a:solidFill>
                 <a:latin typeface="League Spartan SemiBold"/>
-                <a:ea typeface="League Spartan SemiBold"/>
-                <a:cs typeface="League Spartan SemiBold"/>
               </a:rPr>
               <a:t>COLUMN</a:t>
             </a:r>
@@ -14872,8 +14440,6 @@
                   <a:srgbClr val="FFFFFF"/>
                 </a:solidFill>
                 <a:latin typeface="League Spartan SemiBold"/>
-                <a:ea typeface="League Spartan SemiBold"/>
-                <a:cs typeface="League Spartan SemiBold"/>
               </a:rPr>
               <a:t>COLUMN</a:t>
             </a:r>
@@ -14939,8 +14505,6 @@
                   <a:srgbClr val="FFFFFF"/>
                 </a:solidFill>
                 <a:latin typeface="League Spartan SemiBold"/>
-                <a:ea typeface="League Spartan SemiBold"/>
-                <a:cs typeface="League Spartan SemiBold"/>
               </a:rPr>
               <a:t>COLUMN</a:t>
             </a:r>
@@ -15006,8 +14570,6 @@
                   <a:srgbClr val="64707A"/>
                 </a:solidFill>
                 <a:latin typeface="Urbanist SemiBold"/>
-                <a:ea typeface="Urbanist SemiBold"/>
-                <a:cs typeface="Urbanist SemiBold"/>
               </a:rPr>
               <a:t>Row label</a:t>
             </a:r>
@@ -15073,8 +14635,6 @@
                   <a:srgbClr val="64707A"/>
                 </a:solidFill>
                 <a:latin typeface="Urbanist"/>
-                <a:ea typeface="Urbanist"/>
-                <a:cs typeface="Urbanist"/>
               </a:rPr>
               <a:t>Value</a:t>
             </a:r>
@@ -15140,8 +14700,6 @@
                   <a:srgbClr val="64707A"/>
                 </a:solidFill>
                 <a:latin typeface="Urbanist"/>
-                <a:ea typeface="Urbanist"/>
-                <a:cs typeface="Urbanist"/>
               </a:rPr>
               <a:t>Value</a:t>
             </a:r>
@@ -15207,8 +14765,6 @@
                   <a:srgbClr val="64707A"/>
                 </a:solidFill>
                 <a:latin typeface="Urbanist"/>
-                <a:ea typeface="Urbanist"/>
-                <a:cs typeface="Urbanist"/>
               </a:rPr>
               <a:t>Value</a:t>
             </a:r>
@@ -15274,8 +14830,6 @@
                   <a:srgbClr val="64707A"/>
                 </a:solidFill>
                 <a:latin typeface="Urbanist SemiBold"/>
-                <a:ea typeface="Urbanist SemiBold"/>
-                <a:cs typeface="Urbanist SemiBold"/>
               </a:rPr>
               <a:t>Called out</a:t>
             </a:r>
@@ -15341,8 +14895,6 @@
                   <a:srgbClr val="64707A"/>
                 </a:solidFill>
                 <a:latin typeface="Urbanist SemiBold"/>
-                <a:ea typeface="Urbanist SemiBold"/>
-                <a:cs typeface="Urbanist SemiBold"/>
               </a:rPr>
               <a:t>Row label</a:t>
             </a:r>
@@ -15408,8 +14960,6 @@
                   <a:srgbClr val="64707A"/>
                 </a:solidFill>
                 <a:latin typeface="Urbanist"/>
-                <a:ea typeface="Urbanist"/>
-                <a:cs typeface="Urbanist"/>
               </a:rPr>
               <a:t>Value</a:t>
             </a:r>
@@ -15475,8 +15025,6 @@
                   <a:srgbClr val="64707A"/>
                 </a:solidFill>
                 <a:latin typeface="Urbanist"/>
-                <a:ea typeface="Urbanist"/>
-                <a:cs typeface="Urbanist"/>
               </a:rPr>
               <a:t>Value</a:t>
             </a:r>
@@ -15542,8 +15090,6 @@
                   <a:srgbClr val="64707A"/>
                 </a:solidFill>
                 <a:latin typeface="Urbanist"/>
-                <a:ea typeface="Urbanist"/>
-                <a:cs typeface="Urbanist"/>
               </a:rPr>
               <a:t>Value</a:t>
             </a:r>
@@ -15609,8 +15155,6 @@
                   <a:srgbClr val="64707A"/>
                 </a:solidFill>
                 <a:latin typeface="Urbanist SemiBold"/>
-                <a:ea typeface="Urbanist SemiBold"/>
-                <a:cs typeface="Urbanist SemiBold"/>
               </a:rPr>
               <a:t>Called out</a:t>
             </a:r>
@@ -15676,8 +15220,6 @@
                   <a:srgbClr val="64707A"/>
                 </a:solidFill>
                 <a:latin typeface="Urbanist SemiBold"/>
-                <a:ea typeface="Urbanist SemiBold"/>
-                <a:cs typeface="Urbanist SemiBold"/>
               </a:rPr>
               <a:t>Row label</a:t>
             </a:r>
@@ -15743,8 +15285,6 @@
                   <a:srgbClr val="64707A"/>
                 </a:solidFill>
                 <a:latin typeface="Urbanist"/>
-                <a:ea typeface="Urbanist"/>
-                <a:cs typeface="Urbanist"/>
               </a:rPr>
               <a:t>Value</a:t>
             </a:r>
@@ -15810,8 +15350,6 @@
                   <a:srgbClr val="64707A"/>
                 </a:solidFill>
                 <a:latin typeface="Urbanist"/>
-                <a:ea typeface="Urbanist"/>
-                <a:cs typeface="Urbanist"/>
               </a:rPr>
               <a:t>Value</a:t>
             </a:r>
@@ -15877,8 +15415,6 @@
                   <a:srgbClr val="64707A"/>
                 </a:solidFill>
                 <a:latin typeface="Urbanist"/>
-                <a:ea typeface="Urbanist"/>
-                <a:cs typeface="Urbanist"/>
               </a:rPr>
               <a:t>Value</a:t>
             </a:r>
@@ -15944,8 +15480,6 @@
                   <a:srgbClr val="64707A"/>
                 </a:solidFill>
                 <a:latin typeface="Urbanist SemiBold"/>
-                <a:ea typeface="Urbanist SemiBold"/>
-                <a:cs typeface="Urbanist SemiBold"/>
               </a:rPr>
               <a:t>Called out</a:t>
             </a:r>
@@ -16011,8 +15545,6 @@
                   <a:srgbClr val="64707A"/>
                 </a:solidFill>
                 <a:latin typeface="Urbanist SemiBold"/>
-                <a:ea typeface="Urbanist SemiBold"/>
-                <a:cs typeface="Urbanist SemiBold"/>
               </a:rPr>
               <a:t>Row label</a:t>
             </a:r>
@@ -16078,8 +15610,6 @@
                   <a:srgbClr val="64707A"/>
                 </a:solidFill>
                 <a:latin typeface="Urbanist"/>
-                <a:ea typeface="Urbanist"/>
-                <a:cs typeface="Urbanist"/>
               </a:rPr>
               <a:t>Value</a:t>
             </a:r>
@@ -16145,8 +15675,6 @@
                   <a:srgbClr val="64707A"/>
                 </a:solidFill>
                 <a:latin typeface="Urbanist"/>
-                <a:ea typeface="Urbanist"/>
-                <a:cs typeface="Urbanist"/>
               </a:rPr>
               <a:t>Value</a:t>
             </a:r>
@@ -16212,8 +15740,6 @@
                   <a:srgbClr val="64707A"/>
                 </a:solidFill>
                 <a:latin typeface="Urbanist"/>
-                <a:ea typeface="Urbanist"/>
-                <a:cs typeface="Urbanist"/>
               </a:rPr>
               <a:t>Value</a:t>
             </a:r>
@@ -16279,8 +15805,6 @@
                   <a:srgbClr val="64707A"/>
                 </a:solidFill>
                 <a:latin typeface="Urbanist SemiBold"/>
-                <a:ea typeface="Urbanist SemiBold"/>
-                <a:cs typeface="Urbanist SemiBold"/>
               </a:rPr>
               <a:t>Called out</a:t>
             </a:r>
@@ -16346,8 +15870,6 @@
                   <a:srgbClr val="64707A"/>
                 </a:solidFill>
                 <a:latin typeface="Urbanist SemiBold"/>
-                <a:ea typeface="Urbanist SemiBold"/>
-                <a:cs typeface="Urbanist SemiBold"/>
               </a:rPr>
               <a:t>Row label</a:t>
             </a:r>
@@ -16413,8 +15935,6 @@
                   <a:srgbClr val="64707A"/>
                 </a:solidFill>
                 <a:latin typeface="Urbanist"/>
-                <a:ea typeface="Urbanist"/>
-                <a:cs typeface="Urbanist"/>
               </a:rPr>
               <a:t>Value</a:t>
             </a:r>
@@ -16480,8 +16000,6 @@
                   <a:srgbClr val="64707A"/>
                 </a:solidFill>
                 <a:latin typeface="Urbanist"/>
-                <a:ea typeface="Urbanist"/>
-                <a:cs typeface="Urbanist"/>
               </a:rPr>
               <a:t>Value</a:t>
             </a:r>
@@ -16547,8 +16065,6 @@
                   <a:srgbClr val="64707A"/>
                 </a:solidFill>
                 <a:latin typeface="Urbanist"/>
-                <a:ea typeface="Urbanist"/>
-                <a:cs typeface="Urbanist"/>
               </a:rPr>
               <a:t>Value</a:t>
             </a:r>
@@ -16614,8 +16130,6 @@
                   <a:srgbClr val="64707A"/>
                 </a:solidFill>
                 <a:latin typeface="Urbanist SemiBold"/>
-                <a:ea typeface="Urbanist SemiBold"/>
-                <a:cs typeface="Urbanist SemiBold"/>
               </a:rPr>
               <a:t>Called out</a:t>
             </a:r>
@@ -16681,8 +16195,6 @@
                   <a:srgbClr val="64707A"/>
                 </a:solidFill>
                 <a:latin typeface="Urbanist SemiBold"/>
-                <a:ea typeface="Urbanist SemiBold"/>
-                <a:cs typeface="Urbanist SemiBold"/>
               </a:rPr>
               <a:t>Row label</a:t>
             </a:r>
@@ -16748,8 +16260,6 @@
                   <a:srgbClr val="64707A"/>
                 </a:solidFill>
                 <a:latin typeface="Urbanist"/>
-                <a:ea typeface="Urbanist"/>
-                <a:cs typeface="Urbanist"/>
               </a:rPr>
               <a:t>Value</a:t>
             </a:r>
@@ -16815,8 +16325,6 @@
                   <a:srgbClr val="64707A"/>
                 </a:solidFill>
                 <a:latin typeface="Urbanist"/>
-                <a:ea typeface="Urbanist"/>
-                <a:cs typeface="Urbanist"/>
               </a:rPr>
               <a:t>Value</a:t>
             </a:r>
@@ -16882,8 +16390,6 @@
                   <a:srgbClr val="64707A"/>
                 </a:solidFill>
                 <a:latin typeface="Urbanist"/>
-                <a:ea typeface="Urbanist"/>
-                <a:cs typeface="Urbanist"/>
               </a:rPr>
               <a:t>Value</a:t>
             </a:r>
@@ -16949,8 +16455,6 @@
                   <a:srgbClr val="64707A"/>
                 </a:solidFill>
                 <a:latin typeface="Urbanist SemiBold"/>
-                <a:ea typeface="Urbanist SemiBold"/>
-                <a:cs typeface="Urbanist SemiBold"/>
               </a:rPr>
               <a:t>Called out</a:t>
             </a:r>
@@ -16986,8 +16490,6 @@
                   <a:srgbClr val="64707A"/>
                 </a:solidFill>
                 <a:latin typeface="League Spartan Medium"/>
-                <a:ea typeface="League Spartan Medium"/>
-                <a:cs typeface="League Spartan Medium"/>
               </a:rPr>
               <a:t>15</a:t>
             </a:r>
@@ -17023,8 +16525,6 @@
                   <a:srgbClr val="64707A"/>
                 </a:solidFill>
                 <a:latin typeface="League Spartan"/>
-                <a:ea typeface="League Spartan"/>
-                <a:cs typeface="League Spartan"/>
               </a:rPr>
               <a:t>TABLE</a:t>
             </a:r>
@@ -17258,8 +16758,6 @@
                   <a:srgbClr val="FFFFFF"/>
                 </a:solidFill>
                 <a:latin typeface="League Spartan SemiBold"/>
-                <a:ea typeface="League Spartan SemiBold"/>
-                <a:cs typeface="League Spartan SemiBold"/>
               </a:rPr>
               <a:t>16</a:t>
             </a:r>
@@ -17295,8 +16793,6 @@
                   <a:srgbClr val="E7EBF0"/>
                 </a:solidFill>
                 <a:latin typeface="League Spartan SemiBold"/>
-                <a:ea typeface="League Spartan SemiBold"/>
-                <a:cs typeface="League Spartan SemiBold"/>
               </a:rPr>
               <a:t>IAQ TECHNOLOGY INTERNATIONAL SDN BHD</a:t>
             </a:r>
@@ -17415,8 +16911,6 @@
                   <a:srgbClr val="FFFFFF"/>
                 </a:solidFill>
                 <a:latin typeface="Poppins SemiBold"/>
-                <a:ea typeface="Poppins SemiBold"/>
-                <a:cs typeface="Poppins SemiBold"/>
               </a:rPr>
               <a:t>One line over the photograph.</a:t>
             </a:r>
@@ -17452,8 +16946,6 @@
                   <a:srgbClr val="E7EBF0"/>
                 </a:solidFill>
                 <a:latin typeface="Urbanist"/>
-                <a:ea typeface="Urbanist"/>
-                <a:cs typeface="Urbanist"/>
               </a:rPr>
               <a:t>A sentence under it, if the line needs support. Otherwise leave it out.</a:t>
             </a:r>
@@ -17489,8 +16981,6 @@
                   <a:srgbClr val="96A2B2"/>
                 </a:solidFill>
                 <a:latin typeface="League Spartan Medium"/>
-                <a:ea typeface="League Spartan Medium"/>
-                <a:cs typeface="League Spartan Medium"/>
               </a:rPr>
               <a:t>16</a:t>
             </a:r>
@@ -17526,8 +17016,6 @@
                   <a:srgbClr val="96A2B2"/>
                 </a:solidFill>
                 <a:latin typeface="League Spartan"/>
-                <a:ea typeface="League Spartan"/>
-                <a:cs typeface="League Spartan"/>
               </a:rPr>
               <a:t>FULL-BLEED IMAGE</a:t>
             </a:r>
@@ -17761,8 +17249,6 @@
                   <a:srgbClr val="FFFFFF"/>
                 </a:solidFill>
                 <a:latin typeface="League Spartan SemiBold"/>
-                <a:ea typeface="League Spartan SemiBold"/>
-                <a:cs typeface="League Spartan SemiBold"/>
               </a:rPr>
               <a:t>17</a:t>
             </a:r>
@@ -17798,8 +17284,6 @@
                   <a:srgbClr val="E7EBF0"/>
                 </a:solidFill>
                 <a:latin typeface="League Spartan SemiBold"/>
-                <a:ea typeface="League Spartan SemiBold"/>
-                <a:cs typeface="League Spartan SemiBold"/>
               </a:rPr>
               <a:t>IAQ TECHNOLOGY INTERNATIONAL SDN BHD</a:t>
             </a:r>
@@ -17859,8 +17343,6 @@
                   <a:srgbClr val="FFFFFF"/>
                 </a:solidFill>
                 <a:latin typeface="Poppins SemiBold"/>
-                <a:ea typeface="Poppins SemiBold"/>
-                <a:cs typeface="Poppins SemiBold"/>
               </a:rPr>
               <a:t>The closing line, six words or fewer.</a:t>
             </a:r>
@@ -17896,8 +17378,6 @@
                   <a:srgbClr val="64707A"/>
                 </a:solidFill>
                 <a:latin typeface="Urbanist"/>
-                <a:ea typeface="Urbanist"/>
-                <a:cs typeface="Urbanist"/>
               </a:rPr>
               <a:t>A sentence saying what you want to happen next.</a:t>
             </a:r>
@@ -17933,8 +17413,6 @@
                   <a:srgbClr val="96A2B2"/>
                 </a:solidFill>
                 <a:latin typeface="League Spartan SemiBold"/>
-                <a:ea typeface="League Spartan SemiBold"/>
-                <a:cs typeface="League Spartan SemiBold"/>
               </a:rPr>
               <a:t>LABEL</a:t>
             </a:r>
@@ -17970,8 +17448,6 @@
                   <a:srgbClr val="E7EBF0"/>
                 </a:solidFill>
                 <a:latin typeface="Urbanist"/>
-                <a:ea typeface="Urbanist"/>
-                <a:cs typeface="Urbanist"/>
               </a:rPr>
               <a:t>The detail</a:t>
             </a:r>
@@ -18007,8 +17483,6 @@
                   <a:srgbClr val="96A2B2"/>
                 </a:solidFill>
                 <a:latin typeface="League Spartan SemiBold"/>
-                <a:ea typeface="League Spartan SemiBold"/>
-                <a:cs typeface="League Spartan SemiBold"/>
               </a:rPr>
               <a:t>LABEL</a:t>
             </a:r>
@@ -18044,8 +17518,6 @@
                   <a:srgbClr val="E7EBF0"/>
                 </a:solidFill>
                 <a:latin typeface="Urbanist"/>
-                <a:ea typeface="Urbanist"/>
-                <a:cs typeface="Urbanist"/>
               </a:rPr>
               <a:t>The detail</a:t>
             </a:r>
@@ -18081,8 +17553,6 @@
                   <a:srgbClr val="96A2B2"/>
                 </a:solidFill>
                 <a:latin typeface="League Spartan SemiBold"/>
-                <a:ea typeface="League Spartan SemiBold"/>
-                <a:cs typeface="League Spartan SemiBold"/>
               </a:rPr>
               <a:t>LABEL</a:t>
             </a:r>
@@ -18118,8 +17588,6 @@
                   <a:srgbClr val="E7EBF0"/>
                 </a:solidFill>
                 <a:latin typeface="Urbanist"/>
-                <a:ea typeface="Urbanist"/>
-                <a:cs typeface="Urbanist"/>
               </a:rPr>
               <a:t>The detail</a:t>
             </a:r>
@@ -18155,8 +17623,6 @@
                   <a:srgbClr val="96A2B2"/>
                 </a:solidFill>
                 <a:latin typeface="League Spartan SemiBold"/>
-                <a:ea typeface="League Spartan SemiBold"/>
-                <a:cs typeface="League Spartan SemiBold"/>
               </a:rPr>
               <a:t>LABEL</a:t>
             </a:r>
@@ -18192,8 +17658,6 @@
                   <a:srgbClr val="E7EBF0"/>
                 </a:solidFill>
                 <a:latin typeface="Urbanist"/>
-                <a:ea typeface="Urbanist"/>
-                <a:cs typeface="Urbanist"/>
               </a:rPr>
               <a:t>The detail</a:t>
             </a:r>
@@ -18229,8 +17693,6 @@
                   <a:srgbClr val="96A2B2"/>
                 </a:solidFill>
                 <a:latin typeface="League Spartan Medium"/>
-                <a:ea typeface="League Spartan Medium"/>
-                <a:cs typeface="League Spartan Medium"/>
               </a:rPr>
               <a:t>17</a:t>
             </a:r>
@@ -18266,8 +17728,6 @@
                   <a:srgbClr val="96A2B2"/>
                 </a:solidFill>
                 <a:latin typeface="League Spartan"/>
-                <a:ea typeface="League Spartan"/>
-                <a:cs typeface="League Spartan"/>
               </a:rPr>
               <a:t>CLOSING</a:t>
             </a:r>
@@ -18381,8 +17841,6 @@
                   <a:srgbClr val="FFFFFF"/>
                 </a:solidFill>
                 <a:latin typeface="League Spartan SemiBold"/>
-                <a:ea typeface="League Spartan SemiBold"/>
-                <a:cs typeface="League Spartan SemiBold"/>
               </a:rPr>
               <a:t>18</a:t>
             </a:r>
@@ -18418,8 +17876,6 @@
                   <a:srgbClr val="101A2B"/>
                 </a:solidFill>
                 <a:latin typeface="League Spartan SemiBold"/>
-                <a:ea typeface="League Spartan SemiBold"/>
-                <a:cs typeface="League Spartan SemiBold"/>
               </a:rPr>
               <a:t>SECTION NAME</a:t>
             </a:r>
@@ -18509,8 +17965,6 @@
                   <a:srgbClr val="64707A"/>
                 </a:solidFill>
                 <a:latin typeface="Poppins SemiBold"/>
-                <a:ea typeface="Poppins SemiBold"/>
-                <a:cs typeface="Poppins SemiBold"/>
               </a:rPr>
               <a:t>Page title</a:t>
             </a:r>
@@ -18546,8 +18000,6 @@
                   <a:srgbClr val="64707A"/>
                 </a:solidFill>
                 <a:latin typeface="Urbanist"/>
-                <a:ea typeface="Urbanist"/>
-                <a:cs typeface="Urbanist"/>
               </a:rPr>
               <a:t>One line under it saying what the page is for.</a:t>
             </a:r>
@@ -18583,8 +18035,6 @@
                   <a:srgbClr val="64707A"/>
                 </a:solidFill>
                 <a:latin typeface="Poppins"/>
-                <a:ea typeface="Poppins"/>
-                <a:cs typeface="Poppins"/>
               </a:rPr>
               <a:t>01</a:t>
             </a:r>
@@ -18650,8 +18100,6 @@
                   <a:srgbClr val="64707A"/>
                 </a:solidFill>
                 <a:latin typeface="Poppins SemiBold"/>
-                <a:ea typeface="Poppins SemiBold"/>
-                <a:cs typeface="Poppins SemiBold"/>
               </a:rPr>
               <a:t>Part name</a:t>
             </a:r>
@@ -18687,8 +18135,6 @@
                   <a:srgbClr val="64707A"/>
                 </a:solidFill>
                 <a:latin typeface="League Spartan SemiBold"/>
-                <a:ea typeface="League Spartan SemiBold"/>
-                <a:cs typeface="League Spartan SemiBold"/>
               </a:rPr>
               <a:t>01.1</a:t>
             </a:r>
@@ -18724,8 +18170,6 @@
                   <a:srgbClr val="64707A"/>
                 </a:solidFill>
                 <a:latin typeface="Urbanist Medium"/>
-                <a:ea typeface="Urbanist Medium"/>
-                <a:cs typeface="Urbanist Medium"/>
               </a:rPr>
               <a:t>What this section answers</a:t>
             </a:r>
@@ -18761,8 +18205,6 @@
                   <a:srgbClr val="64707A"/>
                 </a:solidFill>
                 <a:latin typeface="League Spartan SemiBold"/>
-                <a:ea typeface="League Spartan SemiBold"/>
-                <a:cs typeface="League Spartan SemiBold"/>
               </a:rPr>
               <a:t>01.2</a:t>
             </a:r>
@@ -18798,8 +18240,6 @@
                   <a:srgbClr val="64707A"/>
                 </a:solidFill>
                 <a:latin typeface="Urbanist Medium"/>
-                <a:ea typeface="Urbanist Medium"/>
-                <a:cs typeface="Urbanist Medium"/>
               </a:rPr>
               <a:t>What this section answers</a:t>
             </a:r>
@@ -18835,8 +18275,6 @@
                   <a:srgbClr val="64707A"/>
                 </a:solidFill>
                 <a:latin typeface="League Spartan SemiBold"/>
-                <a:ea typeface="League Spartan SemiBold"/>
-                <a:cs typeface="League Spartan SemiBold"/>
               </a:rPr>
               <a:t>01.3</a:t>
             </a:r>
@@ -18872,8 +18310,6 @@
                   <a:srgbClr val="64707A"/>
                 </a:solidFill>
                 <a:latin typeface="Urbanist Medium"/>
-                <a:ea typeface="Urbanist Medium"/>
-                <a:cs typeface="Urbanist Medium"/>
               </a:rPr>
               <a:t>What this section answers</a:t>
             </a:r>
@@ -18909,8 +18345,6 @@
                   <a:srgbClr val="64707A"/>
                 </a:solidFill>
                 <a:latin typeface="League Spartan SemiBold"/>
-                <a:ea typeface="League Spartan SemiBold"/>
-                <a:cs typeface="League Spartan SemiBold"/>
               </a:rPr>
               <a:t>01.4</a:t>
             </a:r>
@@ -18946,8 +18380,6 @@
                   <a:srgbClr val="64707A"/>
                 </a:solidFill>
                 <a:latin typeface="Urbanist Medium"/>
-                <a:ea typeface="Urbanist Medium"/>
-                <a:cs typeface="Urbanist Medium"/>
               </a:rPr>
               <a:t>What this section answers</a:t>
             </a:r>
@@ -18983,8 +18415,6 @@
                   <a:srgbClr val="64707A"/>
                 </a:solidFill>
                 <a:latin typeface="Poppins"/>
-                <a:ea typeface="Poppins"/>
-                <a:cs typeface="Poppins"/>
               </a:rPr>
               <a:t>02</a:t>
             </a:r>
@@ -19050,8 +18480,6 @@
                   <a:srgbClr val="64707A"/>
                 </a:solidFill>
                 <a:latin typeface="Poppins SemiBold"/>
-                <a:ea typeface="Poppins SemiBold"/>
-                <a:cs typeface="Poppins SemiBold"/>
               </a:rPr>
               <a:t>Part name</a:t>
             </a:r>
@@ -19087,8 +18515,6 @@
                   <a:srgbClr val="64707A"/>
                 </a:solidFill>
                 <a:latin typeface="League Spartan SemiBold"/>
-                <a:ea typeface="League Spartan SemiBold"/>
-                <a:cs typeface="League Spartan SemiBold"/>
               </a:rPr>
               <a:t>02.1</a:t>
             </a:r>
@@ -19124,8 +18550,6 @@
                   <a:srgbClr val="64707A"/>
                 </a:solidFill>
                 <a:latin typeface="Urbanist Medium"/>
-                <a:ea typeface="Urbanist Medium"/>
-                <a:cs typeface="Urbanist Medium"/>
               </a:rPr>
               <a:t>What this section answers</a:t>
             </a:r>
@@ -19161,8 +18585,6 @@
                   <a:srgbClr val="64707A"/>
                 </a:solidFill>
                 <a:latin typeface="League Spartan SemiBold"/>
-                <a:ea typeface="League Spartan SemiBold"/>
-                <a:cs typeface="League Spartan SemiBold"/>
               </a:rPr>
               <a:t>02.2</a:t>
             </a:r>
@@ -19198,8 +18620,6 @@
                   <a:srgbClr val="64707A"/>
                 </a:solidFill>
                 <a:latin typeface="Urbanist Medium"/>
-                <a:ea typeface="Urbanist Medium"/>
-                <a:cs typeface="Urbanist Medium"/>
               </a:rPr>
               <a:t>What this section answers</a:t>
             </a:r>
@@ -19235,8 +18655,6 @@
                   <a:srgbClr val="64707A"/>
                 </a:solidFill>
                 <a:latin typeface="League Spartan SemiBold"/>
-                <a:ea typeface="League Spartan SemiBold"/>
-                <a:cs typeface="League Spartan SemiBold"/>
               </a:rPr>
               <a:t>02.3</a:t>
             </a:r>
@@ -19272,8 +18690,6 @@
                   <a:srgbClr val="64707A"/>
                 </a:solidFill>
                 <a:latin typeface="Urbanist Medium"/>
-                <a:ea typeface="Urbanist Medium"/>
-                <a:cs typeface="Urbanist Medium"/>
               </a:rPr>
               <a:t>What this section answers</a:t>
             </a:r>
@@ -19309,8 +18725,6 @@
                   <a:srgbClr val="64707A"/>
                 </a:solidFill>
                 <a:latin typeface="League Spartan SemiBold"/>
-                <a:ea typeface="League Spartan SemiBold"/>
-                <a:cs typeface="League Spartan SemiBold"/>
               </a:rPr>
               <a:t>02.4</a:t>
             </a:r>
@@ -19346,8 +18760,6 @@
                   <a:srgbClr val="64707A"/>
                 </a:solidFill>
                 <a:latin typeface="Urbanist Medium"/>
-                <a:ea typeface="Urbanist Medium"/>
-                <a:cs typeface="Urbanist Medium"/>
               </a:rPr>
               <a:t>What this section answers</a:t>
             </a:r>
@@ -19383,8 +18795,6 @@
                   <a:srgbClr val="64707A"/>
                 </a:solidFill>
                 <a:latin typeface="Poppins"/>
-                <a:ea typeface="Poppins"/>
-                <a:cs typeface="Poppins"/>
               </a:rPr>
               <a:t>03</a:t>
             </a:r>
@@ -19450,8 +18860,6 @@
                   <a:srgbClr val="64707A"/>
                 </a:solidFill>
                 <a:latin typeface="Poppins SemiBold"/>
-                <a:ea typeface="Poppins SemiBold"/>
-                <a:cs typeface="Poppins SemiBold"/>
               </a:rPr>
               <a:t>Part name</a:t>
             </a:r>
@@ -19487,8 +18895,6 @@
                   <a:srgbClr val="64707A"/>
                 </a:solidFill>
                 <a:latin typeface="League Spartan SemiBold"/>
-                <a:ea typeface="League Spartan SemiBold"/>
-                <a:cs typeface="League Spartan SemiBold"/>
               </a:rPr>
               <a:t>03.1</a:t>
             </a:r>
@@ -19524,8 +18930,6 @@
                   <a:srgbClr val="64707A"/>
                 </a:solidFill>
                 <a:latin typeface="Urbanist Medium"/>
-                <a:ea typeface="Urbanist Medium"/>
-                <a:cs typeface="Urbanist Medium"/>
               </a:rPr>
               <a:t>What this section answers</a:t>
             </a:r>
@@ -19561,8 +18965,6 @@
                   <a:srgbClr val="64707A"/>
                 </a:solidFill>
                 <a:latin typeface="League Spartan SemiBold"/>
-                <a:ea typeface="League Spartan SemiBold"/>
-                <a:cs typeface="League Spartan SemiBold"/>
               </a:rPr>
               <a:t>03.2</a:t>
             </a:r>
@@ -19598,8 +19000,6 @@
                   <a:srgbClr val="64707A"/>
                 </a:solidFill>
                 <a:latin typeface="Urbanist Medium"/>
-                <a:ea typeface="Urbanist Medium"/>
-                <a:cs typeface="Urbanist Medium"/>
               </a:rPr>
               <a:t>What this section answers</a:t>
             </a:r>
@@ -19635,8 +19035,6 @@
                   <a:srgbClr val="64707A"/>
                 </a:solidFill>
                 <a:latin typeface="League Spartan SemiBold"/>
-                <a:ea typeface="League Spartan SemiBold"/>
-                <a:cs typeface="League Spartan SemiBold"/>
               </a:rPr>
               <a:t>03.3</a:t>
             </a:r>
@@ -19672,8 +19070,6 @@
                   <a:srgbClr val="64707A"/>
                 </a:solidFill>
                 <a:latin typeface="Urbanist Medium"/>
-                <a:ea typeface="Urbanist Medium"/>
-                <a:cs typeface="Urbanist Medium"/>
               </a:rPr>
               <a:t>What this section answers</a:t>
             </a:r>
@@ -19709,8 +19105,6 @@
                   <a:srgbClr val="64707A"/>
                 </a:solidFill>
                 <a:latin typeface="League Spartan SemiBold"/>
-                <a:ea typeface="League Spartan SemiBold"/>
-                <a:cs typeface="League Spartan SemiBold"/>
               </a:rPr>
               <a:t>03.4</a:t>
             </a:r>
@@ -19746,8 +19140,6 @@
                   <a:srgbClr val="64707A"/>
                 </a:solidFill>
                 <a:latin typeface="Urbanist Medium"/>
-                <a:ea typeface="Urbanist Medium"/>
-                <a:cs typeface="Urbanist Medium"/>
               </a:rPr>
               <a:t>What this section answers</a:t>
             </a:r>
@@ -19783,8 +19175,6 @@
                   <a:srgbClr val="64707A"/>
                 </a:solidFill>
                 <a:latin typeface="League Spartan Medium"/>
-                <a:ea typeface="League Spartan Medium"/>
-                <a:cs typeface="League Spartan Medium"/>
               </a:rPr>
               <a:t>18</a:t>
             </a:r>
@@ -19820,8 +19210,6 @@
                   <a:srgbClr val="64707A"/>
                 </a:solidFill>
                 <a:latin typeface="League Spartan"/>
-                <a:ea typeface="League Spartan"/>
-                <a:cs typeface="League Spartan"/>
               </a:rPr>
               <a:t>AGENDA</a:t>
             </a:r>
@@ -20055,8 +19443,6 @@
                   <a:srgbClr val="FFFFFF"/>
                 </a:solidFill>
                 <a:latin typeface="League Spartan SemiBold"/>
-                <a:ea typeface="League Spartan SemiBold"/>
-                <a:cs typeface="League Spartan SemiBold"/>
               </a:rPr>
               <a:t>01</a:t>
             </a:r>
@@ -20092,8 +19478,6 @@
                   <a:srgbClr val="E7EBF0"/>
                 </a:solidFill>
                 <a:latin typeface="League Spartan SemiBold"/>
-                <a:ea typeface="League Spartan SemiBold"/>
-                <a:cs typeface="League Spartan SemiBold"/>
               </a:rPr>
               <a:t>IAQ TECHNOLOGY INTERNATIONAL SDN BHD</a:t>
             </a:r>
@@ -20153,8 +19537,6 @@
                   <a:srgbClr val="64707A"/>
                 </a:solidFill>
                 <a:latin typeface="League Spartan SemiBold"/>
-                <a:ea typeface="League Spartan SemiBold"/>
-                <a:cs typeface="League Spartan SemiBold"/>
               </a:rPr>
               <a:t>KICKER · TWO OR THREE WORDS</a:t>
             </a:r>
@@ -20194,8 +19576,6 @@
                   <a:srgbClr val="FFFFFF"/>
                 </a:solidFill>
                 <a:latin typeface="Poppins SemiBold"/>
-                <a:ea typeface="Poppins SemiBold"/>
-                <a:cs typeface="Poppins SemiBold"/>
               </a:rPr>
               <a:t>The one line this deck is about, eight words or fewer.</a:t>
             </a:r>
@@ -20231,8 +19611,6 @@
                   <a:srgbClr val="64707A"/>
                 </a:solidFill>
                 <a:latin typeface="Urbanist"/>
-                <a:ea typeface="Urbanist"/>
-                <a:cs typeface="Urbanist"/>
               </a:rPr>
               <a:t>A sentence under it saying who it is for and what it covers.</a:t>
             </a:r>
@@ -20268,8 +19646,6 @@
                   <a:srgbClr val="64707A"/>
                 </a:solidFill>
                 <a:latin typeface="League Spartan"/>
-                <a:ea typeface="League Spartan"/>
-                <a:cs typeface="League Spartan"/>
               </a:rPr>
               <a:t>PREPARED FOR · CLIENT · DATE</a:t>
             </a:r>
@@ -20305,8 +19681,6 @@
                   <a:srgbClr val="96A2B2"/>
                 </a:solidFill>
                 <a:latin typeface="League Spartan Medium"/>
-                <a:ea typeface="League Spartan Medium"/>
-                <a:cs typeface="League Spartan Medium"/>
               </a:rPr>
               <a:t>01</a:t>
             </a:r>
@@ -20342,8 +19716,6 @@
                   <a:srgbClr val="96A2B2"/>
                 </a:solidFill>
                 <a:latin typeface="League Spartan"/>
-                <a:ea typeface="League Spartan"/>
-                <a:cs typeface="League Spartan"/>
               </a:rPr>
               <a:t>TITLE</a:t>
             </a:r>
@@ -20457,8 +19829,6 @@
                   <a:srgbClr val="FFFFFF"/>
                 </a:solidFill>
                 <a:latin typeface="League Spartan SemiBold"/>
-                <a:ea typeface="League Spartan SemiBold"/>
-                <a:cs typeface="League Spartan SemiBold"/>
               </a:rPr>
               <a:t>19</a:t>
             </a:r>
@@ -20494,8 +19864,6 @@
                   <a:srgbClr val="101A2B"/>
                 </a:solidFill>
                 <a:latin typeface="League Spartan SemiBold"/>
-                <a:ea typeface="League Spartan SemiBold"/>
-                <a:cs typeface="League Spartan SemiBold"/>
               </a:rPr>
               <a:t>SECTION NAME</a:t>
             </a:r>
@@ -20585,8 +19953,6 @@
                   <a:srgbClr val="64707A"/>
                 </a:solidFill>
                 <a:latin typeface="Poppins SemiBold"/>
-                <a:ea typeface="Poppins SemiBold"/>
-                <a:cs typeface="Poppins SemiBold"/>
               </a:rPr>
               <a:t>Page title</a:t>
             </a:r>
@@ -20622,8 +19988,6 @@
                   <a:srgbClr val="64707A"/>
                 </a:solidFill>
                 <a:latin typeface="Urbanist"/>
-                <a:ea typeface="Urbanist"/>
-                <a:cs typeface="Urbanist"/>
               </a:rPr>
               <a:t>One line under it saying what the page is for.</a:t>
             </a:r>
@@ -20659,8 +20023,6 @@
                   <a:srgbClr val="64707A"/>
                 </a:solidFill>
                 <a:latin typeface="Poppins"/>
-                <a:ea typeface="Poppins"/>
-                <a:cs typeface="Poppins"/>
               </a:rPr>
               <a:t>“</a:t>
             </a:r>
@@ -20700,8 +20062,6 @@
                   <a:srgbClr val="64707A"/>
                 </a:solidFill>
                 <a:latin typeface="Poppins SemiBold"/>
-                <a:ea typeface="Poppins SemiBold"/>
-                <a:cs typeface="Poppins SemiBold"/>
               </a:rPr>
               <a:t>The quotation, two lines at most. Cut it back until only the part worth repeating is left.</a:t>
             </a:r>
@@ -20767,8 +20127,6 @@
                   <a:srgbClr val="64707A"/>
                 </a:solidFill>
                 <a:latin typeface="Urbanist SemiBold"/>
-                <a:ea typeface="Urbanist SemiBold"/>
-                <a:cs typeface="Urbanist SemiBold"/>
               </a:rPr>
               <a:t>Name of the person</a:t>
             </a:r>
@@ -20804,8 +20162,6 @@
                   <a:srgbClr val="64707A"/>
                 </a:solidFill>
                 <a:latin typeface="League Spartan SemiBold"/>
-                <a:ea typeface="League Spartan SemiBold"/>
-                <a:cs typeface="League Spartan SemiBold"/>
               </a:rPr>
               <a:t>ROLE · ORGANISATION</a:t>
             </a:r>
@@ -20896,8 +20252,6 @@
                   <a:srgbClr val="64707A"/>
                 </a:solidFill>
                 <a:latin typeface="League Spartan Medium"/>
-                <a:ea typeface="League Spartan Medium"/>
-                <a:cs typeface="League Spartan Medium"/>
               </a:rPr>
               <a:t>19</a:t>
             </a:r>
@@ -20933,8 +20287,6 @@
                   <a:srgbClr val="64707A"/>
                 </a:solidFill>
                 <a:latin typeface="League Spartan"/>
-                <a:ea typeface="League Spartan"/>
-                <a:cs typeface="League Spartan"/>
               </a:rPr>
               <a:t>QUOTE</a:t>
             </a:r>
@@ -21048,8 +20400,6 @@
                   <a:srgbClr val="FFFFFF"/>
                 </a:solidFill>
                 <a:latin typeface="League Spartan SemiBold"/>
-                <a:ea typeface="League Spartan SemiBold"/>
-                <a:cs typeface="League Spartan SemiBold"/>
               </a:rPr>
               <a:t>20</a:t>
             </a:r>
@@ -21085,8 +20435,6 @@
                   <a:srgbClr val="101A2B"/>
                 </a:solidFill>
                 <a:latin typeface="League Spartan SemiBold"/>
-                <a:ea typeface="League Spartan SemiBold"/>
-                <a:cs typeface="League Spartan SemiBold"/>
               </a:rPr>
               <a:t>SECTION NAME</a:t>
             </a:r>
@@ -21176,8 +20524,6 @@
                   <a:srgbClr val="64707A"/>
                 </a:solidFill>
                 <a:latin typeface="Poppins SemiBold"/>
-                <a:ea typeface="Poppins SemiBold"/>
-                <a:cs typeface="Poppins SemiBold"/>
               </a:rPr>
               <a:t>Page title</a:t>
             </a:r>
@@ -21213,8 +20559,6 @@
                   <a:srgbClr val="64707A"/>
                 </a:solidFill>
                 <a:latin typeface="Urbanist"/>
-                <a:ea typeface="Urbanist"/>
-                <a:cs typeface="Urbanist"/>
               </a:rPr>
               <a:t>One line under it saying what the page is for.</a:t>
             </a:r>
@@ -21310,8 +20654,6 @@
                   <a:srgbClr val="FFFFFF"/>
                 </a:solidFill>
                 <a:latin typeface="League Spartan SemiBold"/>
-                <a:ea typeface="League Spartan SemiBold"/>
-                <a:cs typeface="League Spartan SemiBold"/>
               </a:rPr>
               <a:t>BEFORE</a:t>
             </a:r>
@@ -21372,8 +20714,6 @@
                   <a:srgbClr val="64707A"/>
                 </a:solidFill>
                 <a:latin typeface="Poppins SemiBold"/>
-                <a:ea typeface="Poppins SemiBold"/>
-                <a:cs typeface="Poppins SemiBold"/>
               </a:rPr>
               <a:t>What it was</a:t>
             </a:r>
@@ -21409,8 +20749,6 @@
                   <a:srgbClr val="64707A"/>
                 </a:solidFill>
                 <a:latin typeface="Urbanist"/>
-                <a:ea typeface="Urbanist"/>
-                <a:cs typeface="Urbanist"/>
               </a:rPr>
               <a:t>One or two sentences on the state it started in.</a:t>
             </a:r>
@@ -21506,8 +20844,6 @@
                   <a:srgbClr val="FFFFFF"/>
                 </a:solidFill>
                 <a:latin typeface="League Spartan SemiBold"/>
-                <a:ea typeface="League Spartan SemiBold"/>
-                <a:cs typeface="League Spartan SemiBold"/>
               </a:rPr>
               <a:t>AFTER</a:t>
             </a:r>
@@ -21568,8 +20904,6 @@
                   <a:srgbClr val="64707A"/>
                 </a:solidFill>
                 <a:latin typeface="Poppins SemiBold"/>
-                <a:ea typeface="Poppins SemiBold"/>
-                <a:cs typeface="Poppins SemiBold"/>
               </a:rPr>
               <a:t>What it became</a:t>
             </a:r>
@@ -21605,8 +20939,6 @@
                   <a:srgbClr val="64707A"/>
                 </a:solidFill>
                 <a:latin typeface="Urbanist"/>
-                <a:ea typeface="Urbanist"/>
-                <a:cs typeface="Urbanist"/>
               </a:rPr>
               <a:t>One or two sentences on the state it ended in.</a:t>
             </a:r>
@@ -21642,8 +20974,6 @@
                   <a:srgbClr val="64707A"/>
                 </a:solidFill>
                 <a:latin typeface="League Spartan Medium"/>
-                <a:ea typeface="League Spartan Medium"/>
-                <a:cs typeface="League Spartan Medium"/>
               </a:rPr>
               <a:t>20</a:t>
             </a:r>
@@ -21679,8 +21009,6 @@
                   <a:srgbClr val="64707A"/>
                 </a:solidFill>
                 <a:latin typeface="League Spartan"/>
-                <a:ea typeface="League Spartan"/>
-                <a:cs typeface="League Spartan"/>
               </a:rPr>
               <a:t>BEFORE AND AFTER</a:t>
             </a:r>
@@ -21914,8 +21242,6 @@
                   <a:srgbClr val="FFFFFF"/>
                 </a:solidFill>
                 <a:latin typeface="League Spartan SemiBold"/>
-                <a:ea typeface="League Spartan SemiBold"/>
-                <a:cs typeface="League Spartan SemiBold"/>
               </a:rPr>
               <a:t>02</a:t>
             </a:r>
@@ -21951,8 +21277,6 @@
                   <a:srgbClr val="E7EBF0"/>
                 </a:solidFill>
                 <a:latin typeface="League Spartan SemiBold"/>
-                <a:ea typeface="League Spartan SemiBold"/>
-                <a:cs typeface="League Spartan SemiBold"/>
               </a:rPr>
               <a:t>SECTION NAME</a:t>
             </a:r>
@@ -21988,8 +21312,6 @@
                   <a:srgbClr val="EC2326"/>
                 </a:solidFill>
                 <a:latin typeface="League Spartan SemiBold"/>
-                <a:ea typeface="League Spartan SemiBold"/>
-                <a:cs typeface="League Spartan SemiBold"/>
               </a:rPr>
               <a:t>PART 00 OF 00</a:t>
             </a:r>
@@ -22025,8 +21347,6 @@
                   <a:srgbClr val="EC2326"/>
                 </a:solidFill>
                 <a:latin typeface="Poppins"/>
-                <a:ea typeface="Poppins"/>
-                <a:cs typeface="Poppins"/>
               </a:rPr>
               <a:t>00</a:t>
             </a:r>
@@ -22062,8 +21382,6 @@
                   <a:srgbClr val="FFFFFF"/>
                 </a:solidFill>
                 <a:latin typeface="Poppins SemiBold"/>
-                <a:ea typeface="Poppins SemiBold"/>
-                <a:cs typeface="Poppins SemiBold"/>
               </a:rPr>
               <a:t>Section name</a:t>
             </a:r>
@@ -22099,8 +21417,6 @@
                   <a:srgbClr val="96A2B2"/>
                 </a:solidFill>
                 <a:latin typeface="League Spartan Medium"/>
-                <a:ea typeface="League Spartan Medium"/>
-                <a:cs typeface="League Spartan Medium"/>
               </a:rPr>
               <a:t>WHAT THIS PART COVERS</a:t>
             </a:r>
@@ -22168,8 +21484,6 @@
                   <a:srgbClr val="E7EBF0"/>
                 </a:solidFill>
                 <a:latin typeface="Urbanist Medium"/>
-                <a:ea typeface="Urbanist Medium"/>
-                <a:cs typeface="Urbanist Medium"/>
               </a:rPr>
               <a:t>A fact worth leading with</a:t>
             </a:r>
@@ -22205,8 +21519,6 @@
                   <a:srgbClr val="E7EBF0"/>
                 </a:solidFill>
                 <a:latin typeface="Urbanist Medium"/>
-                <a:ea typeface="Urbanist Medium"/>
-                <a:cs typeface="Urbanist Medium"/>
               </a:rPr>
               <a:t>A second fact, the same length</a:t>
             </a:r>
@@ -22266,8 +21578,6 @@
                   <a:srgbClr val="96A2B2"/>
                 </a:solidFill>
                 <a:latin typeface="League Spartan Medium"/>
-                <a:ea typeface="League Spartan Medium"/>
-                <a:cs typeface="League Spartan Medium"/>
               </a:rPr>
               <a:t>02</a:t>
             </a:r>
@@ -22381,8 +21691,6 @@
                   <a:srgbClr val="FFFFFF"/>
                 </a:solidFill>
                 <a:latin typeface="League Spartan SemiBold"/>
-                <a:ea typeface="League Spartan SemiBold"/>
-                <a:cs typeface="League Spartan SemiBold"/>
               </a:rPr>
               <a:t>03</a:t>
             </a:r>
@@ -22418,8 +21726,6 @@
                   <a:srgbClr val="101A2B"/>
                 </a:solidFill>
                 <a:latin typeface="League Spartan SemiBold"/>
-                <a:ea typeface="League Spartan SemiBold"/>
-                <a:cs typeface="League Spartan SemiBold"/>
               </a:rPr>
               <a:t>SECTION NAME</a:t>
             </a:r>
@@ -22509,8 +21815,6 @@
                   <a:srgbClr val="64707A"/>
                 </a:solidFill>
                 <a:latin typeface="Poppins SemiBold"/>
-                <a:ea typeface="Poppins SemiBold"/>
-                <a:cs typeface="Poppins SemiBold"/>
               </a:rPr>
               <a:t>Page title</a:t>
             </a:r>
@@ -22546,8 +21850,6 @@
                   <a:srgbClr val="64707A"/>
                 </a:solidFill>
                 <a:latin typeface="Urbanist"/>
-                <a:ea typeface="Urbanist"/>
-                <a:cs typeface="Urbanist"/>
               </a:rPr>
               <a:t>One line under it saying what the page is for.</a:t>
             </a:r>
@@ -22587,8 +21889,6 @@
                   <a:srgbClr val="64707A"/>
                 </a:solidFill>
                 <a:latin typeface="Poppins SemiBold"/>
-                <a:ea typeface="Poppins SemiBold"/>
-                <a:cs typeface="Poppins SemiBold"/>
               </a:rPr>
               <a:t>The statement, two lines at most, said plainly.</a:t>
             </a:r>
@@ -22628,8 +21928,6 @@
                   <a:srgbClr val="64707A"/>
                 </a:solidFill>
                 <a:latin typeface="Urbanist"/>
-                <a:ea typeface="Urbanist"/>
-                <a:cs typeface="Urbanist"/>
               </a:rPr>
               <a:t>Two or three sentences carrying the argument. Say what is true, what it is worth, and leave the rest to the next page.</a:t>
             </a:r>
@@ -22690,8 +21988,6 @@
                   <a:srgbClr val="64707A"/>
                 </a:solidFill>
                 <a:latin typeface="League Spartan Medium"/>
-                <a:ea typeface="League Spartan Medium"/>
-                <a:cs typeface="League Spartan Medium"/>
               </a:rPr>
               <a:t>03</a:t>
             </a:r>
@@ -22727,8 +22023,6 @@
                   <a:srgbClr val="64707A"/>
                 </a:solidFill>
                 <a:latin typeface="League Spartan"/>
-                <a:ea typeface="League Spartan"/>
-                <a:cs typeface="League Spartan"/>
               </a:rPr>
               <a:t>STATEMENT</a:t>
             </a:r>
@@ -22842,8 +22136,6 @@
                   <a:srgbClr val="FFFFFF"/>
                 </a:solidFill>
                 <a:latin typeface="League Spartan SemiBold"/>
-                <a:ea typeface="League Spartan SemiBold"/>
-                <a:cs typeface="League Spartan SemiBold"/>
               </a:rPr>
               <a:t>04</a:t>
             </a:r>
@@ -22879,8 +22171,6 @@
                   <a:srgbClr val="101A2B"/>
                 </a:solidFill>
                 <a:latin typeface="League Spartan SemiBold"/>
-                <a:ea typeface="League Spartan SemiBold"/>
-                <a:cs typeface="League Spartan SemiBold"/>
               </a:rPr>
               <a:t>SECTION NAME</a:t>
             </a:r>
@@ -22970,8 +22260,6 @@
                   <a:srgbClr val="64707A"/>
                 </a:solidFill>
                 <a:latin typeface="Poppins SemiBold"/>
-                <a:ea typeface="Poppins SemiBold"/>
-                <a:cs typeface="Poppins SemiBold"/>
               </a:rPr>
               <a:t>Page title</a:t>
             </a:r>
@@ -23007,8 +22295,6 @@
                   <a:srgbClr val="64707A"/>
                 </a:solidFill>
                 <a:latin typeface="Urbanist"/>
-                <a:ea typeface="Urbanist"/>
-                <a:cs typeface="Urbanist"/>
               </a:rPr>
               <a:t>One line under it saying what the page is for.</a:t>
             </a:r>
@@ -23074,8 +22360,6 @@
                   <a:srgbClr val="64707A"/>
                 </a:solidFill>
                 <a:latin typeface="League Spartan SemiBold"/>
-                <a:ea typeface="League Spartan SemiBold"/>
-                <a:cs typeface="League Spartan SemiBold"/>
               </a:rPr>
               <a:t>LABEL</a:t>
             </a:r>
@@ -23115,8 +22399,6 @@
                   <a:srgbClr val="FFFFFF"/>
                 </a:solidFill>
                 <a:latin typeface="Poppins"/>
-                <a:ea typeface="Poppins"/>
-                <a:cs typeface="Poppins"/>
               </a:rPr>
               <a:t>00</a:t>
             </a:r>
@@ -23126,8 +22408,6 @@
                   <a:srgbClr val="64707A"/>
                 </a:solidFill>
                 <a:latin typeface="Urbanist Medium"/>
-                <a:ea typeface="Urbanist Medium"/>
-                <a:cs typeface="Urbanist Medium"/>
               </a:rPr>
               <a:t>+</a:t>
             </a:r>
@@ -23163,8 +22443,6 @@
                   <a:srgbClr val="64707A"/>
                 </a:solidFill>
                 <a:latin typeface="Urbanist"/>
-                <a:ea typeface="Urbanist"/>
-                <a:cs typeface="Urbanist"/>
               </a:rPr>
               <a:t>What the figure counts, one line</a:t>
             </a:r>
@@ -23230,8 +22508,6 @@
                   <a:srgbClr val="64707A"/>
                 </a:solidFill>
                 <a:latin typeface="League Spartan SemiBold"/>
-                <a:ea typeface="League Spartan SemiBold"/>
-                <a:cs typeface="League Spartan SemiBold"/>
               </a:rPr>
               <a:t>LABEL</a:t>
             </a:r>
@@ -23271,8 +22547,6 @@
                   <a:srgbClr val="101A2B"/>
                 </a:solidFill>
                 <a:latin typeface="Poppins"/>
-                <a:ea typeface="Poppins"/>
-                <a:cs typeface="Poppins"/>
               </a:rPr>
               <a:t>00</a:t>
             </a:r>
@@ -23282,8 +22556,6 @@
                   <a:srgbClr val="64707A"/>
                 </a:solidFill>
                 <a:latin typeface="Urbanist Medium"/>
-                <a:ea typeface="Urbanist Medium"/>
-                <a:cs typeface="Urbanist Medium"/>
               </a:rPr>
               <a:t>unit</a:t>
             </a:r>
@@ -23319,8 +22591,6 @@
                   <a:srgbClr val="64707A"/>
                 </a:solidFill>
                 <a:latin typeface="Urbanist"/>
-                <a:ea typeface="Urbanist"/>
-                <a:cs typeface="Urbanist"/>
               </a:rPr>
               <a:t>What the figure counts, one line</a:t>
             </a:r>
@@ -23386,8 +22656,6 @@
                   <a:srgbClr val="64707A"/>
                 </a:solidFill>
                 <a:latin typeface="League Spartan SemiBold"/>
-                <a:ea typeface="League Spartan SemiBold"/>
-                <a:cs typeface="League Spartan SemiBold"/>
               </a:rPr>
               <a:t>LABEL</a:t>
             </a:r>
@@ -23427,8 +22695,6 @@
                   <a:srgbClr val="101A2B"/>
                 </a:solidFill>
                 <a:latin typeface="Poppins"/>
-                <a:ea typeface="Poppins"/>
-                <a:cs typeface="Poppins"/>
               </a:rPr>
               <a:t>00</a:t>
             </a:r>
@@ -23438,8 +22704,6 @@
                   <a:srgbClr val="64707A"/>
                 </a:solidFill>
                 <a:latin typeface="Urbanist Medium"/>
-                <a:ea typeface="Urbanist Medium"/>
-                <a:cs typeface="Urbanist Medium"/>
               </a:rPr>
               <a:t>%</a:t>
             </a:r>
@@ -23475,8 +22739,6 @@
                   <a:srgbClr val="64707A"/>
                 </a:solidFill>
                 <a:latin typeface="Urbanist"/>
-                <a:ea typeface="Urbanist"/>
-                <a:cs typeface="Urbanist"/>
               </a:rPr>
               <a:t>What the figure counts, one line</a:t>
             </a:r>
@@ -23542,8 +22804,6 @@
                   <a:srgbClr val="64707A"/>
                 </a:solidFill>
                 <a:latin typeface="League Spartan SemiBold"/>
-                <a:ea typeface="League Spartan SemiBold"/>
-                <a:cs typeface="League Spartan SemiBold"/>
               </a:rPr>
               <a:t>LABEL</a:t>
             </a:r>
@@ -23579,8 +22839,6 @@
                   <a:srgbClr val="101A2B"/>
                 </a:solidFill>
                 <a:latin typeface="Poppins"/>
-                <a:ea typeface="Poppins"/>
-                <a:cs typeface="Poppins"/>
               </a:rPr>
               <a:t>00</a:t>
             </a:r>
@@ -23616,8 +22874,6 @@
                   <a:srgbClr val="64707A"/>
                 </a:solidFill>
                 <a:latin typeface="Urbanist"/>
-                <a:ea typeface="Urbanist"/>
-                <a:cs typeface="Urbanist"/>
               </a:rPr>
               <a:t>What the figure counts, one line</a:t>
             </a:r>
@@ -23653,8 +22909,6 @@
                   <a:srgbClr val="64707A"/>
                 </a:solidFill>
                 <a:latin typeface="League Spartan Medium"/>
-                <a:ea typeface="League Spartan Medium"/>
-                <a:cs typeface="League Spartan Medium"/>
               </a:rPr>
               <a:t>04</a:t>
             </a:r>
@@ -23690,8 +22944,6 @@
                   <a:srgbClr val="64707A"/>
                 </a:solidFill>
                 <a:latin typeface="League Spartan"/>
-                <a:ea typeface="League Spartan"/>
-                <a:cs typeface="League Spartan"/>
               </a:rPr>
               <a:t>HIGHLIGHTS</a:t>
             </a:r>
@@ -23805,8 +23057,6 @@
                   <a:srgbClr val="FFFFFF"/>
                 </a:solidFill>
                 <a:latin typeface="League Spartan SemiBold"/>
-                <a:ea typeface="League Spartan SemiBold"/>
-                <a:cs typeface="League Spartan SemiBold"/>
               </a:rPr>
               <a:t>05</a:t>
             </a:r>
@@ -23842,8 +23092,6 @@
                   <a:srgbClr val="101A2B"/>
                 </a:solidFill>
                 <a:latin typeface="League Spartan SemiBold"/>
-                <a:ea typeface="League Spartan SemiBold"/>
-                <a:cs typeface="League Spartan SemiBold"/>
               </a:rPr>
               <a:t>SECTION NAME</a:t>
             </a:r>
@@ -23933,8 +23181,6 @@
                   <a:srgbClr val="64707A"/>
                 </a:solidFill>
                 <a:latin typeface="Poppins SemiBold"/>
-                <a:ea typeface="Poppins SemiBold"/>
-                <a:cs typeface="Poppins SemiBold"/>
               </a:rPr>
               <a:t>Page title</a:t>
             </a:r>
@@ -23970,8 +23216,6 @@
                   <a:srgbClr val="64707A"/>
                 </a:solidFill>
                 <a:latin typeface="Urbanist"/>
-                <a:ea typeface="Urbanist"/>
-                <a:cs typeface="Urbanist"/>
               </a:rPr>
               <a:t>One line under it saying what the page is for.</a:t>
             </a:r>
@@ -24093,8 +23337,6 @@
                   <a:srgbClr val="64707A"/>
                 </a:solidFill>
                 <a:latin typeface="Urbanist SemiBold"/>
-                <a:ea typeface="Urbanist SemiBold"/>
-                <a:cs typeface="Urbanist SemiBold"/>
               </a:rPr>
               <a:t>Item name</a:t>
             </a:r>
@@ -24130,8 +23372,6 @@
                   <a:srgbClr val="64707A"/>
                 </a:solidFill>
                 <a:latin typeface="Urbanist"/>
-                <a:ea typeface="Urbanist"/>
-                <a:cs typeface="Urbanist"/>
               </a:rPr>
               <a:t>What it covers, four or five words</a:t>
             </a:r>
@@ -24169,8 +23409,6 @@
                   </a:srgbClr>
                 </a:solidFill>
                 <a:latin typeface="Poppins"/>
-                <a:ea typeface="Poppins"/>
-                <a:cs typeface="Poppins"/>
               </a:rPr>
               <a:t>01</a:t>
             </a:r>
@@ -24292,8 +23530,6 @@
                   <a:srgbClr val="64707A"/>
                 </a:solidFill>
                 <a:latin typeface="Urbanist SemiBold"/>
-                <a:ea typeface="Urbanist SemiBold"/>
-                <a:cs typeface="Urbanist SemiBold"/>
               </a:rPr>
               <a:t>Item name</a:t>
             </a:r>
@@ -24329,8 +23565,6 @@
                   <a:srgbClr val="64707A"/>
                 </a:solidFill>
                 <a:latin typeface="Urbanist"/>
-                <a:ea typeface="Urbanist"/>
-                <a:cs typeface="Urbanist"/>
               </a:rPr>
               <a:t>What it covers, four or five words</a:t>
             </a:r>
@@ -24368,8 +23602,6 @@
                   </a:srgbClr>
                 </a:solidFill>
                 <a:latin typeface="Poppins"/>
-                <a:ea typeface="Poppins"/>
-                <a:cs typeface="Poppins"/>
               </a:rPr>
               <a:t>02</a:t>
             </a:r>
@@ -24491,8 +23723,6 @@
                   <a:srgbClr val="64707A"/>
                 </a:solidFill>
                 <a:latin typeface="Urbanist SemiBold"/>
-                <a:ea typeface="Urbanist SemiBold"/>
-                <a:cs typeface="Urbanist SemiBold"/>
               </a:rPr>
               <a:t>Item name</a:t>
             </a:r>
@@ -24528,8 +23758,6 @@
                   <a:srgbClr val="64707A"/>
                 </a:solidFill>
                 <a:latin typeface="Urbanist"/>
-                <a:ea typeface="Urbanist"/>
-                <a:cs typeface="Urbanist"/>
               </a:rPr>
               <a:t>What it covers, four or five words</a:t>
             </a:r>
@@ -24567,8 +23795,6 @@
                   </a:srgbClr>
                 </a:solidFill>
                 <a:latin typeface="Poppins"/>
-                <a:ea typeface="Poppins"/>
-                <a:cs typeface="Poppins"/>
               </a:rPr>
               <a:t>03</a:t>
             </a:r>
@@ -24690,8 +23916,6 @@
                   <a:srgbClr val="64707A"/>
                 </a:solidFill>
                 <a:latin typeface="Urbanist SemiBold"/>
-                <a:ea typeface="Urbanist SemiBold"/>
-                <a:cs typeface="Urbanist SemiBold"/>
               </a:rPr>
               <a:t>Item name</a:t>
             </a:r>
@@ -24727,8 +23951,6 @@
                   <a:srgbClr val="64707A"/>
                 </a:solidFill>
                 <a:latin typeface="Urbanist"/>
-                <a:ea typeface="Urbanist"/>
-                <a:cs typeface="Urbanist"/>
               </a:rPr>
               <a:t>What it covers, four or five words</a:t>
             </a:r>
@@ -24766,8 +23988,6 @@
                   </a:srgbClr>
                 </a:solidFill>
                 <a:latin typeface="Poppins"/>
-                <a:ea typeface="Poppins"/>
-                <a:cs typeface="Poppins"/>
               </a:rPr>
               <a:t>04</a:t>
             </a:r>
@@ -24919,8 +24139,6 @@
                   <a:srgbClr val="64707A"/>
                 </a:solidFill>
                 <a:latin typeface="Urbanist SemiBold"/>
-                <a:ea typeface="Urbanist SemiBold"/>
-                <a:cs typeface="Urbanist SemiBold"/>
               </a:rPr>
               <a:t>Item name</a:t>
             </a:r>
@@ -24956,8 +24174,6 @@
                   <a:srgbClr val="64707A"/>
                 </a:solidFill>
                 <a:latin typeface="Urbanist"/>
-                <a:ea typeface="Urbanist"/>
-                <a:cs typeface="Urbanist"/>
               </a:rPr>
               <a:t>What it covers, four or five words</a:t>
             </a:r>
@@ -24995,8 +24211,6 @@
                   </a:srgbClr>
                 </a:solidFill>
                 <a:latin typeface="Poppins"/>
-                <a:ea typeface="Poppins"/>
-                <a:cs typeface="Poppins"/>
               </a:rPr>
               <a:t>05</a:t>
             </a:r>
@@ -25148,8 +24362,6 @@
                   <a:srgbClr val="64707A"/>
                 </a:solidFill>
                 <a:latin typeface="Urbanist SemiBold"/>
-                <a:ea typeface="Urbanist SemiBold"/>
-                <a:cs typeface="Urbanist SemiBold"/>
               </a:rPr>
               <a:t>Item name</a:t>
             </a:r>
@@ -25185,8 +24397,6 @@
                   <a:srgbClr val="64707A"/>
                 </a:solidFill>
                 <a:latin typeface="Urbanist"/>
-                <a:ea typeface="Urbanist"/>
-                <a:cs typeface="Urbanist"/>
               </a:rPr>
               <a:t>What it covers, four or five words</a:t>
             </a:r>
@@ -25224,8 +24434,6 @@
                   </a:srgbClr>
                 </a:solidFill>
                 <a:latin typeface="Poppins"/>
-                <a:ea typeface="Poppins"/>
-                <a:cs typeface="Poppins"/>
               </a:rPr>
               <a:t>06</a:t>
             </a:r>
@@ -25261,8 +24469,6 @@
                   <a:srgbClr val="64707A"/>
                 </a:solidFill>
                 <a:latin typeface="League Spartan Medium"/>
-                <a:ea typeface="League Spartan Medium"/>
-                <a:cs typeface="League Spartan Medium"/>
               </a:rPr>
               <a:t>05</a:t>
             </a:r>
@@ -25298,8 +24504,6 @@
                   <a:srgbClr val="64707A"/>
                 </a:solidFill>
                 <a:latin typeface="League Spartan"/>
-                <a:ea typeface="League Spartan"/>
-                <a:cs typeface="League Spartan"/>
               </a:rPr>
               <a:t>ICON CARDS</a:t>
             </a:r>
@@ -25413,8 +24617,6 @@
                   <a:srgbClr val="FFFFFF"/>
                 </a:solidFill>
                 <a:latin typeface="League Spartan SemiBold"/>
-                <a:ea typeface="League Spartan SemiBold"/>
-                <a:cs typeface="League Spartan SemiBold"/>
               </a:rPr>
               <a:t>06</a:t>
             </a:r>
@@ -25450,8 +24652,6 @@
                   <a:srgbClr val="101A2B"/>
                 </a:solidFill>
                 <a:latin typeface="League Spartan SemiBold"/>
-                <a:ea typeface="League Spartan SemiBold"/>
-                <a:cs typeface="League Spartan SemiBold"/>
               </a:rPr>
               <a:t>SECTION NAME</a:t>
             </a:r>
@@ -25541,8 +24741,6 @@
                   <a:srgbClr val="64707A"/>
                 </a:solidFill>
                 <a:latin typeface="Poppins SemiBold"/>
-                <a:ea typeface="Poppins SemiBold"/>
-                <a:cs typeface="Poppins SemiBold"/>
               </a:rPr>
               <a:t>Page title</a:t>
             </a:r>
@@ -25578,8 +24776,6 @@
                   <a:srgbClr val="64707A"/>
                 </a:solidFill>
                 <a:latin typeface="Urbanist"/>
-                <a:ea typeface="Urbanist"/>
-                <a:cs typeface="Urbanist"/>
               </a:rPr>
               <a:t>One line under it saying what the page is for.</a:t>
             </a:r>
@@ -25645,8 +24841,6 @@
                   <a:srgbClr val="64707A"/>
                 </a:solidFill>
                 <a:latin typeface="League Spartan SemiBold"/>
-                <a:ea typeface="League Spartan SemiBold"/>
-                <a:cs typeface="League Spartan SemiBold"/>
               </a:rPr>
               <a:t>OPTION 01</a:t>
             </a:r>
@@ -25682,8 +24876,6 @@
                   <a:srgbClr val="64707A"/>
                 </a:solidFill>
                 <a:latin typeface="Poppins SemiBold"/>
-                <a:ea typeface="Poppins SemiBold"/>
-                <a:cs typeface="Poppins SemiBold"/>
               </a:rPr>
               <a:t>First option</a:t>
             </a:r>
@@ -25749,8 +24941,6 @@
                   <a:srgbClr val="64707A"/>
                 </a:solidFill>
                 <a:latin typeface="Urbanist"/>
-                <a:ea typeface="Urbanist"/>
-                <a:cs typeface="Urbanist"/>
               </a:rPr>
               <a:t>One sentence saying what it is.</a:t>
             </a:r>
@@ -25816,8 +25006,6 @@
                   <a:srgbClr val="64707A"/>
                 </a:solidFill>
                 <a:latin typeface="Urbanist"/>
-                <a:ea typeface="Urbanist"/>
-                <a:cs typeface="Urbanist"/>
               </a:rPr>
               <a:t>A point of difference</a:t>
             </a:r>
@@ -25883,8 +25071,6 @@
                   <a:srgbClr val="64707A"/>
                 </a:solidFill>
                 <a:latin typeface="Urbanist"/>
-                <a:ea typeface="Urbanist"/>
-                <a:cs typeface="Urbanist"/>
               </a:rPr>
               <a:t>A second point</a:t>
             </a:r>
@@ -25950,8 +25136,6 @@
                   <a:srgbClr val="64707A"/>
                 </a:solidFill>
                 <a:latin typeface="Urbanist"/>
-                <a:ea typeface="Urbanist"/>
-                <a:cs typeface="Urbanist"/>
               </a:rPr>
               <a:t>A third point</a:t>
             </a:r>
@@ -26017,8 +25201,6 @@
                   <a:srgbClr val="64707A"/>
                 </a:solidFill>
                 <a:latin typeface="Urbanist"/>
-                <a:ea typeface="Urbanist"/>
-                <a:cs typeface="Urbanist"/>
               </a:rPr>
               <a:t>When to choose it</a:t>
             </a:r>
@@ -26084,8 +25266,6 @@
                   <a:srgbClr val="64707A"/>
                 </a:solidFill>
                 <a:latin typeface="League Spartan SemiBold"/>
-                <a:ea typeface="League Spartan SemiBold"/>
-                <a:cs typeface="League Spartan SemiBold"/>
               </a:rPr>
               <a:t>OPTION 02</a:t>
             </a:r>
@@ -26121,8 +25301,6 @@
                   <a:srgbClr val="64707A"/>
                 </a:solidFill>
                 <a:latin typeface="Poppins SemiBold"/>
-                <a:ea typeface="Poppins SemiBold"/>
-                <a:cs typeface="Poppins SemiBold"/>
               </a:rPr>
               <a:t>Second option</a:t>
             </a:r>
@@ -26188,8 +25366,6 @@
                   <a:srgbClr val="64707A"/>
                 </a:solidFill>
                 <a:latin typeface="Urbanist"/>
-                <a:ea typeface="Urbanist"/>
-                <a:cs typeface="Urbanist"/>
               </a:rPr>
               <a:t>One sentence saying what it is.</a:t>
             </a:r>
@@ -26255,8 +25431,6 @@
                   <a:srgbClr val="E7EBF0"/>
                 </a:solidFill>
                 <a:latin typeface="Urbanist"/>
-                <a:ea typeface="Urbanist"/>
-                <a:cs typeface="Urbanist"/>
               </a:rPr>
               <a:t>A point of difference</a:t>
             </a:r>
@@ -26322,8 +25496,6 @@
                   <a:srgbClr val="E7EBF0"/>
                 </a:solidFill>
                 <a:latin typeface="Urbanist"/>
-                <a:ea typeface="Urbanist"/>
-                <a:cs typeface="Urbanist"/>
               </a:rPr>
               <a:t>A second point</a:t>
             </a:r>
@@ -26389,8 +25561,6 @@
                   <a:srgbClr val="E7EBF0"/>
                 </a:solidFill>
                 <a:latin typeface="Urbanist"/>
-                <a:ea typeface="Urbanist"/>
-                <a:cs typeface="Urbanist"/>
               </a:rPr>
               <a:t>A third point</a:t>
             </a:r>
@@ -26456,8 +25626,6 @@
                   <a:srgbClr val="E7EBF0"/>
                 </a:solidFill>
                 <a:latin typeface="Urbanist"/>
-                <a:ea typeface="Urbanist"/>
-                <a:cs typeface="Urbanist"/>
               </a:rPr>
               <a:t>When to choose it</a:t>
             </a:r>
@@ -26523,8 +25691,6 @@
                   <a:srgbClr val="64707A"/>
                 </a:solidFill>
                 <a:latin typeface="League Spartan SemiBold"/>
-                <a:ea typeface="League Spartan SemiBold"/>
-                <a:cs typeface="League Spartan SemiBold"/>
               </a:rPr>
               <a:t>OPTION 03</a:t>
             </a:r>
@@ -26560,8 +25726,6 @@
                   <a:srgbClr val="64707A"/>
                 </a:solidFill>
                 <a:latin typeface="Poppins SemiBold"/>
-                <a:ea typeface="Poppins SemiBold"/>
-                <a:cs typeface="Poppins SemiBold"/>
               </a:rPr>
               <a:t>Third option</a:t>
             </a:r>
@@ -26627,8 +25791,6 @@
                   <a:srgbClr val="64707A"/>
                 </a:solidFill>
                 <a:latin typeface="Urbanist"/>
-                <a:ea typeface="Urbanist"/>
-                <a:cs typeface="Urbanist"/>
               </a:rPr>
               <a:t>One sentence saying what it is.</a:t>
             </a:r>
@@ -26694,8 +25856,6 @@
                   <a:srgbClr val="64707A"/>
                 </a:solidFill>
                 <a:latin typeface="Urbanist"/>
-                <a:ea typeface="Urbanist"/>
-                <a:cs typeface="Urbanist"/>
               </a:rPr>
               <a:t>A point of difference</a:t>
             </a:r>
@@ -26761,8 +25921,6 @@
                   <a:srgbClr val="64707A"/>
                 </a:solidFill>
                 <a:latin typeface="Urbanist"/>
-                <a:ea typeface="Urbanist"/>
-                <a:cs typeface="Urbanist"/>
               </a:rPr>
               <a:t>A second point</a:t>
             </a:r>
@@ -26828,8 +25986,6 @@
                   <a:srgbClr val="64707A"/>
                 </a:solidFill>
                 <a:latin typeface="Urbanist"/>
-                <a:ea typeface="Urbanist"/>
-                <a:cs typeface="Urbanist"/>
               </a:rPr>
               <a:t>A third point</a:t>
             </a:r>
@@ -26895,8 +26051,6 @@
                   <a:srgbClr val="64707A"/>
                 </a:solidFill>
                 <a:latin typeface="Urbanist"/>
-                <a:ea typeface="Urbanist"/>
-                <a:cs typeface="Urbanist"/>
               </a:rPr>
               <a:t>When to choose it</a:t>
             </a:r>
@@ -26932,8 +26086,6 @@
                   <a:srgbClr val="64707A"/>
                 </a:solidFill>
                 <a:latin typeface="League Spartan Medium"/>
-                <a:ea typeface="League Spartan Medium"/>
-                <a:cs typeface="League Spartan Medium"/>
               </a:rPr>
               <a:t>06</a:t>
             </a:r>
@@ -26969,8 +26121,6 @@
                   <a:srgbClr val="64707A"/>
                 </a:solidFill>
                 <a:latin typeface="League Spartan"/>
-                <a:ea typeface="League Spartan"/>
-                <a:cs typeface="League Spartan"/>
               </a:rPr>
               <a:t>COMPARISON</a:t>
             </a:r>
@@ -27084,8 +26234,6 @@
                   <a:srgbClr val="FFFFFF"/>
                 </a:solidFill>
                 <a:latin typeface="League Spartan SemiBold"/>
-                <a:ea typeface="League Spartan SemiBold"/>
-                <a:cs typeface="League Spartan SemiBold"/>
               </a:rPr>
               <a:t>07</a:t>
             </a:r>
@@ -27121,8 +26269,6 @@
                   <a:srgbClr val="101A2B"/>
                 </a:solidFill>
                 <a:latin typeface="League Spartan SemiBold"/>
-                <a:ea typeface="League Spartan SemiBold"/>
-                <a:cs typeface="League Spartan SemiBold"/>
               </a:rPr>
               <a:t>SECTION NAME</a:t>
             </a:r>
@@ -27212,8 +26358,6 @@
                   <a:srgbClr val="64707A"/>
                 </a:solidFill>
                 <a:latin typeface="Poppins SemiBold"/>
-                <a:ea typeface="Poppins SemiBold"/>
-                <a:cs typeface="Poppins SemiBold"/>
               </a:rPr>
               <a:t>Page title</a:t>
             </a:r>
@@ -27249,8 +26393,6 @@
                   <a:srgbClr val="64707A"/>
                 </a:solidFill>
                 <a:latin typeface="Urbanist"/>
-                <a:ea typeface="Urbanist"/>
-                <a:cs typeface="Urbanist"/>
               </a:rPr>
               <a:t>One line under it saying what the page is for.</a:t>
             </a:r>
@@ -27316,8 +26458,6 @@
                   <a:srgbClr val="64707A"/>
                 </a:solidFill>
                 <a:latin typeface="League Spartan SemiBold"/>
-                <a:ea typeface="League Spartan SemiBold"/>
-                <a:cs typeface="League Spartan SemiBold"/>
               </a:rPr>
               <a:t>ROLE</a:t>
             </a:r>
@@ -27353,8 +26493,6 @@
                   <a:srgbClr val="64707A"/>
                 </a:solidFill>
                 <a:latin typeface="Poppins SemiBold"/>
-                <a:ea typeface="Poppins SemiBold"/>
-                <a:cs typeface="Poppins SemiBold"/>
               </a:rPr>
               <a:t>Name or function</a:t>
             </a:r>
@@ -27390,8 +26528,6 @@
                   <a:srgbClr val="64707A"/>
                 </a:solidFill>
                 <a:latin typeface="Urbanist"/>
-                <a:ea typeface="Urbanist"/>
-                <a:cs typeface="Urbanist"/>
               </a:rPr>
               <a:t>What they are accountable for</a:t>
             </a:r>
@@ -27637,8 +26773,6 @@
                   <a:srgbClr val="64707A"/>
                 </a:solidFill>
                 <a:latin typeface="League Spartan SemiBold"/>
-                <a:ea typeface="League Spartan SemiBold"/>
-                <a:cs typeface="League Spartan SemiBold"/>
               </a:rPr>
               <a:t>ROLE</a:t>
             </a:r>
@@ -27674,8 +26808,6 @@
                   <a:srgbClr val="64707A"/>
                 </a:solidFill>
                 <a:latin typeface="Poppins SemiBold"/>
-                <a:ea typeface="Poppins SemiBold"/>
-                <a:cs typeface="Poppins SemiBold"/>
               </a:rPr>
               <a:t>Name or function</a:t>
             </a:r>
@@ -27711,8 +26843,6 @@
                   <a:srgbClr val="64707A"/>
                 </a:solidFill>
                 <a:latin typeface="Urbanist"/>
-                <a:ea typeface="Urbanist"/>
-                <a:cs typeface="Urbanist"/>
               </a:rPr>
               <a:t>One line</a:t>
             </a:r>
@@ -27778,8 +26908,6 @@
                   <a:srgbClr val="64707A"/>
                 </a:solidFill>
                 <a:latin typeface="League Spartan SemiBold"/>
-                <a:ea typeface="League Spartan SemiBold"/>
-                <a:cs typeface="League Spartan SemiBold"/>
               </a:rPr>
               <a:t>ROLE</a:t>
             </a:r>
@@ -27815,8 +26943,6 @@
                   <a:srgbClr val="64707A"/>
                 </a:solidFill>
                 <a:latin typeface="Poppins SemiBold"/>
-                <a:ea typeface="Poppins SemiBold"/>
-                <a:cs typeface="Poppins SemiBold"/>
               </a:rPr>
               <a:t>Name or function</a:t>
             </a:r>
@@ -27852,8 +26978,6 @@
                   <a:srgbClr val="64707A"/>
                 </a:solidFill>
                 <a:latin typeface="Urbanist"/>
-                <a:ea typeface="Urbanist"/>
-                <a:cs typeface="Urbanist"/>
               </a:rPr>
               <a:t>One line</a:t>
             </a:r>
@@ -27919,8 +27043,6 @@
                   <a:srgbClr val="64707A"/>
                 </a:solidFill>
                 <a:latin typeface="League Spartan SemiBold"/>
-                <a:ea typeface="League Spartan SemiBold"/>
-                <a:cs typeface="League Spartan SemiBold"/>
               </a:rPr>
               <a:t>ROLE</a:t>
             </a:r>
@@ -27956,8 +27078,6 @@
                   <a:srgbClr val="64707A"/>
                 </a:solidFill>
                 <a:latin typeface="Poppins SemiBold"/>
-                <a:ea typeface="Poppins SemiBold"/>
-                <a:cs typeface="Poppins SemiBold"/>
               </a:rPr>
               <a:t>Name or function</a:t>
             </a:r>
@@ -27993,8 +27113,6 @@
                   <a:srgbClr val="64707A"/>
                 </a:solidFill>
                 <a:latin typeface="Urbanist"/>
-                <a:ea typeface="Urbanist"/>
-                <a:cs typeface="Urbanist"/>
               </a:rPr>
               <a:t>One line</a:t>
             </a:r>
@@ -28060,8 +27178,6 @@
                   <a:srgbClr val="64707A"/>
                 </a:solidFill>
                 <a:latin typeface="League Spartan SemiBold"/>
-                <a:ea typeface="League Spartan SemiBold"/>
-                <a:cs typeface="League Spartan SemiBold"/>
               </a:rPr>
               <a:t>ROLE</a:t>
             </a:r>
@@ -28097,8 +27213,6 @@
                   <a:srgbClr val="64707A"/>
                 </a:solidFill>
                 <a:latin typeface="Poppins SemiBold"/>
-                <a:ea typeface="Poppins SemiBold"/>
-                <a:cs typeface="Poppins SemiBold"/>
               </a:rPr>
               <a:t>Name or function</a:t>
             </a:r>
@@ -28134,8 +27248,6 @@
                   <a:srgbClr val="64707A"/>
                 </a:solidFill>
                 <a:latin typeface="Urbanist"/>
-                <a:ea typeface="Urbanist"/>
-                <a:cs typeface="Urbanist"/>
               </a:rPr>
               <a:t>One line</a:t>
             </a:r>
@@ -28171,8 +27283,6 @@
                   <a:srgbClr val="64707A"/>
                 </a:solidFill>
                 <a:latin typeface="League Spartan Medium"/>
-                <a:ea typeface="League Spartan Medium"/>
-                <a:cs typeface="League Spartan Medium"/>
               </a:rPr>
               <a:t>07</a:t>
             </a:r>
@@ -28208,8 +27318,6 @@
                   <a:srgbClr val="64707A"/>
                 </a:solidFill>
                 <a:latin typeface="League Spartan"/>
-                <a:ea typeface="League Spartan"/>
-                <a:cs typeface="League Spartan"/>
               </a:rPr>
               <a:t>ORG CHART · REPORTING TREE</a:t>
             </a:r>
@@ -28323,8 +27431,6 @@
                   <a:srgbClr val="FFFFFF"/>
                 </a:solidFill>
                 <a:latin typeface="League Spartan SemiBold"/>
-                <a:ea typeface="League Spartan SemiBold"/>
-                <a:cs typeface="League Spartan SemiBold"/>
               </a:rPr>
               <a:t>08</a:t>
             </a:r>
@@ -28360,8 +27466,6 @@
                   <a:srgbClr val="101A2B"/>
                 </a:solidFill>
                 <a:latin typeface="League Spartan SemiBold"/>
-                <a:ea typeface="League Spartan SemiBold"/>
-                <a:cs typeface="League Spartan SemiBold"/>
               </a:rPr>
               <a:t>SECTION NAME</a:t>
             </a:r>
@@ -28451,8 +27555,6 @@
                   <a:srgbClr val="64707A"/>
                 </a:solidFill>
                 <a:latin typeface="Poppins SemiBold"/>
-                <a:ea typeface="Poppins SemiBold"/>
-                <a:cs typeface="Poppins SemiBold"/>
               </a:rPr>
               <a:t>Page title</a:t>
             </a:r>
@@ -28488,8 +27590,6 @@
                   <a:srgbClr val="64707A"/>
                 </a:solidFill>
                 <a:latin typeface="Urbanist"/>
-                <a:ea typeface="Urbanist"/>
-                <a:cs typeface="Urbanist"/>
               </a:rPr>
               <a:t>One line under it saying what the page is for.</a:t>
             </a:r>
@@ -28611,8 +27711,6 @@
                   <a:srgbClr val="64707A"/>
                 </a:solidFill>
                 <a:latin typeface="League Spartan SemiBold"/>
-                <a:ea typeface="League Spartan SemiBold"/>
-                <a:cs typeface="League Spartan SemiBold"/>
               </a:rPr>
               <a:t>ROLE</a:t>
             </a:r>
@@ -28648,8 +27746,6 @@
                   <a:srgbClr val="64707A"/>
                 </a:solidFill>
                 <a:latin typeface="Poppins SemiBold"/>
-                <a:ea typeface="Poppins SemiBold"/>
-                <a:cs typeface="Poppins SemiBold"/>
               </a:rPr>
               <a:t>Name</a:t>
             </a:r>
@@ -28685,8 +27781,6 @@
                   <a:srgbClr val="64707A"/>
                 </a:solidFill>
                 <a:latin typeface="Urbanist"/>
-                <a:ea typeface="Urbanist"/>
-                <a:cs typeface="Urbanist"/>
               </a:rPr>
               <a:t>What they own</a:t>
             </a:r>
@@ -28808,8 +27902,6 @@
                   <a:srgbClr val="64707A"/>
                 </a:solidFill>
                 <a:latin typeface="League Spartan SemiBold"/>
-                <a:ea typeface="League Spartan SemiBold"/>
-                <a:cs typeface="League Spartan SemiBold"/>
               </a:rPr>
               <a:t>ROLE</a:t>
             </a:r>
@@ -28845,8 +27937,6 @@
                   <a:srgbClr val="64707A"/>
                 </a:solidFill>
                 <a:latin typeface="Poppins SemiBold"/>
-                <a:ea typeface="Poppins SemiBold"/>
-                <a:cs typeface="Poppins SemiBold"/>
               </a:rPr>
               <a:t>Name</a:t>
             </a:r>
@@ -28882,8 +27972,6 @@
                   <a:srgbClr val="64707A"/>
                 </a:solidFill>
                 <a:latin typeface="Urbanist"/>
-                <a:ea typeface="Urbanist"/>
-                <a:cs typeface="Urbanist"/>
               </a:rPr>
               <a:t>What they own</a:t>
             </a:r>
@@ -29005,8 +28093,6 @@
                   <a:srgbClr val="64707A"/>
                 </a:solidFill>
                 <a:latin typeface="League Spartan SemiBold"/>
-                <a:ea typeface="League Spartan SemiBold"/>
-                <a:cs typeface="League Spartan SemiBold"/>
               </a:rPr>
               <a:t>ROLE</a:t>
             </a:r>
@@ -29042,8 +28128,6 @@
                   <a:srgbClr val="64707A"/>
                 </a:solidFill>
                 <a:latin typeface="Poppins SemiBold"/>
-                <a:ea typeface="Poppins SemiBold"/>
-                <a:cs typeface="Poppins SemiBold"/>
               </a:rPr>
               <a:t>Name</a:t>
             </a:r>
@@ -29079,8 +28163,6 @@
                   <a:srgbClr val="64707A"/>
                 </a:solidFill>
                 <a:latin typeface="Urbanist"/>
-                <a:ea typeface="Urbanist"/>
-                <a:cs typeface="Urbanist"/>
               </a:rPr>
               <a:t>What they own</a:t>
             </a:r>
@@ -29202,8 +28284,6 @@
                   <a:srgbClr val="64707A"/>
                 </a:solidFill>
                 <a:latin typeface="League Spartan SemiBold"/>
-                <a:ea typeface="League Spartan SemiBold"/>
-                <a:cs typeface="League Spartan SemiBold"/>
               </a:rPr>
               <a:t>ROLE</a:t>
             </a:r>
@@ -29239,8 +28319,6 @@
                   <a:srgbClr val="64707A"/>
                 </a:solidFill>
                 <a:latin typeface="Poppins SemiBold"/>
-                <a:ea typeface="Poppins SemiBold"/>
-                <a:cs typeface="Poppins SemiBold"/>
               </a:rPr>
               <a:t>Name</a:t>
             </a:r>
@@ -29276,8 +28354,6 @@
                   <a:srgbClr val="64707A"/>
                 </a:solidFill>
                 <a:latin typeface="Urbanist"/>
-                <a:ea typeface="Urbanist"/>
-                <a:cs typeface="Urbanist"/>
               </a:rPr>
               <a:t>What they own</a:t>
             </a:r>
@@ -29399,8 +28475,6 @@
                   <a:srgbClr val="64707A"/>
                 </a:solidFill>
                 <a:latin typeface="League Spartan SemiBold"/>
-                <a:ea typeface="League Spartan SemiBold"/>
-                <a:cs typeface="League Spartan SemiBold"/>
               </a:rPr>
               <a:t>ROLE</a:t>
             </a:r>
@@ -29436,8 +28510,6 @@
                   <a:srgbClr val="64707A"/>
                 </a:solidFill>
                 <a:latin typeface="Poppins SemiBold"/>
-                <a:ea typeface="Poppins SemiBold"/>
-                <a:cs typeface="Poppins SemiBold"/>
               </a:rPr>
               <a:t>Name</a:t>
             </a:r>
@@ -29473,8 +28545,6 @@
                   <a:srgbClr val="64707A"/>
                 </a:solidFill>
                 <a:latin typeface="Urbanist"/>
-                <a:ea typeface="Urbanist"/>
-                <a:cs typeface="Urbanist"/>
               </a:rPr>
               <a:t>What they own</a:t>
             </a:r>
@@ -29510,8 +28580,6 @@
                   <a:srgbClr val="64707A"/>
                 </a:solidFill>
                 <a:latin typeface="League Spartan Medium"/>
-                <a:ea typeface="League Spartan Medium"/>
-                <a:cs typeface="League Spartan Medium"/>
               </a:rPr>
               <a:t>08</a:t>
             </a:r>
@@ -29547,8 +28615,6 @@
                   <a:srgbClr val="64707A"/>
                 </a:solidFill>
                 <a:latin typeface="League Spartan"/>
-                <a:ea typeface="League Spartan"/>
-                <a:cs typeface="League Spartan"/>
               </a:rPr>
               <a:t>ORG CHART · FLAT TEAM BAND</a:t>
             </a:r>

</xml_diff>